<commit_message>
creation workshop and seminary
</commit_message>
<xml_diff>
--- a/Programa Flammam - R&D Propulsion Technical Workshop.pptx
+++ b/Programa Flammam - R&D Propulsion Technical Workshop.pptx
@@ -147,7 +147,7 @@
 </file>
 
 <file path=ppt/charts/chart1.xml><?xml version="1.0" encoding="utf-8"?>
-<c:chartSpace xmlns:c="http://schemas.openxmlformats.org/drawingml/2006/chart" xmlns:a="http://schemas.openxmlformats.org/drawingml/2006/main" xmlns:r="http://schemas.openxmlformats.org/officeDocument/2006/relationships" xmlns:c16r2="http://schemas.microsoft.com/office/drawing/2015/06/chart">
+<c:chartSpace xmlns:c="http://schemas.openxmlformats.org/drawingml/2006/chart" xmlns:a="http://schemas.openxmlformats.org/drawingml/2006/main" xmlns:r="http://schemas.openxmlformats.org/officeDocument/2006/relationships">
   <c:date1904 val="0"/>
   <c:lang val="en-US"/>
   <c:roundedCorners val="0"/>
@@ -5546,7 +5546,7 @@
             </c:numRef>
           </c:yVal>
           <c:smooth val="1"/>
-          <c:extLst>
+          <c:extLst xmlns:c16r2="http://schemas.microsoft.com/office/drawing/2015/06/chart">
             <c:ext xmlns:c16="http://schemas.microsoft.com/office/drawing/2014/chart" uri="{C3380CC4-5D6E-409C-BE32-E72D297353CC}">
               <c16:uniqueId val="{00000000-1F1C-454E-8959-BA764F9DA5B5}"/>
             </c:ext>
@@ -5560,11 +5560,11 @@
           <c:showPercent val="0"/>
           <c:showBubbleSize val="0"/>
         </c:dLbls>
-        <c:axId val="306710864"/>
-        <c:axId val="306711256"/>
+        <c:axId val="325321496"/>
+        <c:axId val="325121120"/>
       </c:scatterChart>
       <c:valAx>
-        <c:axId val="306710864"/>
+        <c:axId val="325321496"/>
         <c:scaling>
           <c:orientation val="minMax"/>
           <c:min val="0"/>
@@ -5649,12 +5649,12 @@
             <a:endParaRPr lang="en-US"/>
           </a:p>
         </c:txPr>
-        <c:crossAx val="306711256"/>
+        <c:crossAx val="325121120"/>
         <c:crosses val="autoZero"/>
         <c:crossBetween val="midCat"/>
       </c:valAx>
       <c:valAx>
-        <c:axId val="306711256"/>
+        <c:axId val="325121120"/>
         <c:scaling>
           <c:orientation val="minMax"/>
           <c:min val="0"/>
@@ -5739,7 +5739,7 @@
             <a:endParaRPr lang="en-US"/>
           </a:p>
         </c:txPr>
-        <c:crossAx val="306710864"/>
+        <c:crossAx val="325321496"/>
         <c:crosses val="autoZero"/>
         <c:crossBetween val="midCat"/>
       </c:valAx>
@@ -6316,7 +6316,7 @@
           <a:p>
             <a:fld id="{B723E7E9-0B4C-4599-8387-854B68DD1F3F}" type="datetimeFigureOut">
               <a:rPr lang="es-MX" smtClean="0"/>
-              <a:t>07/10/2025</a:t>
+              <a:t>08/10/2025</a:t>
             </a:fld>
             <a:endParaRPr lang="es-MX"/>
           </a:p>
@@ -6628,6 +6628,28 @@
           <a:bodyPr/>
           <a:lstStyle/>
           <a:p>
+            <a:r>
+              <a:rPr lang="es-MX" dirty="0" smtClean="0"/>
+              <a:t>Workshop por la tarde -&gt; es mas</a:t>
+            </a:r>
+            <a:r>
+              <a:rPr lang="es-MX" baseline="0" dirty="0" smtClean="0"/>
+              <a:t> como un “taller para entrenamiento” tipo laboratorio y </a:t>
+            </a:r>
+            <a:r>
+              <a:rPr lang="es-MX" baseline="0" dirty="0" err="1" smtClean="0"/>
+              <a:t>tmb</a:t>
+            </a:r>
+            <a:r>
+              <a:rPr lang="es-MX" baseline="0" dirty="0" smtClean="0"/>
+              <a:t> vemos ejercicios </a:t>
+            </a:r>
+          </a:p>
+          <a:p>
+            <a:r>
+              <a:rPr lang="es-MX" baseline="0" dirty="0" smtClean="0"/>
+              <a:t>Seminario por la mañana -&gt; vemos la teoría con un poco más de profundidad de porque suceden los fenómenos pero de manera condensada</a:t>
+            </a:r>
             <a:endParaRPr lang="es-MX" dirty="0"/>
           </a:p>
         </p:txBody>
@@ -6676,7 +6698,7 @@
         <p:cNvPr id="1" name="">
           <a:extLst>
             <a:ext uri="{FF2B5EF4-FFF2-40B4-BE49-F238E27FC236}">
-              <a16:creationId xmlns:a16="http://schemas.microsoft.com/office/drawing/2014/main" id="{B7B2D333-4ABD-BAA5-69F3-C31FB73D45EF}"/>
+              <a16:creationId xmlns:a16="http://schemas.microsoft.com/office/drawing/2014/main" xmlns="" id="{B7B2D333-4ABD-BAA5-69F3-C31FB73D45EF}"/>
             </a:ext>
           </a:extLst>
         </p:cNvPr>
@@ -6696,7 +6718,7 @@
           <p:cNvPr id="2" name="Marcador de imagen de diapositiva 1">
             <a:extLst>
               <a:ext uri="{FF2B5EF4-FFF2-40B4-BE49-F238E27FC236}">
-                <a16:creationId xmlns:a16="http://schemas.microsoft.com/office/drawing/2014/main" id="{C6B6BF19-AEAE-42B5-8FA3-3E9C4D05896C}"/>
+                <a16:creationId xmlns:a16="http://schemas.microsoft.com/office/drawing/2014/main" xmlns="" id="{C6B6BF19-AEAE-42B5-8FA3-3E9C4D05896C}"/>
               </a:ext>
             </a:extLst>
           </p:cNvPr>
@@ -6714,7 +6736,7 @@
           <p:cNvPr id="3" name="Marcador de notas 2">
             <a:extLst>
               <a:ext uri="{FF2B5EF4-FFF2-40B4-BE49-F238E27FC236}">
-                <a16:creationId xmlns:a16="http://schemas.microsoft.com/office/drawing/2014/main" id="{A976F343-B24A-5BCF-88EF-90FB29A7C863}"/>
+                <a16:creationId xmlns:a16="http://schemas.microsoft.com/office/drawing/2014/main" xmlns="" id="{A976F343-B24A-5BCF-88EF-90FB29A7C863}"/>
               </a:ext>
             </a:extLst>
           </p:cNvPr>
@@ -6743,7 +6765,7 @@
           <p:cNvPr id="4" name="Marcador de número de diapositiva 3">
             <a:extLst>
               <a:ext uri="{FF2B5EF4-FFF2-40B4-BE49-F238E27FC236}">
-                <a16:creationId xmlns:a16="http://schemas.microsoft.com/office/drawing/2014/main" id="{9664074F-D602-7BA4-F9BA-23096A9C6A38}"/>
+                <a16:creationId xmlns:a16="http://schemas.microsoft.com/office/drawing/2014/main" xmlns="" id="{9664074F-D602-7BA4-F9BA-23096A9C6A38}"/>
               </a:ext>
             </a:extLst>
           </p:cNvPr>
@@ -6788,7 +6810,7 @@
         <p:cNvPr id="1" name="">
           <a:extLst>
             <a:ext uri="{FF2B5EF4-FFF2-40B4-BE49-F238E27FC236}">
-              <a16:creationId xmlns:a16="http://schemas.microsoft.com/office/drawing/2014/main" id="{6EA57328-AAAD-8754-FFAD-71061F97785C}"/>
+              <a16:creationId xmlns:a16="http://schemas.microsoft.com/office/drawing/2014/main" xmlns="" id="{6EA57328-AAAD-8754-FFAD-71061F97785C}"/>
             </a:ext>
           </a:extLst>
         </p:cNvPr>
@@ -6808,7 +6830,7 @@
           <p:cNvPr id="2" name="Marcador de imagen de diapositiva 1">
             <a:extLst>
               <a:ext uri="{FF2B5EF4-FFF2-40B4-BE49-F238E27FC236}">
-                <a16:creationId xmlns:a16="http://schemas.microsoft.com/office/drawing/2014/main" id="{441F522B-C9D9-9F56-19DD-C4AB74C55273}"/>
+                <a16:creationId xmlns:a16="http://schemas.microsoft.com/office/drawing/2014/main" xmlns="" id="{441F522B-C9D9-9F56-19DD-C4AB74C55273}"/>
               </a:ext>
             </a:extLst>
           </p:cNvPr>
@@ -6826,7 +6848,7 @@
           <p:cNvPr id="3" name="Marcador de notas 2">
             <a:extLst>
               <a:ext uri="{FF2B5EF4-FFF2-40B4-BE49-F238E27FC236}">
-                <a16:creationId xmlns:a16="http://schemas.microsoft.com/office/drawing/2014/main" id="{4373AB38-1F06-0DCC-E3CE-74CA129726D6}"/>
+                <a16:creationId xmlns:a16="http://schemas.microsoft.com/office/drawing/2014/main" xmlns="" id="{4373AB38-1F06-0DCC-E3CE-74CA129726D6}"/>
               </a:ext>
             </a:extLst>
           </p:cNvPr>
@@ -6851,7 +6873,7 @@
           <p:cNvPr id="4" name="Marcador de número de diapositiva 3">
             <a:extLst>
               <a:ext uri="{FF2B5EF4-FFF2-40B4-BE49-F238E27FC236}">
-                <a16:creationId xmlns:a16="http://schemas.microsoft.com/office/drawing/2014/main" id="{7F45A3EC-518F-4874-4E15-BD41DD47172C}"/>
+                <a16:creationId xmlns:a16="http://schemas.microsoft.com/office/drawing/2014/main" xmlns="" id="{7F45A3EC-518F-4874-4E15-BD41DD47172C}"/>
               </a:ext>
             </a:extLst>
           </p:cNvPr>
@@ -6896,7 +6918,7 @@
         <p:cNvPr id="1" name="">
           <a:extLst>
             <a:ext uri="{FF2B5EF4-FFF2-40B4-BE49-F238E27FC236}">
-              <a16:creationId xmlns:a16="http://schemas.microsoft.com/office/drawing/2014/main" id="{316C1E33-CA39-2193-6148-88F450841C46}"/>
+              <a16:creationId xmlns:a16="http://schemas.microsoft.com/office/drawing/2014/main" xmlns="" id="{316C1E33-CA39-2193-6148-88F450841C46}"/>
             </a:ext>
           </a:extLst>
         </p:cNvPr>
@@ -6916,7 +6938,7 @@
           <p:cNvPr id="2" name="Marcador de imagen de diapositiva 1">
             <a:extLst>
               <a:ext uri="{FF2B5EF4-FFF2-40B4-BE49-F238E27FC236}">
-                <a16:creationId xmlns:a16="http://schemas.microsoft.com/office/drawing/2014/main" id="{6DE77322-52A1-7EBC-B43B-414E28D4A552}"/>
+                <a16:creationId xmlns:a16="http://schemas.microsoft.com/office/drawing/2014/main" xmlns="" id="{6DE77322-52A1-7EBC-B43B-414E28D4A552}"/>
               </a:ext>
             </a:extLst>
           </p:cNvPr>
@@ -6934,7 +6956,7 @@
           <p:cNvPr id="3" name="Marcador de notas 2">
             <a:extLst>
               <a:ext uri="{FF2B5EF4-FFF2-40B4-BE49-F238E27FC236}">
-                <a16:creationId xmlns:a16="http://schemas.microsoft.com/office/drawing/2014/main" id="{424EEB5D-06D9-D802-B502-A1398B1502CB}"/>
+                <a16:creationId xmlns:a16="http://schemas.microsoft.com/office/drawing/2014/main" xmlns="" id="{424EEB5D-06D9-D802-B502-A1398B1502CB}"/>
               </a:ext>
             </a:extLst>
           </p:cNvPr>
@@ -6959,7 +6981,7 @@
           <p:cNvPr id="4" name="Marcador de número de diapositiva 3">
             <a:extLst>
               <a:ext uri="{FF2B5EF4-FFF2-40B4-BE49-F238E27FC236}">
-                <a16:creationId xmlns:a16="http://schemas.microsoft.com/office/drawing/2014/main" id="{9613C39C-8B5F-3765-1484-F2205D391090}"/>
+                <a16:creationId xmlns:a16="http://schemas.microsoft.com/office/drawing/2014/main" xmlns="" id="{9613C39C-8B5F-3765-1484-F2205D391090}"/>
               </a:ext>
             </a:extLst>
           </p:cNvPr>
@@ -7004,7 +7026,7 @@
         <p:cNvPr id="1" name="">
           <a:extLst>
             <a:ext uri="{FF2B5EF4-FFF2-40B4-BE49-F238E27FC236}">
-              <a16:creationId xmlns:a16="http://schemas.microsoft.com/office/drawing/2014/main" id="{AFFD9064-8FEF-37A0-7B1B-B93C0AA936DC}"/>
+              <a16:creationId xmlns:a16="http://schemas.microsoft.com/office/drawing/2014/main" xmlns="" id="{AFFD9064-8FEF-37A0-7B1B-B93C0AA936DC}"/>
             </a:ext>
           </a:extLst>
         </p:cNvPr>
@@ -7024,7 +7046,7 @@
           <p:cNvPr id="2" name="Marcador de imagen de diapositiva 1">
             <a:extLst>
               <a:ext uri="{FF2B5EF4-FFF2-40B4-BE49-F238E27FC236}">
-                <a16:creationId xmlns:a16="http://schemas.microsoft.com/office/drawing/2014/main" id="{1058E621-AF6A-A981-68E8-C1577F3CDD5F}"/>
+                <a16:creationId xmlns:a16="http://schemas.microsoft.com/office/drawing/2014/main" xmlns="" id="{1058E621-AF6A-A981-68E8-C1577F3CDD5F}"/>
               </a:ext>
             </a:extLst>
           </p:cNvPr>
@@ -7042,7 +7064,7 @@
           <p:cNvPr id="3" name="Marcador de notas 2">
             <a:extLst>
               <a:ext uri="{FF2B5EF4-FFF2-40B4-BE49-F238E27FC236}">
-                <a16:creationId xmlns:a16="http://schemas.microsoft.com/office/drawing/2014/main" id="{6046705E-859B-6ABE-8504-161E604A9A55}"/>
+                <a16:creationId xmlns:a16="http://schemas.microsoft.com/office/drawing/2014/main" xmlns="" id="{6046705E-859B-6ABE-8504-161E604A9A55}"/>
               </a:ext>
             </a:extLst>
           </p:cNvPr>
@@ -7067,7 +7089,7 @@
           <p:cNvPr id="4" name="Marcador de número de diapositiva 3">
             <a:extLst>
               <a:ext uri="{FF2B5EF4-FFF2-40B4-BE49-F238E27FC236}">
-                <a16:creationId xmlns:a16="http://schemas.microsoft.com/office/drawing/2014/main" id="{F406BC02-B764-5E67-CBC6-E22C444008BB}"/>
+                <a16:creationId xmlns:a16="http://schemas.microsoft.com/office/drawing/2014/main" xmlns="" id="{F406BC02-B764-5E67-CBC6-E22C444008BB}"/>
               </a:ext>
             </a:extLst>
           </p:cNvPr>
@@ -7112,7 +7134,7 @@
         <p:cNvPr id="1" name="">
           <a:extLst>
             <a:ext uri="{FF2B5EF4-FFF2-40B4-BE49-F238E27FC236}">
-              <a16:creationId xmlns:a16="http://schemas.microsoft.com/office/drawing/2014/main" id="{1FD6FE79-52DE-87B6-07BB-DB2FD527FDBD}"/>
+              <a16:creationId xmlns:a16="http://schemas.microsoft.com/office/drawing/2014/main" xmlns="" id="{1FD6FE79-52DE-87B6-07BB-DB2FD527FDBD}"/>
             </a:ext>
           </a:extLst>
         </p:cNvPr>
@@ -7132,7 +7154,7 @@
           <p:cNvPr id="2" name="Marcador de imagen de diapositiva 1">
             <a:extLst>
               <a:ext uri="{FF2B5EF4-FFF2-40B4-BE49-F238E27FC236}">
-                <a16:creationId xmlns:a16="http://schemas.microsoft.com/office/drawing/2014/main" id="{8150B7FE-5DC3-724C-B676-7F1DBCF623FB}"/>
+                <a16:creationId xmlns:a16="http://schemas.microsoft.com/office/drawing/2014/main" xmlns="" id="{8150B7FE-5DC3-724C-B676-7F1DBCF623FB}"/>
               </a:ext>
             </a:extLst>
           </p:cNvPr>
@@ -7150,7 +7172,7 @@
           <p:cNvPr id="3" name="Marcador de notas 2">
             <a:extLst>
               <a:ext uri="{FF2B5EF4-FFF2-40B4-BE49-F238E27FC236}">
-                <a16:creationId xmlns:a16="http://schemas.microsoft.com/office/drawing/2014/main" id="{8A2CE2C8-03A6-9BB7-6071-FE58737B2151}"/>
+                <a16:creationId xmlns:a16="http://schemas.microsoft.com/office/drawing/2014/main" xmlns="" id="{8A2CE2C8-03A6-9BB7-6071-FE58737B2151}"/>
               </a:ext>
             </a:extLst>
           </p:cNvPr>
@@ -7175,7 +7197,7 @@
           <p:cNvPr id="4" name="Marcador de número de diapositiva 3">
             <a:extLst>
               <a:ext uri="{FF2B5EF4-FFF2-40B4-BE49-F238E27FC236}">
-                <a16:creationId xmlns:a16="http://schemas.microsoft.com/office/drawing/2014/main" id="{652DCEEE-E07C-E210-6E45-2CC589218B89}"/>
+                <a16:creationId xmlns:a16="http://schemas.microsoft.com/office/drawing/2014/main" xmlns="" id="{652DCEEE-E07C-E210-6E45-2CC589218B89}"/>
               </a:ext>
             </a:extLst>
           </p:cNvPr>
@@ -7220,7 +7242,7 @@
         <p:cNvPr id="1" name="">
           <a:extLst>
             <a:ext uri="{FF2B5EF4-FFF2-40B4-BE49-F238E27FC236}">
-              <a16:creationId xmlns:a16="http://schemas.microsoft.com/office/drawing/2014/main" id="{C58933E4-F443-0EF4-A9FE-67833B001336}"/>
+              <a16:creationId xmlns:a16="http://schemas.microsoft.com/office/drawing/2014/main" xmlns="" id="{C58933E4-F443-0EF4-A9FE-67833B001336}"/>
             </a:ext>
           </a:extLst>
         </p:cNvPr>
@@ -7240,7 +7262,7 @@
           <p:cNvPr id="2" name="Marcador de imagen de diapositiva 1">
             <a:extLst>
               <a:ext uri="{FF2B5EF4-FFF2-40B4-BE49-F238E27FC236}">
-                <a16:creationId xmlns:a16="http://schemas.microsoft.com/office/drawing/2014/main" id="{4F70297F-F309-E806-CCA8-D3FCC32ADB6F}"/>
+                <a16:creationId xmlns:a16="http://schemas.microsoft.com/office/drawing/2014/main" xmlns="" id="{4F70297F-F309-E806-CCA8-D3FCC32ADB6F}"/>
               </a:ext>
             </a:extLst>
           </p:cNvPr>
@@ -7258,7 +7280,7 @@
           <p:cNvPr id="3" name="Marcador de notas 2">
             <a:extLst>
               <a:ext uri="{FF2B5EF4-FFF2-40B4-BE49-F238E27FC236}">
-                <a16:creationId xmlns:a16="http://schemas.microsoft.com/office/drawing/2014/main" id="{34ED910F-AB8C-7BE7-43CE-E863C3E2E28F}"/>
+                <a16:creationId xmlns:a16="http://schemas.microsoft.com/office/drawing/2014/main" xmlns="" id="{34ED910F-AB8C-7BE7-43CE-E863C3E2E28F}"/>
               </a:ext>
             </a:extLst>
           </p:cNvPr>
@@ -7283,7 +7305,7 @@
           <p:cNvPr id="4" name="Marcador de número de diapositiva 3">
             <a:extLst>
               <a:ext uri="{FF2B5EF4-FFF2-40B4-BE49-F238E27FC236}">
-                <a16:creationId xmlns:a16="http://schemas.microsoft.com/office/drawing/2014/main" id="{17A06162-F436-5B7E-9088-189F02566719}"/>
+                <a16:creationId xmlns:a16="http://schemas.microsoft.com/office/drawing/2014/main" xmlns="" id="{17A06162-F436-5B7E-9088-189F02566719}"/>
               </a:ext>
             </a:extLst>
           </p:cNvPr>
@@ -7328,7 +7350,7 @@
         <p:cNvPr id="1" name="">
           <a:extLst>
             <a:ext uri="{FF2B5EF4-FFF2-40B4-BE49-F238E27FC236}">
-              <a16:creationId xmlns:a16="http://schemas.microsoft.com/office/drawing/2014/main" id="{26E6BAEC-44C1-5A2E-AD4B-D2838E392C14}"/>
+              <a16:creationId xmlns:a16="http://schemas.microsoft.com/office/drawing/2014/main" xmlns="" id="{26E6BAEC-44C1-5A2E-AD4B-D2838E392C14}"/>
             </a:ext>
           </a:extLst>
         </p:cNvPr>
@@ -7348,7 +7370,7 @@
           <p:cNvPr id="2" name="Marcador de imagen de diapositiva 1">
             <a:extLst>
               <a:ext uri="{FF2B5EF4-FFF2-40B4-BE49-F238E27FC236}">
-                <a16:creationId xmlns:a16="http://schemas.microsoft.com/office/drawing/2014/main" id="{93932EF0-2E00-FC28-3F70-9ECE2F948031}"/>
+                <a16:creationId xmlns:a16="http://schemas.microsoft.com/office/drawing/2014/main" xmlns="" id="{93932EF0-2E00-FC28-3F70-9ECE2F948031}"/>
               </a:ext>
             </a:extLst>
           </p:cNvPr>
@@ -7366,7 +7388,7 @@
           <p:cNvPr id="3" name="Marcador de notas 2">
             <a:extLst>
               <a:ext uri="{FF2B5EF4-FFF2-40B4-BE49-F238E27FC236}">
-                <a16:creationId xmlns:a16="http://schemas.microsoft.com/office/drawing/2014/main" id="{855BBE16-9477-63DA-1B95-46C8F1252043}"/>
+                <a16:creationId xmlns:a16="http://schemas.microsoft.com/office/drawing/2014/main" xmlns="" id="{855BBE16-9477-63DA-1B95-46C8F1252043}"/>
               </a:ext>
             </a:extLst>
           </p:cNvPr>
@@ -7441,7 +7463,7 @@
           <p:cNvPr id="4" name="Marcador de número de diapositiva 3">
             <a:extLst>
               <a:ext uri="{FF2B5EF4-FFF2-40B4-BE49-F238E27FC236}">
-                <a16:creationId xmlns:a16="http://schemas.microsoft.com/office/drawing/2014/main" id="{623A789C-4886-A0E5-19F8-9831EADBA6A6}"/>
+                <a16:creationId xmlns:a16="http://schemas.microsoft.com/office/drawing/2014/main" xmlns="" id="{623A789C-4886-A0E5-19F8-9831EADBA6A6}"/>
               </a:ext>
             </a:extLst>
           </p:cNvPr>
@@ -7486,7 +7508,7 @@
         <p:cNvPr id="1" name="">
           <a:extLst>
             <a:ext uri="{FF2B5EF4-FFF2-40B4-BE49-F238E27FC236}">
-              <a16:creationId xmlns:a16="http://schemas.microsoft.com/office/drawing/2014/main" id="{8B35ABB3-DC78-B13C-12E6-F99E0F3D5315}"/>
+              <a16:creationId xmlns:a16="http://schemas.microsoft.com/office/drawing/2014/main" xmlns="" id="{8B35ABB3-DC78-B13C-12E6-F99E0F3D5315}"/>
             </a:ext>
           </a:extLst>
         </p:cNvPr>
@@ -7506,7 +7528,7 @@
           <p:cNvPr id="2" name="Marcador de imagen de diapositiva 1">
             <a:extLst>
               <a:ext uri="{FF2B5EF4-FFF2-40B4-BE49-F238E27FC236}">
-                <a16:creationId xmlns:a16="http://schemas.microsoft.com/office/drawing/2014/main" id="{D6E884D2-1416-6222-1F04-CE2309F473FC}"/>
+                <a16:creationId xmlns:a16="http://schemas.microsoft.com/office/drawing/2014/main" xmlns="" id="{D6E884D2-1416-6222-1F04-CE2309F473FC}"/>
               </a:ext>
             </a:extLst>
           </p:cNvPr>
@@ -7524,7 +7546,7 @@
           <p:cNvPr id="3" name="Marcador de notas 2">
             <a:extLst>
               <a:ext uri="{FF2B5EF4-FFF2-40B4-BE49-F238E27FC236}">
-                <a16:creationId xmlns:a16="http://schemas.microsoft.com/office/drawing/2014/main" id="{A22EF291-97F7-5901-B05D-C04E44B98C97}"/>
+                <a16:creationId xmlns:a16="http://schemas.microsoft.com/office/drawing/2014/main" xmlns="" id="{A22EF291-97F7-5901-B05D-C04E44B98C97}"/>
               </a:ext>
             </a:extLst>
           </p:cNvPr>
@@ -7549,7 +7571,7 @@
           <p:cNvPr id="4" name="Marcador de número de diapositiva 3">
             <a:extLst>
               <a:ext uri="{FF2B5EF4-FFF2-40B4-BE49-F238E27FC236}">
-                <a16:creationId xmlns:a16="http://schemas.microsoft.com/office/drawing/2014/main" id="{BE456964-3528-D9A1-7629-89B88C0007C0}"/>
+                <a16:creationId xmlns:a16="http://schemas.microsoft.com/office/drawing/2014/main" xmlns="" id="{BE456964-3528-D9A1-7629-89B88C0007C0}"/>
               </a:ext>
             </a:extLst>
           </p:cNvPr>
@@ -7594,7 +7616,7 @@
         <p:cNvPr id="1" name="">
           <a:extLst>
             <a:ext uri="{FF2B5EF4-FFF2-40B4-BE49-F238E27FC236}">
-              <a16:creationId xmlns:a16="http://schemas.microsoft.com/office/drawing/2014/main" id="{97878398-47F3-6B76-039A-0312B0EC30DD}"/>
+              <a16:creationId xmlns:a16="http://schemas.microsoft.com/office/drawing/2014/main" xmlns="" id="{97878398-47F3-6B76-039A-0312B0EC30DD}"/>
             </a:ext>
           </a:extLst>
         </p:cNvPr>
@@ -7614,7 +7636,7 @@
           <p:cNvPr id="2" name="Marcador de imagen de diapositiva 1">
             <a:extLst>
               <a:ext uri="{FF2B5EF4-FFF2-40B4-BE49-F238E27FC236}">
-                <a16:creationId xmlns:a16="http://schemas.microsoft.com/office/drawing/2014/main" id="{23D01E90-C6DA-75BC-82DD-4EB4DF85B0B2}"/>
+                <a16:creationId xmlns:a16="http://schemas.microsoft.com/office/drawing/2014/main" xmlns="" id="{23D01E90-C6DA-75BC-82DD-4EB4DF85B0B2}"/>
               </a:ext>
             </a:extLst>
           </p:cNvPr>
@@ -7632,7 +7654,7 @@
           <p:cNvPr id="3" name="Marcador de notas 2">
             <a:extLst>
               <a:ext uri="{FF2B5EF4-FFF2-40B4-BE49-F238E27FC236}">
-                <a16:creationId xmlns:a16="http://schemas.microsoft.com/office/drawing/2014/main" id="{173F8859-4A73-C438-8F98-421331145002}"/>
+                <a16:creationId xmlns:a16="http://schemas.microsoft.com/office/drawing/2014/main" xmlns="" id="{173F8859-4A73-C438-8F98-421331145002}"/>
               </a:ext>
             </a:extLst>
           </p:cNvPr>
@@ -7657,7 +7679,7 @@
           <p:cNvPr id="4" name="Marcador de número de diapositiva 3">
             <a:extLst>
               <a:ext uri="{FF2B5EF4-FFF2-40B4-BE49-F238E27FC236}">
-                <a16:creationId xmlns:a16="http://schemas.microsoft.com/office/drawing/2014/main" id="{F704A619-3851-BE3A-0E11-A37FFBF75140}"/>
+                <a16:creationId xmlns:a16="http://schemas.microsoft.com/office/drawing/2014/main" xmlns="" id="{F704A619-3851-BE3A-0E11-A37FFBF75140}"/>
               </a:ext>
             </a:extLst>
           </p:cNvPr>
@@ -7702,7 +7724,7 @@
         <p:cNvPr id="1" name="">
           <a:extLst>
             <a:ext uri="{FF2B5EF4-FFF2-40B4-BE49-F238E27FC236}">
-              <a16:creationId xmlns:a16="http://schemas.microsoft.com/office/drawing/2014/main" id="{534B254C-8681-7DD0-2206-1EF9DEAF8090}"/>
+              <a16:creationId xmlns:a16="http://schemas.microsoft.com/office/drawing/2014/main" xmlns="" id="{534B254C-8681-7DD0-2206-1EF9DEAF8090}"/>
             </a:ext>
           </a:extLst>
         </p:cNvPr>
@@ -7722,7 +7744,7 @@
           <p:cNvPr id="2" name="Marcador de imagen de diapositiva 1">
             <a:extLst>
               <a:ext uri="{FF2B5EF4-FFF2-40B4-BE49-F238E27FC236}">
-                <a16:creationId xmlns:a16="http://schemas.microsoft.com/office/drawing/2014/main" id="{495EB01F-D632-0C6D-FC67-82BF617502B5}"/>
+                <a16:creationId xmlns:a16="http://schemas.microsoft.com/office/drawing/2014/main" xmlns="" id="{495EB01F-D632-0C6D-FC67-82BF617502B5}"/>
               </a:ext>
             </a:extLst>
           </p:cNvPr>
@@ -7740,7 +7762,7 @@
           <p:cNvPr id="3" name="Marcador de notas 2">
             <a:extLst>
               <a:ext uri="{FF2B5EF4-FFF2-40B4-BE49-F238E27FC236}">
-                <a16:creationId xmlns:a16="http://schemas.microsoft.com/office/drawing/2014/main" id="{8B34515B-4749-C688-6BA3-185E3ADBBE82}"/>
+                <a16:creationId xmlns:a16="http://schemas.microsoft.com/office/drawing/2014/main" xmlns="" id="{8B34515B-4749-C688-6BA3-185E3ADBBE82}"/>
               </a:ext>
             </a:extLst>
           </p:cNvPr>
@@ -7774,7 +7796,7 @@
           <p:cNvPr id="4" name="Marcador de número de diapositiva 3">
             <a:extLst>
               <a:ext uri="{FF2B5EF4-FFF2-40B4-BE49-F238E27FC236}">
-                <a16:creationId xmlns:a16="http://schemas.microsoft.com/office/drawing/2014/main" id="{1B90464B-C3A1-A13C-0087-D33DBA175332}"/>
+                <a16:creationId xmlns:a16="http://schemas.microsoft.com/office/drawing/2014/main" xmlns="" id="{1B90464B-C3A1-A13C-0087-D33DBA175332}"/>
               </a:ext>
             </a:extLst>
           </p:cNvPr>
@@ -7931,7 +7953,7 @@
         <p:cNvPr id="1" name="">
           <a:extLst>
             <a:ext uri="{FF2B5EF4-FFF2-40B4-BE49-F238E27FC236}">
-              <a16:creationId xmlns:a16="http://schemas.microsoft.com/office/drawing/2014/main" id="{C0D59012-3832-5D39-8183-F46236CD5AD5}"/>
+              <a16:creationId xmlns:a16="http://schemas.microsoft.com/office/drawing/2014/main" xmlns="" id="{C0D59012-3832-5D39-8183-F46236CD5AD5}"/>
             </a:ext>
           </a:extLst>
         </p:cNvPr>
@@ -7951,7 +7973,7 @@
           <p:cNvPr id="2" name="Marcador de imagen de diapositiva 1">
             <a:extLst>
               <a:ext uri="{FF2B5EF4-FFF2-40B4-BE49-F238E27FC236}">
-                <a16:creationId xmlns:a16="http://schemas.microsoft.com/office/drawing/2014/main" id="{9753D9C3-71BE-8F24-834A-06238E64A70D}"/>
+                <a16:creationId xmlns:a16="http://schemas.microsoft.com/office/drawing/2014/main" xmlns="" id="{9753D9C3-71BE-8F24-834A-06238E64A70D}"/>
               </a:ext>
             </a:extLst>
           </p:cNvPr>
@@ -7969,7 +7991,7 @@
           <p:cNvPr id="3" name="Marcador de notas 2">
             <a:extLst>
               <a:ext uri="{FF2B5EF4-FFF2-40B4-BE49-F238E27FC236}">
-                <a16:creationId xmlns:a16="http://schemas.microsoft.com/office/drawing/2014/main" id="{E5792187-2B12-7F64-67E7-53D3908B9982}"/>
+                <a16:creationId xmlns:a16="http://schemas.microsoft.com/office/drawing/2014/main" xmlns="" id="{E5792187-2B12-7F64-67E7-53D3908B9982}"/>
               </a:ext>
             </a:extLst>
           </p:cNvPr>
@@ -8003,7 +8025,7 @@
           <p:cNvPr id="4" name="Marcador de número de diapositiva 3">
             <a:extLst>
               <a:ext uri="{FF2B5EF4-FFF2-40B4-BE49-F238E27FC236}">
-                <a16:creationId xmlns:a16="http://schemas.microsoft.com/office/drawing/2014/main" id="{923C1211-D21A-F39B-CA9C-2B2EBF97B8F1}"/>
+                <a16:creationId xmlns:a16="http://schemas.microsoft.com/office/drawing/2014/main" xmlns="" id="{923C1211-D21A-F39B-CA9C-2B2EBF97B8F1}"/>
               </a:ext>
             </a:extLst>
           </p:cNvPr>
@@ -8048,7 +8070,7 @@
         <p:cNvPr id="1" name="">
           <a:extLst>
             <a:ext uri="{FF2B5EF4-FFF2-40B4-BE49-F238E27FC236}">
-              <a16:creationId xmlns:a16="http://schemas.microsoft.com/office/drawing/2014/main" id="{7512AD98-B880-11B4-D1A2-5C54E2D3DB95}"/>
+              <a16:creationId xmlns:a16="http://schemas.microsoft.com/office/drawing/2014/main" xmlns="" id="{7512AD98-B880-11B4-D1A2-5C54E2D3DB95}"/>
             </a:ext>
           </a:extLst>
         </p:cNvPr>
@@ -8068,7 +8090,7 @@
           <p:cNvPr id="2" name="Marcador de imagen de diapositiva 1">
             <a:extLst>
               <a:ext uri="{FF2B5EF4-FFF2-40B4-BE49-F238E27FC236}">
-                <a16:creationId xmlns:a16="http://schemas.microsoft.com/office/drawing/2014/main" id="{9BD5A377-84D8-34B7-CF11-802F2A877DBD}"/>
+                <a16:creationId xmlns:a16="http://schemas.microsoft.com/office/drawing/2014/main" xmlns="" id="{9BD5A377-84D8-34B7-CF11-802F2A877DBD}"/>
               </a:ext>
             </a:extLst>
           </p:cNvPr>
@@ -8086,7 +8108,7 @@
           <p:cNvPr id="3" name="Marcador de notas 2">
             <a:extLst>
               <a:ext uri="{FF2B5EF4-FFF2-40B4-BE49-F238E27FC236}">
-                <a16:creationId xmlns:a16="http://schemas.microsoft.com/office/drawing/2014/main" id="{819F0629-F99B-BE20-02D9-C8F59F9B2BDB}"/>
+                <a16:creationId xmlns:a16="http://schemas.microsoft.com/office/drawing/2014/main" xmlns="" id="{819F0629-F99B-BE20-02D9-C8F59F9B2BDB}"/>
               </a:ext>
             </a:extLst>
           </p:cNvPr>
@@ -8120,7 +8142,7 @@
           <p:cNvPr id="4" name="Marcador de número de diapositiva 3">
             <a:extLst>
               <a:ext uri="{FF2B5EF4-FFF2-40B4-BE49-F238E27FC236}">
-                <a16:creationId xmlns:a16="http://schemas.microsoft.com/office/drawing/2014/main" id="{1E01E37A-A885-024B-3CE1-005FB890C64A}"/>
+                <a16:creationId xmlns:a16="http://schemas.microsoft.com/office/drawing/2014/main" xmlns="" id="{1E01E37A-A885-024B-3CE1-005FB890C64A}"/>
               </a:ext>
             </a:extLst>
           </p:cNvPr>
@@ -8165,7 +8187,7 @@
         <p:cNvPr id="1" name="">
           <a:extLst>
             <a:ext uri="{FF2B5EF4-FFF2-40B4-BE49-F238E27FC236}">
-              <a16:creationId xmlns:a16="http://schemas.microsoft.com/office/drawing/2014/main" id="{D19C022C-D24C-FABF-B7F3-F78A28C9E5E9}"/>
+              <a16:creationId xmlns:a16="http://schemas.microsoft.com/office/drawing/2014/main" xmlns="" id="{D19C022C-D24C-FABF-B7F3-F78A28C9E5E9}"/>
             </a:ext>
           </a:extLst>
         </p:cNvPr>
@@ -8185,7 +8207,7 @@
           <p:cNvPr id="2" name="Marcador de imagen de diapositiva 1">
             <a:extLst>
               <a:ext uri="{FF2B5EF4-FFF2-40B4-BE49-F238E27FC236}">
-                <a16:creationId xmlns:a16="http://schemas.microsoft.com/office/drawing/2014/main" id="{968C4A17-1DC5-FE7A-FAEE-6645F3C452EF}"/>
+                <a16:creationId xmlns:a16="http://schemas.microsoft.com/office/drawing/2014/main" xmlns="" id="{968C4A17-1DC5-FE7A-FAEE-6645F3C452EF}"/>
               </a:ext>
             </a:extLst>
           </p:cNvPr>
@@ -8203,7 +8225,7 @@
           <p:cNvPr id="3" name="Marcador de notas 2">
             <a:extLst>
               <a:ext uri="{FF2B5EF4-FFF2-40B4-BE49-F238E27FC236}">
-                <a16:creationId xmlns:a16="http://schemas.microsoft.com/office/drawing/2014/main" id="{EA4D180A-CB92-EDDF-D75A-DCD6BC2CA479}"/>
+                <a16:creationId xmlns:a16="http://schemas.microsoft.com/office/drawing/2014/main" xmlns="" id="{EA4D180A-CB92-EDDF-D75A-DCD6BC2CA479}"/>
               </a:ext>
             </a:extLst>
           </p:cNvPr>
@@ -8228,7 +8250,7 @@
           <p:cNvPr id="4" name="Marcador de número de diapositiva 3">
             <a:extLst>
               <a:ext uri="{FF2B5EF4-FFF2-40B4-BE49-F238E27FC236}">
-                <a16:creationId xmlns:a16="http://schemas.microsoft.com/office/drawing/2014/main" id="{03598296-8EC7-E502-6F68-E99DAF522D72}"/>
+                <a16:creationId xmlns:a16="http://schemas.microsoft.com/office/drawing/2014/main" xmlns="" id="{03598296-8EC7-E502-6F68-E99DAF522D72}"/>
               </a:ext>
             </a:extLst>
           </p:cNvPr>
@@ -8273,7 +8295,7 @@
         <p:cNvPr id="1" name="">
           <a:extLst>
             <a:ext uri="{FF2B5EF4-FFF2-40B4-BE49-F238E27FC236}">
-              <a16:creationId xmlns:a16="http://schemas.microsoft.com/office/drawing/2014/main" id="{6112B8E2-70FA-9A01-D7E7-9765C246F9E6}"/>
+              <a16:creationId xmlns:a16="http://schemas.microsoft.com/office/drawing/2014/main" xmlns="" id="{6112B8E2-70FA-9A01-D7E7-9765C246F9E6}"/>
             </a:ext>
           </a:extLst>
         </p:cNvPr>
@@ -8293,7 +8315,7 @@
           <p:cNvPr id="2" name="Marcador de imagen de diapositiva 1">
             <a:extLst>
               <a:ext uri="{FF2B5EF4-FFF2-40B4-BE49-F238E27FC236}">
-                <a16:creationId xmlns:a16="http://schemas.microsoft.com/office/drawing/2014/main" id="{317CA1FE-53AB-A4A2-1AD4-174898DCD96B}"/>
+                <a16:creationId xmlns:a16="http://schemas.microsoft.com/office/drawing/2014/main" xmlns="" id="{317CA1FE-53AB-A4A2-1AD4-174898DCD96B}"/>
               </a:ext>
             </a:extLst>
           </p:cNvPr>
@@ -8311,7 +8333,7 @@
           <p:cNvPr id="3" name="Marcador de notas 2">
             <a:extLst>
               <a:ext uri="{FF2B5EF4-FFF2-40B4-BE49-F238E27FC236}">
-                <a16:creationId xmlns:a16="http://schemas.microsoft.com/office/drawing/2014/main" id="{09AC5D18-CF8D-B897-1704-07CA7E6F4DD9}"/>
+                <a16:creationId xmlns:a16="http://schemas.microsoft.com/office/drawing/2014/main" xmlns="" id="{09AC5D18-CF8D-B897-1704-07CA7E6F4DD9}"/>
               </a:ext>
             </a:extLst>
           </p:cNvPr>
@@ -8345,7 +8367,7 @@
           <p:cNvPr id="4" name="Marcador de número de diapositiva 3">
             <a:extLst>
               <a:ext uri="{FF2B5EF4-FFF2-40B4-BE49-F238E27FC236}">
-                <a16:creationId xmlns:a16="http://schemas.microsoft.com/office/drawing/2014/main" id="{94609BF8-7980-12F8-2456-9CB5C9E586DC}"/>
+                <a16:creationId xmlns:a16="http://schemas.microsoft.com/office/drawing/2014/main" xmlns="" id="{94609BF8-7980-12F8-2456-9CB5C9E586DC}"/>
               </a:ext>
             </a:extLst>
           </p:cNvPr>
@@ -8390,7 +8412,7 @@
         <p:cNvPr id="1" name="">
           <a:extLst>
             <a:ext uri="{FF2B5EF4-FFF2-40B4-BE49-F238E27FC236}">
-              <a16:creationId xmlns:a16="http://schemas.microsoft.com/office/drawing/2014/main" id="{C6ACAD4D-95C8-24AB-EB07-78F5E35C29CB}"/>
+              <a16:creationId xmlns:a16="http://schemas.microsoft.com/office/drawing/2014/main" xmlns="" id="{C6ACAD4D-95C8-24AB-EB07-78F5E35C29CB}"/>
             </a:ext>
           </a:extLst>
         </p:cNvPr>
@@ -8410,7 +8432,7 @@
           <p:cNvPr id="2" name="Marcador de imagen de diapositiva 1">
             <a:extLst>
               <a:ext uri="{FF2B5EF4-FFF2-40B4-BE49-F238E27FC236}">
-                <a16:creationId xmlns:a16="http://schemas.microsoft.com/office/drawing/2014/main" id="{E8AB616C-6AE6-F3D5-D09B-F824DDB1C384}"/>
+                <a16:creationId xmlns:a16="http://schemas.microsoft.com/office/drawing/2014/main" xmlns="" id="{E8AB616C-6AE6-F3D5-D09B-F824DDB1C384}"/>
               </a:ext>
             </a:extLst>
           </p:cNvPr>
@@ -8428,7 +8450,7 @@
           <p:cNvPr id="3" name="Marcador de notas 2">
             <a:extLst>
               <a:ext uri="{FF2B5EF4-FFF2-40B4-BE49-F238E27FC236}">
-                <a16:creationId xmlns:a16="http://schemas.microsoft.com/office/drawing/2014/main" id="{403EE9D3-D6A1-43F4-6078-9A1CF02B0691}"/>
+                <a16:creationId xmlns:a16="http://schemas.microsoft.com/office/drawing/2014/main" xmlns="" id="{403EE9D3-D6A1-43F4-6078-9A1CF02B0691}"/>
               </a:ext>
             </a:extLst>
           </p:cNvPr>
@@ -8453,7 +8475,7 @@
           <p:cNvPr id="4" name="Marcador de número de diapositiva 3">
             <a:extLst>
               <a:ext uri="{FF2B5EF4-FFF2-40B4-BE49-F238E27FC236}">
-                <a16:creationId xmlns:a16="http://schemas.microsoft.com/office/drawing/2014/main" id="{E125C349-FDA0-328B-61A4-41A3D521F7BE}"/>
+                <a16:creationId xmlns:a16="http://schemas.microsoft.com/office/drawing/2014/main" xmlns="" id="{E125C349-FDA0-328B-61A4-41A3D521F7BE}"/>
               </a:ext>
             </a:extLst>
           </p:cNvPr>
@@ -8498,7 +8520,7 @@
         <p:cNvPr id="1" name="">
           <a:extLst>
             <a:ext uri="{FF2B5EF4-FFF2-40B4-BE49-F238E27FC236}">
-              <a16:creationId xmlns:a16="http://schemas.microsoft.com/office/drawing/2014/main" id="{CB5C3160-33F1-A4F6-072B-7FA42FE32C41}"/>
+              <a16:creationId xmlns:a16="http://schemas.microsoft.com/office/drawing/2014/main" xmlns="" id="{CB5C3160-33F1-A4F6-072B-7FA42FE32C41}"/>
             </a:ext>
           </a:extLst>
         </p:cNvPr>
@@ -8518,7 +8540,7 @@
           <p:cNvPr id="2" name="Marcador de imagen de diapositiva 1">
             <a:extLst>
               <a:ext uri="{FF2B5EF4-FFF2-40B4-BE49-F238E27FC236}">
-                <a16:creationId xmlns:a16="http://schemas.microsoft.com/office/drawing/2014/main" id="{6FF6A0B3-A051-16C6-69A9-1D69634C93BB}"/>
+                <a16:creationId xmlns:a16="http://schemas.microsoft.com/office/drawing/2014/main" xmlns="" id="{6FF6A0B3-A051-16C6-69A9-1D69634C93BB}"/>
               </a:ext>
             </a:extLst>
           </p:cNvPr>
@@ -8536,7 +8558,7 @@
           <p:cNvPr id="3" name="Marcador de notas 2">
             <a:extLst>
               <a:ext uri="{FF2B5EF4-FFF2-40B4-BE49-F238E27FC236}">
-                <a16:creationId xmlns:a16="http://schemas.microsoft.com/office/drawing/2014/main" id="{275BE463-6DDD-D960-5693-02C74BED994E}"/>
+                <a16:creationId xmlns:a16="http://schemas.microsoft.com/office/drawing/2014/main" xmlns="" id="{275BE463-6DDD-D960-5693-02C74BED994E}"/>
               </a:ext>
             </a:extLst>
           </p:cNvPr>
@@ -8561,7 +8583,7 @@
           <p:cNvPr id="4" name="Marcador de número de diapositiva 3">
             <a:extLst>
               <a:ext uri="{FF2B5EF4-FFF2-40B4-BE49-F238E27FC236}">
-                <a16:creationId xmlns:a16="http://schemas.microsoft.com/office/drawing/2014/main" id="{897523A9-CFD7-7340-FF11-FB4447A3F7A3}"/>
+                <a16:creationId xmlns:a16="http://schemas.microsoft.com/office/drawing/2014/main" xmlns="" id="{897523A9-CFD7-7340-FF11-FB4447A3F7A3}"/>
               </a:ext>
             </a:extLst>
           </p:cNvPr>
@@ -8694,7 +8716,7 @@
         <p:cNvPr id="1" name="">
           <a:extLst>
             <a:ext uri="{FF2B5EF4-FFF2-40B4-BE49-F238E27FC236}">
-              <a16:creationId xmlns:a16="http://schemas.microsoft.com/office/drawing/2014/main" id="{AF305D52-49A3-5848-37E4-4904591C29A4}"/>
+              <a16:creationId xmlns:a16="http://schemas.microsoft.com/office/drawing/2014/main" xmlns="" id="{AF305D52-49A3-5848-37E4-4904591C29A4}"/>
             </a:ext>
           </a:extLst>
         </p:cNvPr>
@@ -8714,7 +8736,7 @@
           <p:cNvPr id="2" name="Marcador de imagen de diapositiva 1">
             <a:extLst>
               <a:ext uri="{FF2B5EF4-FFF2-40B4-BE49-F238E27FC236}">
-                <a16:creationId xmlns:a16="http://schemas.microsoft.com/office/drawing/2014/main" id="{264DE7F8-C010-2EA7-80BB-E2F7E0354C50}"/>
+                <a16:creationId xmlns:a16="http://schemas.microsoft.com/office/drawing/2014/main" xmlns="" id="{264DE7F8-C010-2EA7-80BB-E2F7E0354C50}"/>
               </a:ext>
             </a:extLst>
           </p:cNvPr>
@@ -8732,7 +8754,7 @@
           <p:cNvPr id="3" name="Marcador de notas 2">
             <a:extLst>
               <a:ext uri="{FF2B5EF4-FFF2-40B4-BE49-F238E27FC236}">
-                <a16:creationId xmlns:a16="http://schemas.microsoft.com/office/drawing/2014/main" id="{D23D33F0-7C0F-A6CD-9B2B-96A2E0BB3FCA}"/>
+                <a16:creationId xmlns:a16="http://schemas.microsoft.com/office/drawing/2014/main" xmlns="" id="{D23D33F0-7C0F-A6CD-9B2B-96A2E0BB3FCA}"/>
               </a:ext>
             </a:extLst>
           </p:cNvPr>
@@ -8761,7 +8783,7 @@
           <p:cNvPr id="4" name="Marcador de número de diapositiva 3">
             <a:extLst>
               <a:ext uri="{FF2B5EF4-FFF2-40B4-BE49-F238E27FC236}">
-                <a16:creationId xmlns:a16="http://schemas.microsoft.com/office/drawing/2014/main" id="{32BDB245-CECD-89CE-B664-2CC8D187A9BC}"/>
+                <a16:creationId xmlns:a16="http://schemas.microsoft.com/office/drawing/2014/main" xmlns="" id="{32BDB245-CECD-89CE-B664-2CC8D187A9BC}"/>
               </a:ext>
             </a:extLst>
           </p:cNvPr>
@@ -8806,7 +8828,7 @@
         <p:cNvPr id="1" name="">
           <a:extLst>
             <a:ext uri="{FF2B5EF4-FFF2-40B4-BE49-F238E27FC236}">
-              <a16:creationId xmlns:a16="http://schemas.microsoft.com/office/drawing/2014/main" id="{16CB22E1-7082-2BF6-8BFA-B27D3CB332F1}"/>
+              <a16:creationId xmlns:a16="http://schemas.microsoft.com/office/drawing/2014/main" xmlns="" id="{16CB22E1-7082-2BF6-8BFA-B27D3CB332F1}"/>
             </a:ext>
           </a:extLst>
         </p:cNvPr>
@@ -8826,7 +8848,7 @@
           <p:cNvPr id="2" name="Marcador de imagen de diapositiva 1">
             <a:extLst>
               <a:ext uri="{FF2B5EF4-FFF2-40B4-BE49-F238E27FC236}">
-                <a16:creationId xmlns:a16="http://schemas.microsoft.com/office/drawing/2014/main" id="{A9D483EF-8E9E-6817-54D4-FA50E58AA5BC}"/>
+                <a16:creationId xmlns:a16="http://schemas.microsoft.com/office/drawing/2014/main" xmlns="" id="{A9D483EF-8E9E-6817-54D4-FA50E58AA5BC}"/>
               </a:ext>
             </a:extLst>
           </p:cNvPr>
@@ -8844,7 +8866,7 @@
           <p:cNvPr id="3" name="Marcador de notas 2">
             <a:extLst>
               <a:ext uri="{FF2B5EF4-FFF2-40B4-BE49-F238E27FC236}">
-                <a16:creationId xmlns:a16="http://schemas.microsoft.com/office/drawing/2014/main" id="{D35F5B89-C158-E21C-4D67-D43A902F131E}"/>
+                <a16:creationId xmlns:a16="http://schemas.microsoft.com/office/drawing/2014/main" xmlns="" id="{D35F5B89-C158-E21C-4D67-D43A902F131E}"/>
               </a:ext>
             </a:extLst>
           </p:cNvPr>
@@ -8877,7 +8899,7 @@
           <p:cNvPr id="4" name="Marcador de número de diapositiva 3">
             <a:extLst>
               <a:ext uri="{FF2B5EF4-FFF2-40B4-BE49-F238E27FC236}">
-                <a16:creationId xmlns:a16="http://schemas.microsoft.com/office/drawing/2014/main" id="{A7F57656-A1B3-EA52-D886-4E6C01672D26}"/>
+                <a16:creationId xmlns:a16="http://schemas.microsoft.com/office/drawing/2014/main" xmlns="" id="{A7F57656-A1B3-EA52-D886-4E6C01672D26}"/>
               </a:ext>
             </a:extLst>
           </p:cNvPr>
@@ -8922,7 +8944,7 @@
         <p:cNvPr id="1" name="">
           <a:extLst>
             <a:ext uri="{FF2B5EF4-FFF2-40B4-BE49-F238E27FC236}">
-              <a16:creationId xmlns:a16="http://schemas.microsoft.com/office/drawing/2014/main" id="{E7BAF0A4-D7F0-120A-DC00-57022741514D}"/>
+              <a16:creationId xmlns:a16="http://schemas.microsoft.com/office/drawing/2014/main" xmlns="" id="{E7BAF0A4-D7F0-120A-DC00-57022741514D}"/>
             </a:ext>
           </a:extLst>
         </p:cNvPr>
@@ -8942,7 +8964,7 @@
           <p:cNvPr id="2" name="Marcador de imagen de diapositiva 1">
             <a:extLst>
               <a:ext uri="{FF2B5EF4-FFF2-40B4-BE49-F238E27FC236}">
-                <a16:creationId xmlns:a16="http://schemas.microsoft.com/office/drawing/2014/main" id="{2298E802-686D-6A55-2724-1FC73CDBE2B5}"/>
+                <a16:creationId xmlns:a16="http://schemas.microsoft.com/office/drawing/2014/main" xmlns="" id="{2298E802-686D-6A55-2724-1FC73CDBE2B5}"/>
               </a:ext>
             </a:extLst>
           </p:cNvPr>
@@ -8960,7 +8982,7 @@
           <p:cNvPr id="3" name="Marcador de notas 2">
             <a:extLst>
               <a:ext uri="{FF2B5EF4-FFF2-40B4-BE49-F238E27FC236}">
-                <a16:creationId xmlns:a16="http://schemas.microsoft.com/office/drawing/2014/main" id="{B05DA440-2AAA-0D1C-806F-E672C3841747}"/>
+                <a16:creationId xmlns:a16="http://schemas.microsoft.com/office/drawing/2014/main" xmlns="" id="{B05DA440-2AAA-0D1C-806F-E672C3841747}"/>
               </a:ext>
             </a:extLst>
           </p:cNvPr>
@@ -8989,7 +9011,7 @@
           <p:cNvPr id="4" name="Marcador de número de diapositiva 3">
             <a:extLst>
               <a:ext uri="{FF2B5EF4-FFF2-40B4-BE49-F238E27FC236}">
-                <a16:creationId xmlns:a16="http://schemas.microsoft.com/office/drawing/2014/main" id="{3CA16216-C1B7-06B6-1C48-21A033CE44B4}"/>
+                <a16:creationId xmlns:a16="http://schemas.microsoft.com/office/drawing/2014/main" xmlns="" id="{3CA16216-C1B7-06B6-1C48-21A033CE44B4}"/>
               </a:ext>
             </a:extLst>
           </p:cNvPr>
@@ -9034,7 +9056,7 @@
         <p:cNvPr id="1" name="">
           <a:extLst>
             <a:ext uri="{FF2B5EF4-FFF2-40B4-BE49-F238E27FC236}">
-              <a16:creationId xmlns:a16="http://schemas.microsoft.com/office/drawing/2014/main" id="{C250F8F7-84C2-5B45-37A6-1153B56AFDEA}"/>
+              <a16:creationId xmlns:a16="http://schemas.microsoft.com/office/drawing/2014/main" xmlns="" id="{C250F8F7-84C2-5B45-37A6-1153B56AFDEA}"/>
             </a:ext>
           </a:extLst>
         </p:cNvPr>
@@ -9054,7 +9076,7 @@
           <p:cNvPr id="2" name="Marcador de imagen de diapositiva 1">
             <a:extLst>
               <a:ext uri="{FF2B5EF4-FFF2-40B4-BE49-F238E27FC236}">
-                <a16:creationId xmlns:a16="http://schemas.microsoft.com/office/drawing/2014/main" id="{AF7EA74B-D8FD-7F31-387C-C7BA1287BC62}"/>
+                <a16:creationId xmlns:a16="http://schemas.microsoft.com/office/drawing/2014/main" xmlns="" id="{AF7EA74B-D8FD-7F31-387C-C7BA1287BC62}"/>
               </a:ext>
             </a:extLst>
           </p:cNvPr>
@@ -9072,7 +9094,7 @@
           <p:cNvPr id="3" name="Marcador de notas 2">
             <a:extLst>
               <a:ext uri="{FF2B5EF4-FFF2-40B4-BE49-F238E27FC236}">
-                <a16:creationId xmlns:a16="http://schemas.microsoft.com/office/drawing/2014/main" id="{E4689AB9-36E7-32BB-898E-5D5AE93664F9}"/>
+                <a16:creationId xmlns:a16="http://schemas.microsoft.com/office/drawing/2014/main" xmlns="" id="{E4689AB9-36E7-32BB-898E-5D5AE93664F9}"/>
               </a:ext>
             </a:extLst>
           </p:cNvPr>
@@ -9101,7 +9123,7 @@
           <p:cNvPr id="4" name="Marcador de número de diapositiva 3">
             <a:extLst>
               <a:ext uri="{FF2B5EF4-FFF2-40B4-BE49-F238E27FC236}">
-                <a16:creationId xmlns:a16="http://schemas.microsoft.com/office/drawing/2014/main" id="{2A9A8C79-6B0F-1272-769E-1604E7A38E7E}"/>
+                <a16:creationId xmlns:a16="http://schemas.microsoft.com/office/drawing/2014/main" xmlns="" id="{2A9A8C79-6B0F-1272-769E-1604E7A38E7E}"/>
               </a:ext>
             </a:extLst>
           </p:cNvPr>
@@ -9146,7 +9168,7 @@
         <p:cNvPr id="1" name="">
           <a:extLst>
             <a:ext uri="{FF2B5EF4-FFF2-40B4-BE49-F238E27FC236}">
-              <a16:creationId xmlns:a16="http://schemas.microsoft.com/office/drawing/2014/main" id="{36D94D25-0505-EC87-FB19-515369FCDAAF}"/>
+              <a16:creationId xmlns:a16="http://schemas.microsoft.com/office/drawing/2014/main" xmlns="" id="{36D94D25-0505-EC87-FB19-515369FCDAAF}"/>
             </a:ext>
           </a:extLst>
         </p:cNvPr>
@@ -9166,7 +9188,7 @@
           <p:cNvPr id="2" name="Marcador de imagen de diapositiva 1">
             <a:extLst>
               <a:ext uri="{FF2B5EF4-FFF2-40B4-BE49-F238E27FC236}">
-                <a16:creationId xmlns:a16="http://schemas.microsoft.com/office/drawing/2014/main" id="{FB4DEB8D-A6E9-F9BC-F753-D7B1974C1434}"/>
+                <a16:creationId xmlns:a16="http://schemas.microsoft.com/office/drawing/2014/main" xmlns="" id="{FB4DEB8D-A6E9-F9BC-F753-D7B1974C1434}"/>
               </a:ext>
             </a:extLst>
           </p:cNvPr>
@@ -9184,7 +9206,7 @@
           <p:cNvPr id="3" name="Marcador de notas 2">
             <a:extLst>
               <a:ext uri="{FF2B5EF4-FFF2-40B4-BE49-F238E27FC236}">
-                <a16:creationId xmlns:a16="http://schemas.microsoft.com/office/drawing/2014/main" id="{D7A48737-222A-462B-E619-ADE82C67BB96}"/>
+                <a16:creationId xmlns:a16="http://schemas.microsoft.com/office/drawing/2014/main" xmlns="" id="{D7A48737-222A-462B-E619-ADE82C67BB96}"/>
               </a:ext>
             </a:extLst>
           </p:cNvPr>
@@ -9225,7 +9247,7 @@
           <p:cNvPr id="4" name="Marcador de número de diapositiva 3">
             <a:extLst>
               <a:ext uri="{FF2B5EF4-FFF2-40B4-BE49-F238E27FC236}">
-                <a16:creationId xmlns:a16="http://schemas.microsoft.com/office/drawing/2014/main" id="{E07417BD-5542-D618-A913-46D99F70A70D}"/>
+                <a16:creationId xmlns:a16="http://schemas.microsoft.com/office/drawing/2014/main" xmlns="" id="{E07417BD-5542-D618-A913-46D99F70A70D}"/>
               </a:ext>
             </a:extLst>
           </p:cNvPr>
@@ -9270,7 +9292,7 @@
         <p:cNvPr id="1" name="">
           <a:extLst>
             <a:ext uri="{FF2B5EF4-FFF2-40B4-BE49-F238E27FC236}">
-              <a16:creationId xmlns:a16="http://schemas.microsoft.com/office/drawing/2014/main" id="{5D017DBE-8451-9A1C-F60E-AF8B55230D8D}"/>
+              <a16:creationId xmlns:a16="http://schemas.microsoft.com/office/drawing/2014/main" xmlns="" id="{5D017DBE-8451-9A1C-F60E-AF8B55230D8D}"/>
             </a:ext>
           </a:extLst>
         </p:cNvPr>
@@ -9290,7 +9312,7 @@
           <p:cNvPr id="2" name="Marcador de imagen de diapositiva 1">
             <a:extLst>
               <a:ext uri="{FF2B5EF4-FFF2-40B4-BE49-F238E27FC236}">
-                <a16:creationId xmlns:a16="http://schemas.microsoft.com/office/drawing/2014/main" id="{300C1553-ADEF-A25E-05FB-925B79791913}"/>
+                <a16:creationId xmlns:a16="http://schemas.microsoft.com/office/drawing/2014/main" xmlns="" id="{300C1553-ADEF-A25E-05FB-925B79791913}"/>
               </a:ext>
             </a:extLst>
           </p:cNvPr>
@@ -9308,7 +9330,7 @@
           <p:cNvPr id="3" name="Marcador de notas 2">
             <a:extLst>
               <a:ext uri="{FF2B5EF4-FFF2-40B4-BE49-F238E27FC236}">
-                <a16:creationId xmlns:a16="http://schemas.microsoft.com/office/drawing/2014/main" id="{C2884912-1AAB-A1F9-FAE2-0F45818B7E12}"/>
+                <a16:creationId xmlns:a16="http://schemas.microsoft.com/office/drawing/2014/main" xmlns="" id="{C2884912-1AAB-A1F9-FAE2-0F45818B7E12}"/>
               </a:ext>
             </a:extLst>
           </p:cNvPr>
@@ -9349,7 +9371,7 @@
           <p:cNvPr id="4" name="Marcador de número de diapositiva 3">
             <a:extLst>
               <a:ext uri="{FF2B5EF4-FFF2-40B4-BE49-F238E27FC236}">
-                <a16:creationId xmlns:a16="http://schemas.microsoft.com/office/drawing/2014/main" id="{A08AA826-DE5D-8987-747F-54A3BB500240}"/>
+                <a16:creationId xmlns:a16="http://schemas.microsoft.com/office/drawing/2014/main" xmlns="" id="{A08AA826-DE5D-8987-747F-54A3BB500240}"/>
               </a:ext>
             </a:extLst>
           </p:cNvPr>
@@ -9408,7 +9430,7 @@
           <p:cNvPr id="2" name="Título 1">
             <a:extLst>
               <a:ext uri="{FF2B5EF4-FFF2-40B4-BE49-F238E27FC236}">
-                <a16:creationId xmlns:a16="http://schemas.microsoft.com/office/drawing/2014/main" id="{C68F5251-D223-BC64-D677-1BEF02B6E87F}"/>
+                <a16:creationId xmlns:a16="http://schemas.microsoft.com/office/drawing/2014/main" xmlns="" id="{C68F5251-D223-BC64-D677-1BEF02B6E87F}"/>
               </a:ext>
             </a:extLst>
           </p:cNvPr>
@@ -9446,7 +9468,7 @@
           <p:cNvPr id="3" name="Subtítulo 2">
             <a:extLst>
               <a:ext uri="{FF2B5EF4-FFF2-40B4-BE49-F238E27FC236}">
-                <a16:creationId xmlns:a16="http://schemas.microsoft.com/office/drawing/2014/main" id="{3F4A65FE-8D2A-DD67-B7B2-6214BCC7FFB3}"/>
+                <a16:creationId xmlns:a16="http://schemas.microsoft.com/office/drawing/2014/main" xmlns="" id="{3F4A65FE-8D2A-DD67-B7B2-6214BCC7FFB3}"/>
               </a:ext>
             </a:extLst>
           </p:cNvPr>
@@ -9517,7 +9539,7 @@
           <p:cNvPr id="4" name="Marcador de fecha 3">
             <a:extLst>
               <a:ext uri="{FF2B5EF4-FFF2-40B4-BE49-F238E27FC236}">
-                <a16:creationId xmlns:a16="http://schemas.microsoft.com/office/drawing/2014/main" id="{464258EB-91E8-2924-CBD4-96B87E7215B3}"/>
+                <a16:creationId xmlns:a16="http://schemas.microsoft.com/office/drawing/2014/main" xmlns="" id="{464258EB-91E8-2924-CBD4-96B87E7215B3}"/>
               </a:ext>
             </a:extLst>
           </p:cNvPr>
@@ -9535,7 +9557,7 @@
           <a:p>
             <a:fld id="{ABDDA2F0-ADA3-4A09-A4A4-0854B4A15306}" type="datetimeFigureOut">
               <a:rPr lang="es-MX" smtClean="0"/>
-              <a:t>07/10/2025</a:t>
+              <a:t>08/10/2025</a:t>
             </a:fld>
             <a:endParaRPr lang="es-MX"/>
           </a:p>
@@ -9546,7 +9568,7 @@
           <p:cNvPr id="5" name="Marcador de pie de página 4">
             <a:extLst>
               <a:ext uri="{FF2B5EF4-FFF2-40B4-BE49-F238E27FC236}">
-                <a16:creationId xmlns:a16="http://schemas.microsoft.com/office/drawing/2014/main" id="{DE84EB14-DDAA-D28A-7BDC-5CA4FD1477E1}"/>
+                <a16:creationId xmlns:a16="http://schemas.microsoft.com/office/drawing/2014/main" xmlns="" id="{DE84EB14-DDAA-D28A-7BDC-5CA4FD1477E1}"/>
               </a:ext>
             </a:extLst>
           </p:cNvPr>
@@ -9571,7 +9593,7 @@
           <p:cNvPr id="6" name="Marcador de número de diapositiva 5">
             <a:extLst>
               <a:ext uri="{FF2B5EF4-FFF2-40B4-BE49-F238E27FC236}">
-                <a16:creationId xmlns:a16="http://schemas.microsoft.com/office/drawing/2014/main" id="{020C777D-DB97-B69E-A018-FD1F6A2F2EA2}"/>
+                <a16:creationId xmlns:a16="http://schemas.microsoft.com/office/drawing/2014/main" xmlns="" id="{020C777D-DB97-B69E-A018-FD1F6A2F2EA2}"/>
               </a:ext>
             </a:extLst>
           </p:cNvPr>
@@ -9630,7 +9652,7 @@
           <p:cNvPr id="2" name="Título 1">
             <a:extLst>
               <a:ext uri="{FF2B5EF4-FFF2-40B4-BE49-F238E27FC236}">
-                <a16:creationId xmlns:a16="http://schemas.microsoft.com/office/drawing/2014/main" id="{885B19B8-5854-260F-CB96-1B6829523669}"/>
+                <a16:creationId xmlns:a16="http://schemas.microsoft.com/office/drawing/2014/main" xmlns="" id="{885B19B8-5854-260F-CB96-1B6829523669}"/>
               </a:ext>
             </a:extLst>
           </p:cNvPr>
@@ -9659,7 +9681,7 @@
           <p:cNvPr id="3" name="Marcador de texto vertical 2">
             <a:extLst>
               <a:ext uri="{FF2B5EF4-FFF2-40B4-BE49-F238E27FC236}">
-                <a16:creationId xmlns:a16="http://schemas.microsoft.com/office/drawing/2014/main" id="{EA8F2339-935A-BA50-6D17-C11D9A50303F}"/>
+                <a16:creationId xmlns:a16="http://schemas.microsoft.com/office/drawing/2014/main" xmlns="" id="{EA8F2339-935A-BA50-6D17-C11D9A50303F}"/>
               </a:ext>
             </a:extLst>
           </p:cNvPr>
@@ -9717,7 +9739,7 @@
           <p:cNvPr id="4" name="Marcador de fecha 3">
             <a:extLst>
               <a:ext uri="{FF2B5EF4-FFF2-40B4-BE49-F238E27FC236}">
-                <a16:creationId xmlns:a16="http://schemas.microsoft.com/office/drawing/2014/main" id="{C0D93516-4160-7AF2-1AD2-1717A1759DF3}"/>
+                <a16:creationId xmlns:a16="http://schemas.microsoft.com/office/drawing/2014/main" xmlns="" id="{C0D93516-4160-7AF2-1AD2-1717A1759DF3}"/>
               </a:ext>
             </a:extLst>
           </p:cNvPr>
@@ -9735,7 +9757,7 @@
           <a:p>
             <a:fld id="{ABDDA2F0-ADA3-4A09-A4A4-0854B4A15306}" type="datetimeFigureOut">
               <a:rPr lang="es-MX" smtClean="0"/>
-              <a:t>07/10/2025</a:t>
+              <a:t>08/10/2025</a:t>
             </a:fld>
             <a:endParaRPr lang="es-MX"/>
           </a:p>
@@ -9746,7 +9768,7 @@
           <p:cNvPr id="5" name="Marcador de pie de página 4">
             <a:extLst>
               <a:ext uri="{FF2B5EF4-FFF2-40B4-BE49-F238E27FC236}">
-                <a16:creationId xmlns:a16="http://schemas.microsoft.com/office/drawing/2014/main" id="{18C2BD7C-43C5-6A6A-2A56-049FECED01E8}"/>
+                <a16:creationId xmlns:a16="http://schemas.microsoft.com/office/drawing/2014/main" xmlns="" id="{18C2BD7C-43C5-6A6A-2A56-049FECED01E8}"/>
               </a:ext>
             </a:extLst>
           </p:cNvPr>
@@ -9771,7 +9793,7 @@
           <p:cNvPr id="6" name="Marcador de número de diapositiva 5">
             <a:extLst>
               <a:ext uri="{FF2B5EF4-FFF2-40B4-BE49-F238E27FC236}">
-                <a16:creationId xmlns:a16="http://schemas.microsoft.com/office/drawing/2014/main" id="{C702C113-1630-F4FE-6B7A-DE6028EAF0DC}"/>
+                <a16:creationId xmlns:a16="http://schemas.microsoft.com/office/drawing/2014/main" xmlns="" id="{C702C113-1630-F4FE-6B7A-DE6028EAF0DC}"/>
               </a:ext>
             </a:extLst>
           </p:cNvPr>
@@ -9830,7 +9852,7 @@
           <p:cNvPr id="2" name="Título vertical 1">
             <a:extLst>
               <a:ext uri="{FF2B5EF4-FFF2-40B4-BE49-F238E27FC236}">
-                <a16:creationId xmlns:a16="http://schemas.microsoft.com/office/drawing/2014/main" id="{35FD6614-0E5D-8F5D-E64C-B2F5267FAFB7}"/>
+                <a16:creationId xmlns:a16="http://schemas.microsoft.com/office/drawing/2014/main" xmlns="" id="{35FD6614-0E5D-8F5D-E64C-B2F5267FAFB7}"/>
               </a:ext>
             </a:extLst>
           </p:cNvPr>
@@ -9864,7 +9886,7 @@
           <p:cNvPr id="3" name="Marcador de texto vertical 2">
             <a:extLst>
               <a:ext uri="{FF2B5EF4-FFF2-40B4-BE49-F238E27FC236}">
-                <a16:creationId xmlns:a16="http://schemas.microsoft.com/office/drawing/2014/main" id="{CF0EED13-C02A-F3ED-C589-DF5EF8C49BD7}"/>
+                <a16:creationId xmlns:a16="http://schemas.microsoft.com/office/drawing/2014/main" xmlns="" id="{CF0EED13-C02A-F3ED-C589-DF5EF8C49BD7}"/>
               </a:ext>
             </a:extLst>
           </p:cNvPr>
@@ -9927,7 +9949,7 @@
           <p:cNvPr id="4" name="Marcador de fecha 3">
             <a:extLst>
               <a:ext uri="{FF2B5EF4-FFF2-40B4-BE49-F238E27FC236}">
-                <a16:creationId xmlns:a16="http://schemas.microsoft.com/office/drawing/2014/main" id="{EB7BDC0A-C2D7-3843-E6F7-DF6981CF3BDF}"/>
+                <a16:creationId xmlns:a16="http://schemas.microsoft.com/office/drawing/2014/main" xmlns="" id="{EB7BDC0A-C2D7-3843-E6F7-DF6981CF3BDF}"/>
               </a:ext>
             </a:extLst>
           </p:cNvPr>
@@ -9945,7 +9967,7 @@
           <a:p>
             <a:fld id="{ABDDA2F0-ADA3-4A09-A4A4-0854B4A15306}" type="datetimeFigureOut">
               <a:rPr lang="es-MX" smtClean="0"/>
-              <a:t>07/10/2025</a:t>
+              <a:t>08/10/2025</a:t>
             </a:fld>
             <a:endParaRPr lang="es-MX"/>
           </a:p>
@@ -9956,7 +9978,7 @@
           <p:cNvPr id="5" name="Marcador de pie de página 4">
             <a:extLst>
               <a:ext uri="{FF2B5EF4-FFF2-40B4-BE49-F238E27FC236}">
-                <a16:creationId xmlns:a16="http://schemas.microsoft.com/office/drawing/2014/main" id="{9F55993D-DADC-BB7C-FB1A-9828BFA237F6}"/>
+                <a16:creationId xmlns:a16="http://schemas.microsoft.com/office/drawing/2014/main" xmlns="" id="{9F55993D-DADC-BB7C-FB1A-9828BFA237F6}"/>
               </a:ext>
             </a:extLst>
           </p:cNvPr>
@@ -9981,7 +10003,7 @@
           <p:cNvPr id="6" name="Marcador de número de diapositiva 5">
             <a:extLst>
               <a:ext uri="{FF2B5EF4-FFF2-40B4-BE49-F238E27FC236}">
-                <a16:creationId xmlns:a16="http://schemas.microsoft.com/office/drawing/2014/main" id="{3BAFEC26-7124-8F71-80CD-4C6F3E3DC2A2}"/>
+                <a16:creationId xmlns:a16="http://schemas.microsoft.com/office/drawing/2014/main" xmlns="" id="{3BAFEC26-7124-8F71-80CD-4C6F3E3DC2A2}"/>
               </a:ext>
             </a:extLst>
           </p:cNvPr>
@@ -10040,7 +10062,7 @@
           <p:cNvPr id="2" name="Título 1">
             <a:extLst>
               <a:ext uri="{FF2B5EF4-FFF2-40B4-BE49-F238E27FC236}">
-                <a16:creationId xmlns:a16="http://schemas.microsoft.com/office/drawing/2014/main" id="{7D2E4EE2-F889-3074-9997-AF6C4F9D6A83}"/>
+                <a16:creationId xmlns:a16="http://schemas.microsoft.com/office/drawing/2014/main" xmlns="" id="{7D2E4EE2-F889-3074-9997-AF6C4F9D6A83}"/>
               </a:ext>
             </a:extLst>
           </p:cNvPr>
@@ -10069,7 +10091,7 @@
           <p:cNvPr id="3" name="Marcador de contenido 2">
             <a:extLst>
               <a:ext uri="{FF2B5EF4-FFF2-40B4-BE49-F238E27FC236}">
-                <a16:creationId xmlns:a16="http://schemas.microsoft.com/office/drawing/2014/main" id="{C236082A-49F3-8097-81BB-B8BDD75B747C}"/>
+                <a16:creationId xmlns:a16="http://schemas.microsoft.com/office/drawing/2014/main" xmlns="" id="{C236082A-49F3-8097-81BB-B8BDD75B747C}"/>
               </a:ext>
             </a:extLst>
           </p:cNvPr>
@@ -10127,7 +10149,7 @@
           <p:cNvPr id="4" name="Marcador de fecha 3">
             <a:extLst>
               <a:ext uri="{FF2B5EF4-FFF2-40B4-BE49-F238E27FC236}">
-                <a16:creationId xmlns:a16="http://schemas.microsoft.com/office/drawing/2014/main" id="{1FBF5EA1-958A-FE14-14ED-F5DDBBF4E116}"/>
+                <a16:creationId xmlns:a16="http://schemas.microsoft.com/office/drawing/2014/main" xmlns="" id="{1FBF5EA1-958A-FE14-14ED-F5DDBBF4E116}"/>
               </a:ext>
             </a:extLst>
           </p:cNvPr>
@@ -10145,7 +10167,7 @@
           <a:p>
             <a:fld id="{ABDDA2F0-ADA3-4A09-A4A4-0854B4A15306}" type="datetimeFigureOut">
               <a:rPr lang="es-MX" smtClean="0"/>
-              <a:t>07/10/2025</a:t>
+              <a:t>08/10/2025</a:t>
             </a:fld>
             <a:endParaRPr lang="es-MX"/>
           </a:p>
@@ -10156,7 +10178,7 @@
           <p:cNvPr id="5" name="Marcador de pie de página 4">
             <a:extLst>
               <a:ext uri="{FF2B5EF4-FFF2-40B4-BE49-F238E27FC236}">
-                <a16:creationId xmlns:a16="http://schemas.microsoft.com/office/drawing/2014/main" id="{DBB1B2F9-BA97-397C-0A95-CF66A84143A0}"/>
+                <a16:creationId xmlns:a16="http://schemas.microsoft.com/office/drawing/2014/main" xmlns="" id="{DBB1B2F9-BA97-397C-0A95-CF66A84143A0}"/>
               </a:ext>
             </a:extLst>
           </p:cNvPr>
@@ -10181,7 +10203,7 @@
           <p:cNvPr id="6" name="Marcador de número de diapositiva 5">
             <a:extLst>
               <a:ext uri="{FF2B5EF4-FFF2-40B4-BE49-F238E27FC236}">
-                <a16:creationId xmlns:a16="http://schemas.microsoft.com/office/drawing/2014/main" id="{DE2F542E-A793-5753-EA04-A2D047EE8D73}"/>
+                <a16:creationId xmlns:a16="http://schemas.microsoft.com/office/drawing/2014/main" xmlns="" id="{DE2F542E-A793-5753-EA04-A2D047EE8D73}"/>
               </a:ext>
             </a:extLst>
           </p:cNvPr>
@@ -10240,7 +10262,7 @@
           <p:cNvPr id="2" name="Título 1">
             <a:extLst>
               <a:ext uri="{FF2B5EF4-FFF2-40B4-BE49-F238E27FC236}">
-                <a16:creationId xmlns:a16="http://schemas.microsoft.com/office/drawing/2014/main" id="{C12F8EC0-6FE4-21EE-0999-41500DA69A5D}"/>
+                <a16:creationId xmlns:a16="http://schemas.microsoft.com/office/drawing/2014/main" xmlns="" id="{C12F8EC0-6FE4-21EE-0999-41500DA69A5D}"/>
               </a:ext>
             </a:extLst>
           </p:cNvPr>
@@ -10278,7 +10300,7 @@
           <p:cNvPr id="3" name="Marcador de texto 2">
             <a:extLst>
               <a:ext uri="{FF2B5EF4-FFF2-40B4-BE49-F238E27FC236}">
-                <a16:creationId xmlns:a16="http://schemas.microsoft.com/office/drawing/2014/main" id="{AAFEFE82-C496-46BF-24AD-3A2E4C024B34}"/>
+                <a16:creationId xmlns:a16="http://schemas.microsoft.com/office/drawing/2014/main" xmlns="" id="{AAFEFE82-C496-46BF-24AD-3A2E4C024B34}"/>
               </a:ext>
             </a:extLst>
           </p:cNvPr>
@@ -10403,7 +10425,7 @@
           <p:cNvPr id="4" name="Marcador de fecha 3">
             <a:extLst>
               <a:ext uri="{FF2B5EF4-FFF2-40B4-BE49-F238E27FC236}">
-                <a16:creationId xmlns:a16="http://schemas.microsoft.com/office/drawing/2014/main" id="{66983407-AB5D-BF9A-FBAB-084762521C54}"/>
+                <a16:creationId xmlns:a16="http://schemas.microsoft.com/office/drawing/2014/main" xmlns="" id="{66983407-AB5D-BF9A-FBAB-084762521C54}"/>
               </a:ext>
             </a:extLst>
           </p:cNvPr>
@@ -10421,7 +10443,7 @@
           <a:p>
             <a:fld id="{ABDDA2F0-ADA3-4A09-A4A4-0854B4A15306}" type="datetimeFigureOut">
               <a:rPr lang="es-MX" smtClean="0"/>
-              <a:t>07/10/2025</a:t>
+              <a:t>08/10/2025</a:t>
             </a:fld>
             <a:endParaRPr lang="es-MX"/>
           </a:p>
@@ -10432,7 +10454,7 @@
           <p:cNvPr id="5" name="Marcador de pie de página 4">
             <a:extLst>
               <a:ext uri="{FF2B5EF4-FFF2-40B4-BE49-F238E27FC236}">
-                <a16:creationId xmlns:a16="http://schemas.microsoft.com/office/drawing/2014/main" id="{A4091B16-700E-54A4-365B-884593DAECF3}"/>
+                <a16:creationId xmlns:a16="http://schemas.microsoft.com/office/drawing/2014/main" xmlns="" id="{A4091B16-700E-54A4-365B-884593DAECF3}"/>
               </a:ext>
             </a:extLst>
           </p:cNvPr>
@@ -10457,7 +10479,7 @@
           <p:cNvPr id="6" name="Marcador de número de diapositiva 5">
             <a:extLst>
               <a:ext uri="{FF2B5EF4-FFF2-40B4-BE49-F238E27FC236}">
-                <a16:creationId xmlns:a16="http://schemas.microsoft.com/office/drawing/2014/main" id="{617E1B6B-5F0B-DA12-3F53-D096E1224374}"/>
+                <a16:creationId xmlns:a16="http://schemas.microsoft.com/office/drawing/2014/main" xmlns="" id="{617E1B6B-5F0B-DA12-3F53-D096E1224374}"/>
               </a:ext>
             </a:extLst>
           </p:cNvPr>
@@ -10516,7 +10538,7 @@
           <p:cNvPr id="2" name="Título 1">
             <a:extLst>
               <a:ext uri="{FF2B5EF4-FFF2-40B4-BE49-F238E27FC236}">
-                <a16:creationId xmlns:a16="http://schemas.microsoft.com/office/drawing/2014/main" id="{917BE101-93AD-A4F6-2218-966EEAA06938}"/>
+                <a16:creationId xmlns:a16="http://schemas.microsoft.com/office/drawing/2014/main" xmlns="" id="{917BE101-93AD-A4F6-2218-966EEAA06938}"/>
               </a:ext>
             </a:extLst>
           </p:cNvPr>
@@ -10545,7 +10567,7 @@
           <p:cNvPr id="3" name="Marcador de contenido 2">
             <a:extLst>
               <a:ext uri="{FF2B5EF4-FFF2-40B4-BE49-F238E27FC236}">
-                <a16:creationId xmlns:a16="http://schemas.microsoft.com/office/drawing/2014/main" id="{D927AB96-2137-7115-C296-851F579A94C7}"/>
+                <a16:creationId xmlns:a16="http://schemas.microsoft.com/office/drawing/2014/main" xmlns="" id="{D927AB96-2137-7115-C296-851F579A94C7}"/>
               </a:ext>
             </a:extLst>
           </p:cNvPr>
@@ -10608,7 +10630,7 @@
           <p:cNvPr id="4" name="Marcador de contenido 3">
             <a:extLst>
               <a:ext uri="{FF2B5EF4-FFF2-40B4-BE49-F238E27FC236}">
-                <a16:creationId xmlns:a16="http://schemas.microsoft.com/office/drawing/2014/main" id="{85653190-5E9F-C666-A5CA-E5400CDB9916}"/>
+                <a16:creationId xmlns:a16="http://schemas.microsoft.com/office/drawing/2014/main" xmlns="" id="{85653190-5E9F-C666-A5CA-E5400CDB9916}"/>
               </a:ext>
             </a:extLst>
           </p:cNvPr>
@@ -10671,7 +10693,7 @@
           <p:cNvPr id="5" name="Marcador de fecha 4">
             <a:extLst>
               <a:ext uri="{FF2B5EF4-FFF2-40B4-BE49-F238E27FC236}">
-                <a16:creationId xmlns:a16="http://schemas.microsoft.com/office/drawing/2014/main" id="{2287A35D-19C4-6423-2182-6F7AEF7D868A}"/>
+                <a16:creationId xmlns:a16="http://schemas.microsoft.com/office/drawing/2014/main" xmlns="" id="{2287A35D-19C4-6423-2182-6F7AEF7D868A}"/>
               </a:ext>
             </a:extLst>
           </p:cNvPr>
@@ -10689,7 +10711,7 @@
           <a:p>
             <a:fld id="{ABDDA2F0-ADA3-4A09-A4A4-0854B4A15306}" type="datetimeFigureOut">
               <a:rPr lang="es-MX" smtClean="0"/>
-              <a:t>07/10/2025</a:t>
+              <a:t>08/10/2025</a:t>
             </a:fld>
             <a:endParaRPr lang="es-MX"/>
           </a:p>
@@ -10700,7 +10722,7 @@
           <p:cNvPr id="6" name="Marcador de pie de página 5">
             <a:extLst>
               <a:ext uri="{FF2B5EF4-FFF2-40B4-BE49-F238E27FC236}">
-                <a16:creationId xmlns:a16="http://schemas.microsoft.com/office/drawing/2014/main" id="{6A20EBBC-FFE4-BF34-584D-1103DDD1E59B}"/>
+                <a16:creationId xmlns:a16="http://schemas.microsoft.com/office/drawing/2014/main" xmlns="" id="{6A20EBBC-FFE4-BF34-584D-1103DDD1E59B}"/>
               </a:ext>
             </a:extLst>
           </p:cNvPr>
@@ -10725,7 +10747,7 @@
           <p:cNvPr id="7" name="Marcador de número de diapositiva 6">
             <a:extLst>
               <a:ext uri="{FF2B5EF4-FFF2-40B4-BE49-F238E27FC236}">
-                <a16:creationId xmlns:a16="http://schemas.microsoft.com/office/drawing/2014/main" id="{32069CD5-9784-24F5-FD3F-2CE7FEEEAFA5}"/>
+                <a16:creationId xmlns:a16="http://schemas.microsoft.com/office/drawing/2014/main" xmlns="" id="{32069CD5-9784-24F5-FD3F-2CE7FEEEAFA5}"/>
               </a:ext>
             </a:extLst>
           </p:cNvPr>
@@ -10784,7 +10806,7 @@
           <p:cNvPr id="2" name="Título 1">
             <a:extLst>
               <a:ext uri="{FF2B5EF4-FFF2-40B4-BE49-F238E27FC236}">
-                <a16:creationId xmlns:a16="http://schemas.microsoft.com/office/drawing/2014/main" id="{0AC6574D-AD08-47C4-E8FA-8F244F9BFAFD}"/>
+                <a16:creationId xmlns:a16="http://schemas.microsoft.com/office/drawing/2014/main" xmlns="" id="{0AC6574D-AD08-47C4-E8FA-8F244F9BFAFD}"/>
               </a:ext>
             </a:extLst>
           </p:cNvPr>
@@ -10818,7 +10840,7 @@
           <p:cNvPr id="3" name="Marcador de texto 2">
             <a:extLst>
               <a:ext uri="{FF2B5EF4-FFF2-40B4-BE49-F238E27FC236}">
-                <a16:creationId xmlns:a16="http://schemas.microsoft.com/office/drawing/2014/main" id="{20EF632E-3FF8-7DD5-F21D-8CB63B8FEDFA}"/>
+                <a16:creationId xmlns:a16="http://schemas.microsoft.com/office/drawing/2014/main" xmlns="" id="{20EF632E-3FF8-7DD5-F21D-8CB63B8FEDFA}"/>
               </a:ext>
             </a:extLst>
           </p:cNvPr>
@@ -10889,7 +10911,7 @@
           <p:cNvPr id="4" name="Marcador de contenido 3">
             <a:extLst>
               <a:ext uri="{FF2B5EF4-FFF2-40B4-BE49-F238E27FC236}">
-                <a16:creationId xmlns:a16="http://schemas.microsoft.com/office/drawing/2014/main" id="{AFA83C99-17BF-FB92-B9A6-6B9D02FA248F}"/>
+                <a16:creationId xmlns:a16="http://schemas.microsoft.com/office/drawing/2014/main" xmlns="" id="{AFA83C99-17BF-FB92-B9A6-6B9D02FA248F}"/>
               </a:ext>
             </a:extLst>
           </p:cNvPr>
@@ -10952,7 +10974,7 @@
           <p:cNvPr id="5" name="Marcador de texto 4">
             <a:extLst>
               <a:ext uri="{FF2B5EF4-FFF2-40B4-BE49-F238E27FC236}">
-                <a16:creationId xmlns:a16="http://schemas.microsoft.com/office/drawing/2014/main" id="{5FE508B0-6C5A-C9B0-FC6B-343EBA1D78DE}"/>
+                <a16:creationId xmlns:a16="http://schemas.microsoft.com/office/drawing/2014/main" xmlns="" id="{5FE508B0-6C5A-C9B0-FC6B-343EBA1D78DE}"/>
               </a:ext>
             </a:extLst>
           </p:cNvPr>
@@ -11023,7 +11045,7 @@
           <p:cNvPr id="6" name="Marcador de contenido 5">
             <a:extLst>
               <a:ext uri="{FF2B5EF4-FFF2-40B4-BE49-F238E27FC236}">
-                <a16:creationId xmlns:a16="http://schemas.microsoft.com/office/drawing/2014/main" id="{10B9C372-15AA-19D9-9B22-DB1573661A8F}"/>
+                <a16:creationId xmlns:a16="http://schemas.microsoft.com/office/drawing/2014/main" xmlns="" id="{10B9C372-15AA-19D9-9B22-DB1573661A8F}"/>
               </a:ext>
             </a:extLst>
           </p:cNvPr>
@@ -11086,7 +11108,7 @@
           <p:cNvPr id="7" name="Marcador de fecha 6">
             <a:extLst>
               <a:ext uri="{FF2B5EF4-FFF2-40B4-BE49-F238E27FC236}">
-                <a16:creationId xmlns:a16="http://schemas.microsoft.com/office/drawing/2014/main" id="{46408DFA-ED9B-85E0-43F4-D76EC22CA284}"/>
+                <a16:creationId xmlns:a16="http://schemas.microsoft.com/office/drawing/2014/main" xmlns="" id="{46408DFA-ED9B-85E0-43F4-D76EC22CA284}"/>
               </a:ext>
             </a:extLst>
           </p:cNvPr>
@@ -11104,7 +11126,7 @@
           <a:p>
             <a:fld id="{ABDDA2F0-ADA3-4A09-A4A4-0854B4A15306}" type="datetimeFigureOut">
               <a:rPr lang="es-MX" smtClean="0"/>
-              <a:t>07/10/2025</a:t>
+              <a:t>08/10/2025</a:t>
             </a:fld>
             <a:endParaRPr lang="es-MX"/>
           </a:p>
@@ -11115,7 +11137,7 @@
           <p:cNvPr id="8" name="Marcador de pie de página 7">
             <a:extLst>
               <a:ext uri="{FF2B5EF4-FFF2-40B4-BE49-F238E27FC236}">
-                <a16:creationId xmlns:a16="http://schemas.microsoft.com/office/drawing/2014/main" id="{B616F6DF-AA3E-072D-4717-93B1D48354DD}"/>
+                <a16:creationId xmlns:a16="http://schemas.microsoft.com/office/drawing/2014/main" xmlns="" id="{B616F6DF-AA3E-072D-4717-93B1D48354DD}"/>
               </a:ext>
             </a:extLst>
           </p:cNvPr>
@@ -11140,7 +11162,7 @@
           <p:cNvPr id="9" name="Marcador de número de diapositiva 8">
             <a:extLst>
               <a:ext uri="{FF2B5EF4-FFF2-40B4-BE49-F238E27FC236}">
-                <a16:creationId xmlns:a16="http://schemas.microsoft.com/office/drawing/2014/main" id="{09AB09DC-E5C6-7D7D-977D-8340C0737E4D}"/>
+                <a16:creationId xmlns:a16="http://schemas.microsoft.com/office/drawing/2014/main" xmlns="" id="{09AB09DC-E5C6-7D7D-977D-8340C0737E4D}"/>
               </a:ext>
             </a:extLst>
           </p:cNvPr>
@@ -11199,7 +11221,7 @@
           <p:cNvPr id="2" name="Título 1">
             <a:extLst>
               <a:ext uri="{FF2B5EF4-FFF2-40B4-BE49-F238E27FC236}">
-                <a16:creationId xmlns:a16="http://schemas.microsoft.com/office/drawing/2014/main" id="{08011C47-A5E1-52D3-713F-69DAB3CBE5A3}"/>
+                <a16:creationId xmlns:a16="http://schemas.microsoft.com/office/drawing/2014/main" xmlns="" id="{08011C47-A5E1-52D3-713F-69DAB3CBE5A3}"/>
               </a:ext>
             </a:extLst>
           </p:cNvPr>
@@ -11228,7 +11250,7 @@
           <p:cNvPr id="3" name="Marcador de fecha 2">
             <a:extLst>
               <a:ext uri="{FF2B5EF4-FFF2-40B4-BE49-F238E27FC236}">
-                <a16:creationId xmlns:a16="http://schemas.microsoft.com/office/drawing/2014/main" id="{1C518C19-B858-A8DC-36D3-86800D8685BC}"/>
+                <a16:creationId xmlns:a16="http://schemas.microsoft.com/office/drawing/2014/main" xmlns="" id="{1C518C19-B858-A8DC-36D3-86800D8685BC}"/>
               </a:ext>
             </a:extLst>
           </p:cNvPr>
@@ -11246,7 +11268,7 @@
           <a:p>
             <a:fld id="{ABDDA2F0-ADA3-4A09-A4A4-0854B4A15306}" type="datetimeFigureOut">
               <a:rPr lang="es-MX" smtClean="0"/>
-              <a:t>07/10/2025</a:t>
+              <a:t>08/10/2025</a:t>
             </a:fld>
             <a:endParaRPr lang="es-MX"/>
           </a:p>
@@ -11257,7 +11279,7 @@
           <p:cNvPr id="4" name="Marcador de pie de página 3">
             <a:extLst>
               <a:ext uri="{FF2B5EF4-FFF2-40B4-BE49-F238E27FC236}">
-                <a16:creationId xmlns:a16="http://schemas.microsoft.com/office/drawing/2014/main" id="{41F53B55-5D75-1FD8-7305-4050FDD68411}"/>
+                <a16:creationId xmlns:a16="http://schemas.microsoft.com/office/drawing/2014/main" xmlns="" id="{41F53B55-5D75-1FD8-7305-4050FDD68411}"/>
               </a:ext>
             </a:extLst>
           </p:cNvPr>
@@ -11282,7 +11304,7 @@
           <p:cNvPr id="5" name="Marcador de número de diapositiva 4">
             <a:extLst>
               <a:ext uri="{FF2B5EF4-FFF2-40B4-BE49-F238E27FC236}">
-                <a16:creationId xmlns:a16="http://schemas.microsoft.com/office/drawing/2014/main" id="{500FEE24-67A8-7C20-546D-BCEB3EEE2CC7}"/>
+                <a16:creationId xmlns:a16="http://schemas.microsoft.com/office/drawing/2014/main" xmlns="" id="{500FEE24-67A8-7C20-546D-BCEB3EEE2CC7}"/>
               </a:ext>
             </a:extLst>
           </p:cNvPr>
@@ -11341,7 +11363,7 @@
           <p:cNvPr id="2" name="Marcador de fecha 1">
             <a:extLst>
               <a:ext uri="{FF2B5EF4-FFF2-40B4-BE49-F238E27FC236}">
-                <a16:creationId xmlns:a16="http://schemas.microsoft.com/office/drawing/2014/main" id="{DE40A591-B9B4-C1D0-2520-DB39CAD388E6}"/>
+                <a16:creationId xmlns:a16="http://schemas.microsoft.com/office/drawing/2014/main" xmlns="" id="{DE40A591-B9B4-C1D0-2520-DB39CAD388E6}"/>
               </a:ext>
             </a:extLst>
           </p:cNvPr>
@@ -11359,7 +11381,7 @@
           <a:p>
             <a:fld id="{ABDDA2F0-ADA3-4A09-A4A4-0854B4A15306}" type="datetimeFigureOut">
               <a:rPr lang="es-MX" smtClean="0"/>
-              <a:t>07/10/2025</a:t>
+              <a:t>08/10/2025</a:t>
             </a:fld>
             <a:endParaRPr lang="es-MX"/>
           </a:p>
@@ -11370,7 +11392,7 @@
           <p:cNvPr id="3" name="Marcador de pie de página 2">
             <a:extLst>
               <a:ext uri="{FF2B5EF4-FFF2-40B4-BE49-F238E27FC236}">
-                <a16:creationId xmlns:a16="http://schemas.microsoft.com/office/drawing/2014/main" id="{59DB7BC8-513F-96E7-0F35-8CDD700E2FC2}"/>
+                <a16:creationId xmlns:a16="http://schemas.microsoft.com/office/drawing/2014/main" xmlns="" id="{59DB7BC8-513F-96E7-0F35-8CDD700E2FC2}"/>
               </a:ext>
             </a:extLst>
           </p:cNvPr>
@@ -11395,7 +11417,7 @@
           <p:cNvPr id="4" name="Marcador de número de diapositiva 3">
             <a:extLst>
               <a:ext uri="{FF2B5EF4-FFF2-40B4-BE49-F238E27FC236}">
-                <a16:creationId xmlns:a16="http://schemas.microsoft.com/office/drawing/2014/main" id="{7AE4AC45-E002-BEEB-8B8E-44514FE6BF11}"/>
+                <a16:creationId xmlns:a16="http://schemas.microsoft.com/office/drawing/2014/main" xmlns="" id="{7AE4AC45-E002-BEEB-8B8E-44514FE6BF11}"/>
               </a:ext>
             </a:extLst>
           </p:cNvPr>
@@ -11454,7 +11476,7 @@
           <p:cNvPr id="2" name="Título 1">
             <a:extLst>
               <a:ext uri="{FF2B5EF4-FFF2-40B4-BE49-F238E27FC236}">
-                <a16:creationId xmlns:a16="http://schemas.microsoft.com/office/drawing/2014/main" id="{A6FC0222-34BC-EBA6-7A21-952CD9074429}"/>
+                <a16:creationId xmlns:a16="http://schemas.microsoft.com/office/drawing/2014/main" xmlns="" id="{A6FC0222-34BC-EBA6-7A21-952CD9074429}"/>
               </a:ext>
             </a:extLst>
           </p:cNvPr>
@@ -11492,7 +11514,7 @@
           <p:cNvPr id="3" name="Marcador de contenido 2">
             <a:extLst>
               <a:ext uri="{FF2B5EF4-FFF2-40B4-BE49-F238E27FC236}">
-                <a16:creationId xmlns:a16="http://schemas.microsoft.com/office/drawing/2014/main" id="{1B2DED37-96F5-2838-76FF-E8FC4633590A}"/>
+                <a16:creationId xmlns:a16="http://schemas.microsoft.com/office/drawing/2014/main" xmlns="" id="{1B2DED37-96F5-2838-76FF-E8FC4633590A}"/>
               </a:ext>
             </a:extLst>
           </p:cNvPr>
@@ -11583,7 +11605,7 @@
           <p:cNvPr id="4" name="Marcador de texto 3">
             <a:extLst>
               <a:ext uri="{FF2B5EF4-FFF2-40B4-BE49-F238E27FC236}">
-                <a16:creationId xmlns:a16="http://schemas.microsoft.com/office/drawing/2014/main" id="{F7204234-1783-9477-4B7F-9E1C2285F215}"/>
+                <a16:creationId xmlns:a16="http://schemas.microsoft.com/office/drawing/2014/main" xmlns="" id="{F7204234-1783-9477-4B7F-9E1C2285F215}"/>
               </a:ext>
             </a:extLst>
           </p:cNvPr>
@@ -11654,7 +11676,7 @@
           <p:cNvPr id="5" name="Marcador de fecha 4">
             <a:extLst>
               <a:ext uri="{FF2B5EF4-FFF2-40B4-BE49-F238E27FC236}">
-                <a16:creationId xmlns:a16="http://schemas.microsoft.com/office/drawing/2014/main" id="{E4AB8F47-7E0B-AC5B-B99B-1397BBF4E1B0}"/>
+                <a16:creationId xmlns:a16="http://schemas.microsoft.com/office/drawing/2014/main" xmlns="" id="{E4AB8F47-7E0B-AC5B-B99B-1397BBF4E1B0}"/>
               </a:ext>
             </a:extLst>
           </p:cNvPr>
@@ -11672,7 +11694,7 @@
           <a:p>
             <a:fld id="{ABDDA2F0-ADA3-4A09-A4A4-0854B4A15306}" type="datetimeFigureOut">
               <a:rPr lang="es-MX" smtClean="0"/>
-              <a:t>07/10/2025</a:t>
+              <a:t>08/10/2025</a:t>
             </a:fld>
             <a:endParaRPr lang="es-MX"/>
           </a:p>
@@ -11683,7 +11705,7 @@
           <p:cNvPr id="6" name="Marcador de pie de página 5">
             <a:extLst>
               <a:ext uri="{FF2B5EF4-FFF2-40B4-BE49-F238E27FC236}">
-                <a16:creationId xmlns:a16="http://schemas.microsoft.com/office/drawing/2014/main" id="{27444E72-2B34-6E35-EB8C-540D1757191F}"/>
+                <a16:creationId xmlns:a16="http://schemas.microsoft.com/office/drawing/2014/main" xmlns="" id="{27444E72-2B34-6E35-EB8C-540D1757191F}"/>
               </a:ext>
             </a:extLst>
           </p:cNvPr>
@@ -11708,7 +11730,7 @@
           <p:cNvPr id="7" name="Marcador de número de diapositiva 6">
             <a:extLst>
               <a:ext uri="{FF2B5EF4-FFF2-40B4-BE49-F238E27FC236}">
-                <a16:creationId xmlns:a16="http://schemas.microsoft.com/office/drawing/2014/main" id="{BA0BA796-5219-8949-D532-E68CFCD5B791}"/>
+                <a16:creationId xmlns:a16="http://schemas.microsoft.com/office/drawing/2014/main" xmlns="" id="{BA0BA796-5219-8949-D532-E68CFCD5B791}"/>
               </a:ext>
             </a:extLst>
           </p:cNvPr>
@@ -11767,7 +11789,7 @@
           <p:cNvPr id="2" name="Título 1">
             <a:extLst>
               <a:ext uri="{FF2B5EF4-FFF2-40B4-BE49-F238E27FC236}">
-                <a16:creationId xmlns:a16="http://schemas.microsoft.com/office/drawing/2014/main" id="{DF931805-E0DF-1EF9-C110-CAC93E17C24B}"/>
+                <a16:creationId xmlns:a16="http://schemas.microsoft.com/office/drawing/2014/main" xmlns="" id="{DF931805-E0DF-1EF9-C110-CAC93E17C24B}"/>
               </a:ext>
             </a:extLst>
           </p:cNvPr>
@@ -11805,7 +11827,7 @@
           <p:cNvPr id="3" name="Marcador de posición de imagen 2">
             <a:extLst>
               <a:ext uri="{FF2B5EF4-FFF2-40B4-BE49-F238E27FC236}">
-                <a16:creationId xmlns:a16="http://schemas.microsoft.com/office/drawing/2014/main" id="{D13ACECD-8E37-357C-8FBF-04124CEBC472}"/>
+                <a16:creationId xmlns:a16="http://schemas.microsoft.com/office/drawing/2014/main" xmlns="" id="{D13ACECD-8E37-357C-8FBF-04124CEBC472}"/>
               </a:ext>
             </a:extLst>
           </p:cNvPr>
@@ -11872,7 +11894,7 @@
           <p:cNvPr id="4" name="Marcador de texto 3">
             <a:extLst>
               <a:ext uri="{FF2B5EF4-FFF2-40B4-BE49-F238E27FC236}">
-                <a16:creationId xmlns:a16="http://schemas.microsoft.com/office/drawing/2014/main" id="{A76933F9-CE62-7A51-2526-EF47F52B49CD}"/>
+                <a16:creationId xmlns:a16="http://schemas.microsoft.com/office/drawing/2014/main" xmlns="" id="{A76933F9-CE62-7A51-2526-EF47F52B49CD}"/>
               </a:ext>
             </a:extLst>
           </p:cNvPr>
@@ -11943,7 +11965,7 @@
           <p:cNvPr id="5" name="Marcador de fecha 4">
             <a:extLst>
               <a:ext uri="{FF2B5EF4-FFF2-40B4-BE49-F238E27FC236}">
-                <a16:creationId xmlns:a16="http://schemas.microsoft.com/office/drawing/2014/main" id="{61295AB3-0527-0650-4A5E-8E39C3FEBC5F}"/>
+                <a16:creationId xmlns:a16="http://schemas.microsoft.com/office/drawing/2014/main" xmlns="" id="{61295AB3-0527-0650-4A5E-8E39C3FEBC5F}"/>
               </a:ext>
             </a:extLst>
           </p:cNvPr>
@@ -11961,7 +11983,7 @@
           <a:p>
             <a:fld id="{ABDDA2F0-ADA3-4A09-A4A4-0854B4A15306}" type="datetimeFigureOut">
               <a:rPr lang="es-MX" smtClean="0"/>
-              <a:t>07/10/2025</a:t>
+              <a:t>08/10/2025</a:t>
             </a:fld>
             <a:endParaRPr lang="es-MX"/>
           </a:p>
@@ -11972,7 +11994,7 @@
           <p:cNvPr id="6" name="Marcador de pie de página 5">
             <a:extLst>
               <a:ext uri="{FF2B5EF4-FFF2-40B4-BE49-F238E27FC236}">
-                <a16:creationId xmlns:a16="http://schemas.microsoft.com/office/drawing/2014/main" id="{EC74B01D-04E3-41D7-9835-5139255EA9B1}"/>
+                <a16:creationId xmlns:a16="http://schemas.microsoft.com/office/drawing/2014/main" xmlns="" id="{EC74B01D-04E3-41D7-9835-5139255EA9B1}"/>
               </a:ext>
             </a:extLst>
           </p:cNvPr>
@@ -11997,7 +12019,7 @@
           <p:cNvPr id="7" name="Marcador de número de diapositiva 6">
             <a:extLst>
               <a:ext uri="{FF2B5EF4-FFF2-40B4-BE49-F238E27FC236}">
-                <a16:creationId xmlns:a16="http://schemas.microsoft.com/office/drawing/2014/main" id="{09D3E2DD-D6F1-4D4F-8C0B-D77DCA7B4F41}"/>
+                <a16:creationId xmlns:a16="http://schemas.microsoft.com/office/drawing/2014/main" xmlns="" id="{09D3E2DD-D6F1-4D4F-8C0B-D77DCA7B4F41}"/>
               </a:ext>
             </a:extLst>
           </p:cNvPr>
@@ -12061,7 +12083,7 @@
           <p:cNvPr id="2" name="Marcador de título 1">
             <a:extLst>
               <a:ext uri="{FF2B5EF4-FFF2-40B4-BE49-F238E27FC236}">
-                <a16:creationId xmlns:a16="http://schemas.microsoft.com/office/drawing/2014/main" id="{D700FFC7-6AF2-7718-31AD-61B3B9EAFA0E}"/>
+                <a16:creationId xmlns:a16="http://schemas.microsoft.com/office/drawing/2014/main" xmlns="" id="{D700FFC7-6AF2-7718-31AD-61B3B9EAFA0E}"/>
               </a:ext>
             </a:extLst>
           </p:cNvPr>
@@ -12100,7 +12122,7 @@
           <p:cNvPr id="3" name="Marcador de texto 2">
             <a:extLst>
               <a:ext uri="{FF2B5EF4-FFF2-40B4-BE49-F238E27FC236}">
-                <a16:creationId xmlns:a16="http://schemas.microsoft.com/office/drawing/2014/main" id="{D0845A47-E640-38C6-B77C-4374D64C3E73}"/>
+                <a16:creationId xmlns:a16="http://schemas.microsoft.com/office/drawing/2014/main" xmlns="" id="{D0845A47-E640-38C6-B77C-4374D64C3E73}"/>
               </a:ext>
             </a:extLst>
           </p:cNvPr>
@@ -12168,7 +12190,7 @@
           <p:cNvPr id="4" name="Marcador de fecha 3">
             <a:extLst>
               <a:ext uri="{FF2B5EF4-FFF2-40B4-BE49-F238E27FC236}">
-                <a16:creationId xmlns:a16="http://schemas.microsoft.com/office/drawing/2014/main" id="{BA621615-6EE4-8999-4974-FC8345B0F043}"/>
+                <a16:creationId xmlns:a16="http://schemas.microsoft.com/office/drawing/2014/main" xmlns="" id="{BA621615-6EE4-8999-4974-FC8345B0F043}"/>
               </a:ext>
             </a:extLst>
           </p:cNvPr>
@@ -12204,7 +12226,7 @@
           <a:p>
             <a:fld id="{ABDDA2F0-ADA3-4A09-A4A4-0854B4A15306}" type="datetimeFigureOut">
               <a:rPr lang="es-MX" smtClean="0"/>
-              <a:t>07/10/2025</a:t>
+              <a:t>08/10/2025</a:t>
             </a:fld>
             <a:endParaRPr lang="es-MX"/>
           </a:p>
@@ -12215,7 +12237,7 @@
           <p:cNvPr id="5" name="Marcador de pie de página 4">
             <a:extLst>
               <a:ext uri="{FF2B5EF4-FFF2-40B4-BE49-F238E27FC236}">
-                <a16:creationId xmlns:a16="http://schemas.microsoft.com/office/drawing/2014/main" id="{1453D141-D99F-08DF-89A5-CE133A10F331}"/>
+                <a16:creationId xmlns:a16="http://schemas.microsoft.com/office/drawing/2014/main" xmlns="" id="{1453D141-D99F-08DF-89A5-CE133A10F331}"/>
               </a:ext>
             </a:extLst>
           </p:cNvPr>
@@ -12258,7 +12280,7 @@
           <p:cNvPr id="6" name="Marcador de número de diapositiva 5">
             <a:extLst>
               <a:ext uri="{FF2B5EF4-FFF2-40B4-BE49-F238E27FC236}">
-                <a16:creationId xmlns:a16="http://schemas.microsoft.com/office/drawing/2014/main" id="{E4B33CF8-1115-CD03-F7AD-24C3565823E7}"/>
+                <a16:creationId xmlns:a16="http://schemas.microsoft.com/office/drawing/2014/main" xmlns="" id="{E4B33CF8-1115-CD03-F7AD-24C3565823E7}"/>
               </a:ext>
             </a:extLst>
           </p:cNvPr>
@@ -12626,7 +12648,7 @@
           <p:cNvPr id="2" name="Título 1">
             <a:extLst>
               <a:ext uri="{FF2B5EF4-FFF2-40B4-BE49-F238E27FC236}">
-                <a16:creationId xmlns:a16="http://schemas.microsoft.com/office/drawing/2014/main" id="{5EF8233C-F3DA-2ABC-9288-4BCD7433344C}"/>
+                <a16:creationId xmlns:a16="http://schemas.microsoft.com/office/drawing/2014/main" xmlns="" id="{5EF8233C-F3DA-2ABC-9288-4BCD7433344C}"/>
               </a:ext>
             </a:extLst>
           </p:cNvPr>
@@ -12701,7 +12723,7 @@
           <p:cNvPr id="3" name="Subtítulo 2">
             <a:extLst>
               <a:ext uri="{FF2B5EF4-FFF2-40B4-BE49-F238E27FC236}">
-                <a16:creationId xmlns:a16="http://schemas.microsoft.com/office/drawing/2014/main" id="{EC6C3CBE-087A-6EFC-794A-BF6D55DB7543}"/>
+                <a16:creationId xmlns:a16="http://schemas.microsoft.com/office/drawing/2014/main" xmlns="" id="{EC6C3CBE-087A-6EFC-794A-BF6D55DB7543}"/>
               </a:ext>
             </a:extLst>
           </p:cNvPr>
@@ -12720,47 +12742,55 @@
         </p:spPr>
         <p:txBody>
           <a:bodyPr>
-            <a:normAutofit fontScale="92500"/>
+            <a:normAutofit/>
           </a:bodyPr>
           <a:lstStyle/>
           <a:p>
             <a:r>
-              <a:rPr lang="es-MX" sz="3400" dirty="0">
+              <a:rPr lang="es-MX" sz="3400" dirty="0" smtClean="0">
                 <a:latin typeface="Times New Roman" panose="02020603050405020304" pitchFamily="18" charset="0"/>
                 <a:cs typeface="Times New Roman" panose="02020603050405020304" pitchFamily="18" charset="0"/>
               </a:rPr>
-              <a:t>Presentación técnica </a:t>
+              <a:t>Seminario técnico</a:t>
             </a:r>
+            <a:endParaRPr lang="es-MX" sz="3400" dirty="0">
+              <a:latin typeface="Times New Roman" panose="02020603050405020304" pitchFamily="18" charset="0"/>
+              <a:cs typeface="Times New Roman" panose="02020603050405020304" pitchFamily="18" charset="0"/>
+            </a:endParaRPr>
           </a:p>
           <a:p>
             <a:r>
-              <a:rPr lang="es-ES" sz="3400" dirty="0">
+              <a:rPr lang="es-ES" sz="3400" dirty="0" smtClean="0">
                 <a:latin typeface="Times New Roman" panose="02020603050405020304" pitchFamily="18" charset="0"/>
                 <a:cs typeface="Times New Roman" panose="02020603050405020304" pitchFamily="18" charset="0"/>
               </a:rPr>
-              <a:t>“Evaluación de la transferencia de calor en un MCS (SRM) en pruebas estáticas </a:t>
+              <a:t>Diseño y manufactura de motores cohete de </a:t>
             </a:r>
             <a:r>
-              <a:rPr lang="es-ES" sz="3400">
+              <a:rPr lang="es-ES" sz="3400" dirty="0" err="1" smtClean="0">
                 <a:latin typeface="Times New Roman" panose="02020603050405020304" pitchFamily="18" charset="0"/>
                 <a:cs typeface="Times New Roman" panose="02020603050405020304" pitchFamily="18" charset="0"/>
               </a:rPr>
-              <a:t>y en condiciones </a:t>
+              <a:t>propelente</a:t>
             </a:r>
             <a:r>
-              <a:rPr lang="es-ES" sz="3400" dirty="0">
+              <a:rPr lang="es-ES" sz="3400" dirty="0" smtClean="0">
                 <a:latin typeface="Times New Roman" panose="02020603050405020304" pitchFamily="18" charset="0"/>
                 <a:cs typeface="Times New Roman" panose="02020603050405020304" pitchFamily="18" charset="0"/>
               </a:rPr>
-              <a:t>de vuelo”</a:t>
+              <a:t> solido</a:t>
             </a:r>
             <a:r>
-              <a:rPr lang="es-MX" sz="3400" dirty="0">
+              <a:rPr lang="es-MX" sz="3400" dirty="0" smtClean="0">
                 <a:latin typeface="Times New Roman" panose="02020603050405020304" pitchFamily="18" charset="0"/>
                 <a:cs typeface="Times New Roman" panose="02020603050405020304" pitchFamily="18" charset="0"/>
               </a:rPr>
-              <a:t> </a:t>
+              <a:t> simples y en metal</a:t>
             </a:r>
+            <a:endParaRPr lang="es-MX" sz="3400" dirty="0">
+              <a:latin typeface="Times New Roman" panose="02020603050405020304" pitchFamily="18" charset="0"/>
+              <a:cs typeface="Times New Roman" panose="02020603050405020304" pitchFamily="18" charset="0"/>
+            </a:endParaRPr>
           </a:p>
         </p:txBody>
       </p:sp>
@@ -12769,7 +12799,7 @@
           <p:cNvPr id="12" name="Subtítulo 2">
             <a:extLst>
               <a:ext uri="{FF2B5EF4-FFF2-40B4-BE49-F238E27FC236}">
-                <a16:creationId xmlns:a16="http://schemas.microsoft.com/office/drawing/2014/main" id="{ECC718EC-22DC-2FC1-E7BF-660F4465FB20}"/>
+                <a16:creationId xmlns:a16="http://schemas.microsoft.com/office/drawing/2014/main" xmlns="" id="{ECC718EC-22DC-2FC1-E7BF-660F4465FB20}"/>
               </a:ext>
             </a:extLst>
           </p:cNvPr>
@@ -12972,7 +13002,7 @@
           <p:cNvPr id="1028" name="Picture 4" descr="Uanl vector logo - Uanl logo vector free download">
             <a:extLst>
               <a:ext uri="{FF2B5EF4-FFF2-40B4-BE49-F238E27FC236}">
-                <a16:creationId xmlns:a16="http://schemas.microsoft.com/office/drawing/2014/main" id="{A1EF89F4-4576-B62D-20F9-D2FF8A2E246A}"/>
+                <a16:creationId xmlns:a16="http://schemas.microsoft.com/office/drawing/2014/main" xmlns="" id="{A1EF89F4-4576-B62D-20F9-D2FF8A2E246A}"/>
               </a:ext>
             </a:extLst>
           </p:cNvPr>
@@ -13033,7 +13063,7 @@
             <p:cNvPr id="14" name="Grupo 13">
               <a:extLst>
                 <a:ext uri="{FF2B5EF4-FFF2-40B4-BE49-F238E27FC236}">
-                  <a16:creationId xmlns:a16="http://schemas.microsoft.com/office/drawing/2014/main" id="{7618CDC3-6984-FA21-1D90-EF5639665330}"/>
+                  <a16:creationId xmlns:a16="http://schemas.microsoft.com/office/drawing/2014/main" xmlns="" id="{7618CDC3-6984-FA21-1D90-EF5639665330}"/>
                 </a:ext>
               </a:extLst>
             </p:cNvPr>
@@ -13053,7 +13083,7 @@
               <p:cNvPr id="1034" name="Picture 10" descr="Universidad Autónoma de Nuevo León">
                 <a:extLst>
                   <a:ext uri="{FF2B5EF4-FFF2-40B4-BE49-F238E27FC236}">
-                    <a16:creationId xmlns:a16="http://schemas.microsoft.com/office/drawing/2014/main" id="{614962FF-F8BC-8C60-D531-371C411ED902}"/>
+                    <a16:creationId xmlns:a16="http://schemas.microsoft.com/office/drawing/2014/main" xmlns="" id="{614962FF-F8BC-8C60-D531-371C411ED902}"/>
                   </a:ext>
                 </a:extLst>
               </p:cNvPr>
@@ -13100,7 +13130,7 @@
               <p:cNvPr id="1036" name="Picture 12" descr="Fisico Matematico Logo Símbolos Coloridos De La Matemáticas 3d Stock">
                 <a:extLst>
                   <a:ext uri="{FF2B5EF4-FFF2-40B4-BE49-F238E27FC236}">
-                    <a16:creationId xmlns:a16="http://schemas.microsoft.com/office/drawing/2014/main" id="{9DCF93C1-4712-9517-4CC0-A6074B26C461}"/>
+                    <a16:creationId xmlns:a16="http://schemas.microsoft.com/office/drawing/2014/main" xmlns="" id="{9DCF93C1-4712-9517-4CC0-A6074B26C461}"/>
                   </a:ext>
                 </a:extLst>
               </p:cNvPr>
@@ -13193,7 +13223,7 @@
         <p:cNvPr id="1" name="">
           <a:extLst>
             <a:ext uri="{FF2B5EF4-FFF2-40B4-BE49-F238E27FC236}">
-              <a16:creationId xmlns:a16="http://schemas.microsoft.com/office/drawing/2014/main" id="{4D7F802C-9985-E39C-3166-A9DE4568D2F3}"/>
+              <a16:creationId xmlns:a16="http://schemas.microsoft.com/office/drawing/2014/main" xmlns="" id="{4D7F802C-9985-E39C-3166-A9DE4568D2F3}"/>
             </a:ext>
           </a:extLst>
         </p:cNvPr>
@@ -13213,7 +13243,7 @@
           <p:cNvPr id="2" name="Título 1">
             <a:extLst>
               <a:ext uri="{FF2B5EF4-FFF2-40B4-BE49-F238E27FC236}">
-                <a16:creationId xmlns:a16="http://schemas.microsoft.com/office/drawing/2014/main" id="{54661051-D6C8-5EF7-AE78-BC87B2E49557}"/>
+                <a16:creationId xmlns:a16="http://schemas.microsoft.com/office/drawing/2014/main" xmlns="" id="{54661051-D6C8-5EF7-AE78-BC87B2E49557}"/>
               </a:ext>
             </a:extLst>
           </p:cNvPr>
@@ -13248,7 +13278,7 @@
               <p:cNvPr id="3" name="Marcador de contenido 2">
                 <a:extLst>
                   <a:ext uri="{FF2B5EF4-FFF2-40B4-BE49-F238E27FC236}">
-                    <a16:creationId xmlns:a16="http://schemas.microsoft.com/office/drawing/2014/main" id="{46707DE8-11C3-8B57-F04C-4C7467D2ED0E}"/>
+                    <a16:creationId xmlns:a16="http://schemas.microsoft.com/office/drawing/2014/main" xmlns="" id="{46707DE8-11C3-8B57-F04C-4C7467D2ED0E}"/>
                   </a:ext>
                 </a:extLst>
               </p:cNvPr>
@@ -13795,7 +13825,7 @@
               <p:cNvPr id="4" name="Marcador de contenido 3">
                 <a:extLst>
                   <a:ext uri="{FF2B5EF4-FFF2-40B4-BE49-F238E27FC236}">
-                    <a16:creationId xmlns:a16="http://schemas.microsoft.com/office/drawing/2014/main" id="{E19B05D6-E926-16DE-FD81-C0A20F518F61}"/>
+                    <a16:creationId xmlns:a16="http://schemas.microsoft.com/office/drawing/2014/main" xmlns="" id="{E19B05D6-E926-16DE-FD81-C0A20F518F61}"/>
                   </a:ext>
                 </a:extLst>
               </p:cNvPr>
@@ -14700,7 +14730,7 @@
         <p:cNvPr id="1" name="">
           <a:extLst>
             <a:ext uri="{FF2B5EF4-FFF2-40B4-BE49-F238E27FC236}">
-              <a16:creationId xmlns:a16="http://schemas.microsoft.com/office/drawing/2014/main" id="{7C374489-8331-1CFD-B27B-DF0CF689C590}"/>
+              <a16:creationId xmlns:a16="http://schemas.microsoft.com/office/drawing/2014/main" xmlns="" id="{7C374489-8331-1CFD-B27B-DF0CF689C590}"/>
             </a:ext>
           </a:extLst>
         </p:cNvPr>
@@ -14720,7 +14750,7 @@
           <p:cNvPr id="2" name="Título 1">
             <a:extLst>
               <a:ext uri="{FF2B5EF4-FFF2-40B4-BE49-F238E27FC236}">
-                <a16:creationId xmlns:a16="http://schemas.microsoft.com/office/drawing/2014/main" id="{8ECDA3B6-5D21-455F-E26A-C1D0E028FFB1}"/>
+                <a16:creationId xmlns:a16="http://schemas.microsoft.com/office/drawing/2014/main" xmlns="" id="{8ECDA3B6-5D21-455F-E26A-C1D0E028FFB1}"/>
               </a:ext>
             </a:extLst>
           </p:cNvPr>
@@ -14753,7 +14783,7 @@
           <p:cNvPr id="12" name="Imagen 11">
             <a:extLst>
               <a:ext uri="{FF2B5EF4-FFF2-40B4-BE49-F238E27FC236}">
-                <a16:creationId xmlns:a16="http://schemas.microsoft.com/office/drawing/2014/main" id="{23D2F379-93E7-C9CE-5619-30DB95B49FB2}"/>
+                <a16:creationId xmlns:a16="http://schemas.microsoft.com/office/drawing/2014/main" xmlns="" id="{23D2F379-93E7-C9CE-5619-30DB95B49FB2}"/>
               </a:ext>
             </a:extLst>
           </p:cNvPr>
@@ -14783,7 +14813,7 @@
           <p:cNvPr id="13" name="CuadroTexto 12">
             <a:extLst>
               <a:ext uri="{FF2B5EF4-FFF2-40B4-BE49-F238E27FC236}">
-                <a16:creationId xmlns:a16="http://schemas.microsoft.com/office/drawing/2014/main" id="{F0821036-0DB9-2DFB-FC0B-B1828674F195}"/>
+                <a16:creationId xmlns:a16="http://schemas.microsoft.com/office/drawing/2014/main" xmlns="" id="{F0821036-0DB9-2DFB-FC0B-B1828674F195}"/>
               </a:ext>
             </a:extLst>
           </p:cNvPr>
@@ -14818,7 +14848,7 @@
           <p:cNvPr id="14" name="CuadroTexto 13">
             <a:extLst>
               <a:ext uri="{FF2B5EF4-FFF2-40B4-BE49-F238E27FC236}">
-                <a16:creationId xmlns:a16="http://schemas.microsoft.com/office/drawing/2014/main" id="{6F4A7D8F-58F3-B39F-60ED-ACEE03328BD1}"/>
+                <a16:creationId xmlns:a16="http://schemas.microsoft.com/office/drawing/2014/main" xmlns="" id="{6F4A7D8F-58F3-B39F-60ED-ACEE03328BD1}"/>
               </a:ext>
             </a:extLst>
           </p:cNvPr>
@@ -14877,7 +14907,7 @@
         <p:cNvPr id="1" name="">
           <a:extLst>
             <a:ext uri="{FF2B5EF4-FFF2-40B4-BE49-F238E27FC236}">
-              <a16:creationId xmlns:a16="http://schemas.microsoft.com/office/drawing/2014/main" id="{96916980-537E-4F36-DE1F-8C339DEFA61A}"/>
+              <a16:creationId xmlns:a16="http://schemas.microsoft.com/office/drawing/2014/main" xmlns="" id="{96916980-537E-4F36-DE1F-8C339DEFA61A}"/>
             </a:ext>
           </a:extLst>
         </p:cNvPr>
@@ -14897,7 +14927,7 @@
           <p:cNvPr id="2" name="Título 1">
             <a:extLst>
               <a:ext uri="{FF2B5EF4-FFF2-40B4-BE49-F238E27FC236}">
-                <a16:creationId xmlns:a16="http://schemas.microsoft.com/office/drawing/2014/main" id="{44448DF7-245D-58B1-5FD8-77845915E9DC}"/>
+                <a16:creationId xmlns:a16="http://schemas.microsoft.com/office/drawing/2014/main" xmlns="" id="{44448DF7-245D-58B1-5FD8-77845915E9DC}"/>
               </a:ext>
             </a:extLst>
           </p:cNvPr>
@@ -14932,7 +14962,7 @@
               <p:cNvPr id="3" name="Marcador de contenido 2">
                 <a:extLst>
                   <a:ext uri="{FF2B5EF4-FFF2-40B4-BE49-F238E27FC236}">
-                    <a16:creationId xmlns:a16="http://schemas.microsoft.com/office/drawing/2014/main" id="{22FCC1EE-000B-93B4-D8C4-8B112FC5E6F0}"/>
+                    <a16:creationId xmlns:a16="http://schemas.microsoft.com/office/drawing/2014/main" xmlns="" id="{22FCC1EE-000B-93B4-D8C4-8B112FC5E6F0}"/>
                   </a:ext>
                 </a:extLst>
               </p:cNvPr>
@@ -15124,7 +15154,7 @@
           <p:cNvPr id="5" name="Imagen 4">
             <a:extLst>
               <a:ext uri="{FF2B5EF4-FFF2-40B4-BE49-F238E27FC236}">
-                <a16:creationId xmlns:a16="http://schemas.microsoft.com/office/drawing/2014/main" id="{3154A138-58CC-81B6-506F-D38524745AD8}"/>
+                <a16:creationId xmlns:a16="http://schemas.microsoft.com/office/drawing/2014/main" xmlns="" id="{3154A138-58CC-81B6-506F-D38524745AD8}"/>
               </a:ext>
             </a:extLst>
           </p:cNvPr>
@@ -15154,7 +15184,7 @@
           <p:cNvPr id="8" name="Grupo 7">
             <a:extLst>
               <a:ext uri="{FF2B5EF4-FFF2-40B4-BE49-F238E27FC236}">
-                <a16:creationId xmlns:a16="http://schemas.microsoft.com/office/drawing/2014/main" id="{C20DA293-F6A0-7252-FF38-05022AFA986A}"/>
+                <a16:creationId xmlns:a16="http://schemas.microsoft.com/office/drawing/2014/main" xmlns="" id="{C20DA293-F6A0-7252-FF38-05022AFA986A}"/>
               </a:ext>
             </a:extLst>
           </p:cNvPr>
@@ -15174,7 +15204,7 @@
             <p:cNvPr id="6" name="Elipse 5">
               <a:extLst>
                 <a:ext uri="{FF2B5EF4-FFF2-40B4-BE49-F238E27FC236}">
-                  <a16:creationId xmlns:a16="http://schemas.microsoft.com/office/drawing/2014/main" id="{F36C48D9-E20B-4E74-7BB8-68534A2217D7}"/>
+                  <a16:creationId xmlns:a16="http://schemas.microsoft.com/office/drawing/2014/main" xmlns="" id="{F36C48D9-E20B-4E74-7BB8-68534A2217D7}"/>
                 </a:ext>
               </a:extLst>
             </p:cNvPr>
@@ -15226,7 +15256,7 @@
             <p:cNvPr id="7" name="Elipse 6">
               <a:extLst>
                 <a:ext uri="{FF2B5EF4-FFF2-40B4-BE49-F238E27FC236}">
-                  <a16:creationId xmlns:a16="http://schemas.microsoft.com/office/drawing/2014/main" id="{F78D14EC-7BE1-CCC8-AF03-B9A7D44E6E42}"/>
+                  <a16:creationId xmlns:a16="http://schemas.microsoft.com/office/drawing/2014/main" xmlns="" id="{F78D14EC-7BE1-CCC8-AF03-B9A7D44E6E42}"/>
                 </a:ext>
               </a:extLst>
             </p:cNvPr>
@@ -15276,7 +15306,7 @@
           <p:cNvPr id="16" name="Grupo 15">
             <a:extLst>
               <a:ext uri="{FF2B5EF4-FFF2-40B4-BE49-F238E27FC236}">
-                <a16:creationId xmlns:a16="http://schemas.microsoft.com/office/drawing/2014/main" id="{D66C3BD7-8A9B-3D45-8BB7-2E1E3AE64D47}"/>
+                <a16:creationId xmlns:a16="http://schemas.microsoft.com/office/drawing/2014/main" xmlns="" id="{D66C3BD7-8A9B-3D45-8BB7-2E1E3AE64D47}"/>
               </a:ext>
             </a:extLst>
           </p:cNvPr>
@@ -15296,7 +15326,7 @@
             <p:cNvPr id="9" name="Grupo 8">
               <a:extLst>
                 <a:ext uri="{FF2B5EF4-FFF2-40B4-BE49-F238E27FC236}">
-                  <a16:creationId xmlns:a16="http://schemas.microsoft.com/office/drawing/2014/main" id="{FB0680F6-606C-DACE-C857-C0E097108A5B}"/>
+                  <a16:creationId xmlns:a16="http://schemas.microsoft.com/office/drawing/2014/main" xmlns="" id="{FB0680F6-606C-DACE-C857-C0E097108A5B}"/>
                 </a:ext>
               </a:extLst>
             </p:cNvPr>
@@ -15316,7 +15346,7 @@
               <p:cNvPr id="10" name="Elipse 9">
                 <a:extLst>
                   <a:ext uri="{FF2B5EF4-FFF2-40B4-BE49-F238E27FC236}">
-                    <a16:creationId xmlns:a16="http://schemas.microsoft.com/office/drawing/2014/main" id="{295B2FE9-4906-65BA-41C5-42E3FA2B9FDA}"/>
+                    <a16:creationId xmlns:a16="http://schemas.microsoft.com/office/drawing/2014/main" xmlns="" id="{295B2FE9-4906-65BA-41C5-42E3FA2B9FDA}"/>
                   </a:ext>
                 </a:extLst>
               </p:cNvPr>
@@ -15368,7 +15398,7 @@
               <p:cNvPr id="11" name="Elipse 10">
                 <a:extLst>
                   <a:ext uri="{FF2B5EF4-FFF2-40B4-BE49-F238E27FC236}">
-                    <a16:creationId xmlns:a16="http://schemas.microsoft.com/office/drawing/2014/main" id="{8B43B637-5983-1EE3-620E-83FE18829586}"/>
+                    <a16:creationId xmlns:a16="http://schemas.microsoft.com/office/drawing/2014/main" xmlns="" id="{8B43B637-5983-1EE3-620E-83FE18829586}"/>
                   </a:ext>
                 </a:extLst>
               </p:cNvPr>
@@ -15418,7 +15448,7 @@
             <p:cNvPr id="14" name="Elipse 13">
               <a:extLst>
                 <a:ext uri="{FF2B5EF4-FFF2-40B4-BE49-F238E27FC236}">
-                  <a16:creationId xmlns:a16="http://schemas.microsoft.com/office/drawing/2014/main" id="{4FAD522E-6176-96CF-3142-2F5D03892BBE}"/>
+                  <a16:creationId xmlns:a16="http://schemas.microsoft.com/office/drawing/2014/main" xmlns="" id="{4FAD522E-6176-96CF-3142-2F5D03892BBE}"/>
                 </a:ext>
               </a:extLst>
             </p:cNvPr>
@@ -15471,7 +15501,7 @@
           <p:cNvPr id="15" name="Elipse 14">
             <a:extLst>
               <a:ext uri="{FF2B5EF4-FFF2-40B4-BE49-F238E27FC236}">
-                <a16:creationId xmlns:a16="http://schemas.microsoft.com/office/drawing/2014/main" id="{12AE98A3-9730-A385-CBEC-390D09989E8F}"/>
+                <a16:creationId xmlns:a16="http://schemas.microsoft.com/office/drawing/2014/main" xmlns="" id="{12AE98A3-9730-A385-CBEC-390D09989E8F}"/>
               </a:ext>
             </a:extLst>
           </p:cNvPr>
@@ -15523,7 +15553,7 @@
           <p:cNvPr id="17" name="Elipse 16">
             <a:extLst>
               <a:ext uri="{FF2B5EF4-FFF2-40B4-BE49-F238E27FC236}">
-                <a16:creationId xmlns:a16="http://schemas.microsoft.com/office/drawing/2014/main" id="{CBFD50D6-894B-F004-DD30-A0F9B51F5780}"/>
+                <a16:creationId xmlns:a16="http://schemas.microsoft.com/office/drawing/2014/main" xmlns="" id="{CBFD50D6-894B-F004-DD30-A0F9B51F5780}"/>
               </a:ext>
             </a:extLst>
           </p:cNvPr>
@@ -15575,7 +15605,7 @@
           <p:cNvPr id="23" name="Grupo 22">
             <a:extLst>
               <a:ext uri="{FF2B5EF4-FFF2-40B4-BE49-F238E27FC236}">
-                <a16:creationId xmlns:a16="http://schemas.microsoft.com/office/drawing/2014/main" id="{612454BF-824F-1FC3-4A01-AF5398ACEA96}"/>
+                <a16:creationId xmlns:a16="http://schemas.microsoft.com/office/drawing/2014/main" xmlns="" id="{612454BF-824F-1FC3-4A01-AF5398ACEA96}"/>
               </a:ext>
             </a:extLst>
           </p:cNvPr>
@@ -15595,7 +15625,7 @@
             <p:cNvPr id="18" name="Rectángulo 17">
               <a:extLst>
                 <a:ext uri="{FF2B5EF4-FFF2-40B4-BE49-F238E27FC236}">
-                  <a16:creationId xmlns:a16="http://schemas.microsoft.com/office/drawing/2014/main" id="{9693F3AF-6A29-C251-9F91-87718945BA0E}"/>
+                  <a16:creationId xmlns:a16="http://schemas.microsoft.com/office/drawing/2014/main" xmlns="" id="{9693F3AF-6A29-C251-9F91-87718945BA0E}"/>
                 </a:ext>
               </a:extLst>
             </p:cNvPr>
@@ -15649,7 +15679,7 @@
             <p:cNvPr id="20" name="Rectángulo 19">
               <a:extLst>
                 <a:ext uri="{FF2B5EF4-FFF2-40B4-BE49-F238E27FC236}">
-                  <a16:creationId xmlns:a16="http://schemas.microsoft.com/office/drawing/2014/main" id="{E564E907-B303-A4E9-DBF3-305E17B230FE}"/>
+                  <a16:creationId xmlns:a16="http://schemas.microsoft.com/office/drawing/2014/main" xmlns="" id="{E564E907-B303-A4E9-DBF3-305E17B230FE}"/>
                 </a:ext>
               </a:extLst>
             </p:cNvPr>
@@ -15703,7 +15733,7 @@
             <p:cNvPr id="21" name="Rectángulo 20">
               <a:extLst>
                 <a:ext uri="{FF2B5EF4-FFF2-40B4-BE49-F238E27FC236}">
-                  <a16:creationId xmlns:a16="http://schemas.microsoft.com/office/drawing/2014/main" id="{EDA15384-A510-1544-C9CE-D2DCAC39911A}"/>
+                  <a16:creationId xmlns:a16="http://schemas.microsoft.com/office/drawing/2014/main" xmlns="" id="{EDA15384-A510-1544-C9CE-D2DCAC39911A}"/>
                 </a:ext>
               </a:extLst>
             </p:cNvPr>
@@ -15757,7 +15787,7 @@
             <p:cNvPr id="22" name="Rectángulo 21">
               <a:extLst>
                 <a:ext uri="{FF2B5EF4-FFF2-40B4-BE49-F238E27FC236}">
-                  <a16:creationId xmlns:a16="http://schemas.microsoft.com/office/drawing/2014/main" id="{2AF5DDF6-281B-417B-1299-032A02A21904}"/>
+                  <a16:creationId xmlns:a16="http://schemas.microsoft.com/office/drawing/2014/main" xmlns="" id="{2AF5DDF6-281B-417B-1299-032A02A21904}"/>
                 </a:ext>
               </a:extLst>
             </p:cNvPr>
@@ -15812,7 +15842,7 @@
           <p:cNvPr id="24" name="CuadroTexto 23">
             <a:extLst>
               <a:ext uri="{FF2B5EF4-FFF2-40B4-BE49-F238E27FC236}">
-                <a16:creationId xmlns:a16="http://schemas.microsoft.com/office/drawing/2014/main" id="{C44CD5A1-5962-3D7B-5621-0D9EAD6F17BD}"/>
+                <a16:creationId xmlns:a16="http://schemas.microsoft.com/office/drawing/2014/main" xmlns="" id="{C44CD5A1-5962-3D7B-5621-0D9EAD6F17BD}"/>
               </a:ext>
             </a:extLst>
           </p:cNvPr>
@@ -15851,7 +15881,7 @@
           <p:cNvPr id="25" name="CuadroTexto 24">
             <a:extLst>
               <a:ext uri="{FF2B5EF4-FFF2-40B4-BE49-F238E27FC236}">
-                <a16:creationId xmlns:a16="http://schemas.microsoft.com/office/drawing/2014/main" id="{455A544C-557B-8616-8C90-2C15053742F2}"/>
+                <a16:creationId xmlns:a16="http://schemas.microsoft.com/office/drawing/2014/main" xmlns="" id="{455A544C-557B-8616-8C90-2C15053742F2}"/>
               </a:ext>
             </a:extLst>
           </p:cNvPr>
@@ -15890,7 +15920,7 @@
           <p:cNvPr id="26" name="CuadroTexto 25">
             <a:extLst>
               <a:ext uri="{FF2B5EF4-FFF2-40B4-BE49-F238E27FC236}">
-                <a16:creationId xmlns:a16="http://schemas.microsoft.com/office/drawing/2014/main" id="{BA155C18-CE85-FA64-3421-BD20A62031AE}"/>
+                <a16:creationId xmlns:a16="http://schemas.microsoft.com/office/drawing/2014/main" xmlns="" id="{BA155C18-CE85-FA64-3421-BD20A62031AE}"/>
               </a:ext>
             </a:extLst>
           </p:cNvPr>
@@ -15929,7 +15959,7 @@
           <p:cNvPr id="27" name="CuadroTexto 26">
             <a:extLst>
               <a:ext uri="{FF2B5EF4-FFF2-40B4-BE49-F238E27FC236}">
-                <a16:creationId xmlns:a16="http://schemas.microsoft.com/office/drawing/2014/main" id="{76EE765D-7086-62AF-86FE-3039F821CEFC}"/>
+                <a16:creationId xmlns:a16="http://schemas.microsoft.com/office/drawing/2014/main" xmlns="" id="{76EE765D-7086-62AF-86FE-3039F821CEFC}"/>
               </a:ext>
             </a:extLst>
           </p:cNvPr>
@@ -15995,7 +16025,7 @@
         <p:cNvPr id="1" name="">
           <a:extLst>
             <a:ext uri="{FF2B5EF4-FFF2-40B4-BE49-F238E27FC236}">
-              <a16:creationId xmlns:a16="http://schemas.microsoft.com/office/drawing/2014/main" id="{FC37CF23-0FAC-907A-6008-F8DFBCF7DD3B}"/>
+              <a16:creationId xmlns:a16="http://schemas.microsoft.com/office/drawing/2014/main" xmlns="" id="{FC37CF23-0FAC-907A-6008-F8DFBCF7DD3B}"/>
             </a:ext>
           </a:extLst>
         </p:cNvPr>
@@ -16015,7 +16045,7 @@
           <p:cNvPr id="2" name="Título 1">
             <a:extLst>
               <a:ext uri="{FF2B5EF4-FFF2-40B4-BE49-F238E27FC236}">
-                <a16:creationId xmlns:a16="http://schemas.microsoft.com/office/drawing/2014/main" id="{E895940F-7496-C6DB-CF42-F5FB3B59DB42}"/>
+                <a16:creationId xmlns:a16="http://schemas.microsoft.com/office/drawing/2014/main" xmlns="" id="{E895940F-7496-C6DB-CF42-F5FB3B59DB42}"/>
               </a:ext>
             </a:extLst>
           </p:cNvPr>
@@ -16050,7 +16080,7 @@
               <p:cNvPr id="3" name="Marcador de contenido 2">
                 <a:extLst>
                   <a:ext uri="{FF2B5EF4-FFF2-40B4-BE49-F238E27FC236}">
-                    <a16:creationId xmlns:a16="http://schemas.microsoft.com/office/drawing/2014/main" id="{79A613D5-7D0F-EC06-12D0-9065AA7C307B}"/>
+                    <a16:creationId xmlns:a16="http://schemas.microsoft.com/office/drawing/2014/main" xmlns="" id="{79A613D5-7D0F-EC06-12D0-9065AA7C307B}"/>
                   </a:ext>
                 </a:extLst>
               </p:cNvPr>
@@ -16422,7 +16452,7 @@
           <p:cNvPr id="33" name="Grupo 32">
             <a:extLst>
               <a:ext uri="{FF2B5EF4-FFF2-40B4-BE49-F238E27FC236}">
-                <a16:creationId xmlns:a16="http://schemas.microsoft.com/office/drawing/2014/main" id="{729909A0-43AF-DCAD-8F35-1ECDFE9C2433}"/>
+                <a16:creationId xmlns:a16="http://schemas.microsoft.com/office/drawing/2014/main" xmlns="" id="{729909A0-43AF-DCAD-8F35-1ECDFE9C2433}"/>
               </a:ext>
             </a:extLst>
           </p:cNvPr>
@@ -16442,7 +16472,7 @@
             <p:cNvPr id="6" name="Grupo 5">
               <a:extLst>
                 <a:ext uri="{FF2B5EF4-FFF2-40B4-BE49-F238E27FC236}">
-                  <a16:creationId xmlns:a16="http://schemas.microsoft.com/office/drawing/2014/main" id="{C322A4B0-8410-32BE-3649-6DDB27EFFA0B}"/>
+                  <a16:creationId xmlns:a16="http://schemas.microsoft.com/office/drawing/2014/main" xmlns="" id="{C322A4B0-8410-32BE-3649-6DDB27EFFA0B}"/>
                 </a:ext>
               </a:extLst>
             </p:cNvPr>
@@ -16462,7 +16492,7 @@
               <p:cNvPr id="4" name="Elipse 3">
                 <a:extLst>
                   <a:ext uri="{FF2B5EF4-FFF2-40B4-BE49-F238E27FC236}">
-                    <a16:creationId xmlns:a16="http://schemas.microsoft.com/office/drawing/2014/main" id="{406CC21C-47A8-E918-EEEA-F86BB7F900F6}"/>
+                    <a16:creationId xmlns:a16="http://schemas.microsoft.com/office/drawing/2014/main" xmlns="" id="{406CC21C-47A8-E918-EEEA-F86BB7F900F6}"/>
                   </a:ext>
                 </a:extLst>
               </p:cNvPr>
@@ -16508,7 +16538,7 @@
               <p:cNvPr id="5" name="Elipse 4">
                 <a:extLst>
                   <a:ext uri="{FF2B5EF4-FFF2-40B4-BE49-F238E27FC236}">
-                    <a16:creationId xmlns:a16="http://schemas.microsoft.com/office/drawing/2014/main" id="{45A5DD1C-D040-6AA2-54D6-0DDF876E6DD1}"/>
+                    <a16:creationId xmlns:a16="http://schemas.microsoft.com/office/drawing/2014/main" xmlns="" id="{45A5DD1C-D040-6AA2-54D6-0DDF876E6DD1}"/>
                   </a:ext>
                 </a:extLst>
               </p:cNvPr>
@@ -16558,7 +16588,7 @@
             <p:cNvPr id="8" name="Conector recto 7">
               <a:extLst>
                 <a:ext uri="{FF2B5EF4-FFF2-40B4-BE49-F238E27FC236}">
-                  <a16:creationId xmlns:a16="http://schemas.microsoft.com/office/drawing/2014/main" id="{DBC34E55-DF1A-B3D3-AB7E-C0A405CFD042}"/>
+                  <a16:creationId xmlns:a16="http://schemas.microsoft.com/office/drawing/2014/main" xmlns="" id="{DBC34E55-DF1A-B3D3-AB7E-C0A405CFD042}"/>
                 </a:ext>
               </a:extLst>
             </p:cNvPr>
@@ -16603,7 +16633,7 @@
             <p:cNvPr id="9" name="Conector recto 8">
               <a:extLst>
                 <a:ext uri="{FF2B5EF4-FFF2-40B4-BE49-F238E27FC236}">
-                  <a16:creationId xmlns:a16="http://schemas.microsoft.com/office/drawing/2014/main" id="{1D3971AF-F728-520C-7A40-13249ABEE709}"/>
+                  <a16:creationId xmlns:a16="http://schemas.microsoft.com/office/drawing/2014/main" xmlns="" id="{1D3971AF-F728-520C-7A40-13249ABEE709}"/>
                 </a:ext>
               </a:extLst>
             </p:cNvPr>
@@ -16648,7 +16678,7 @@
             <p:cNvPr id="14" name="Conector recto 13">
               <a:extLst>
                 <a:ext uri="{FF2B5EF4-FFF2-40B4-BE49-F238E27FC236}">
-                  <a16:creationId xmlns:a16="http://schemas.microsoft.com/office/drawing/2014/main" id="{C2C340D0-7A17-7E3F-227D-AA53C49A33CA}"/>
+                  <a16:creationId xmlns:a16="http://schemas.microsoft.com/office/drawing/2014/main" xmlns="" id="{C2C340D0-7A17-7E3F-227D-AA53C49A33CA}"/>
                 </a:ext>
               </a:extLst>
             </p:cNvPr>
@@ -16693,7 +16723,7 @@
             <p:cNvPr id="17" name="Conector recto 16">
               <a:extLst>
                 <a:ext uri="{FF2B5EF4-FFF2-40B4-BE49-F238E27FC236}">
-                  <a16:creationId xmlns:a16="http://schemas.microsoft.com/office/drawing/2014/main" id="{9C6A866E-8E9D-E197-7C1F-4066849E880F}"/>
+                  <a16:creationId xmlns:a16="http://schemas.microsoft.com/office/drawing/2014/main" xmlns="" id="{9C6A866E-8E9D-E197-7C1F-4066849E880F}"/>
                 </a:ext>
               </a:extLst>
             </p:cNvPr>
@@ -16738,7 +16768,7 @@
             <p:cNvPr id="20" name="Conector recto 19">
               <a:extLst>
                 <a:ext uri="{FF2B5EF4-FFF2-40B4-BE49-F238E27FC236}">
-                  <a16:creationId xmlns:a16="http://schemas.microsoft.com/office/drawing/2014/main" id="{4B0F83E2-5093-6ACB-233C-1421186CF403}"/>
+                  <a16:creationId xmlns:a16="http://schemas.microsoft.com/office/drawing/2014/main" xmlns="" id="{4B0F83E2-5093-6ACB-233C-1421186CF403}"/>
                 </a:ext>
               </a:extLst>
             </p:cNvPr>
@@ -16782,7 +16812,7 @@
             <p:cNvPr id="25" name="Conector recto 24">
               <a:extLst>
                 <a:ext uri="{FF2B5EF4-FFF2-40B4-BE49-F238E27FC236}">
-                  <a16:creationId xmlns:a16="http://schemas.microsoft.com/office/drawing/2014/main" id="{88FFA493-5365-E1A4-1907-6EA3CBD9508C}"/>
+                  <a16:creationId xmlns:a16="http://schemas.microsoft.com/office/drawing/2014/main" xmlns="" id="{88FFA493-5365-E1A4-1907-6EA3CBD9508C}"/>
                 </a:ext>
               </a:extLst>
             </p:cNvPr>
@@ -16829,7 +16859,7 @@
               <p:cNvPr id="28" name="CuadroTexto 27">
                 <a:extLst>
                   <a:ext uri="{FF2B5EF4-FFF2-40B4-BE49-F238E27FC236}">
-                    <a16:creationId xmlns:a16="http://schemas.microsoft.com/office/drawing/2014/main" id="{114BFBBF-29B3-AAFC-A3E9-C0D72A4C4D73}"/>
+                    <a16:creationId xmlns:a16="http://schemas.microsoft.com/office/drawing/2014/main" xmlns="" id="{114BFBBF-29B3-AAFC-A3E9-C0D72A4C4D73}"/>
                   </a:ext>
                 </a:extLst>
               </p:cNvPr>
@@ -16956,7 +16986,7 @@
               <p:cNvPr id="29" name="CuadroTexto 28">
                 <a:extLst>
                   <a:ext uri="{FF2B5EF4-FFF2-40B4-BE49-F238E27FC236}">
-                    <a16:creationId xmlns:a16="http://schemas.microsoft.com/office/drawing/2014/main" id="{54CD28E3-2FB2-FAC5-695F-97F8FFFBA523}"/>
+                    <a16:creationId xmlns:a16="http://schemas.microsoft.com/office/drawing/2014/main" xmlns="" id="{54CD28E3-2FB2-FAC5-695F-97F8FFFBA523}"/>
                   </a:ext>
                 </a:extLst>
               </p:cNvPr>
@@ -17081,7 +17111,7 @@
           <p:cNvPr id="34" name="Rectángulo 33">
             <a:extLst>
               <a:ext uri="{FF2B5EF4-FFF2-40B4-BE49-F238E27FC236}">
-                <a16:creationId xmlns:a16="http://schemas.microsoft.com/office/drawing/2014/main" id="{F1C69102-67B9-D084-840B-0059C5A33502}"/>
+                <a16:creationId xmlns:a16="http://schemas.microsoft.com/office/drawing/2014/main" xmlns="" id="{F1C69102-67B9-D084-840B-0059C5A33502}"/>
               </a:ext>
             </a:extLst>
           </p:cNvPr>
@@ -17127,7 +17157,7 @@
           <p:cNvPr id="35" name="Conector recto 34">
             <a:extLst>
               <a:ext uri="{FF2B5EF4-FFF2-40B4-BE49-F238E27FC236}">
-                <a16:creationId xmlns:a16="http://schemas.microsoft.com/office/drawing/2014/main" id="{A66DBDFD-7922-25A0-2802-9BAB5211EA81}"/>
+                <a16:creationId xmlns:a16="http://schemas.microsoft.com/office/drawing/2014/main" xmlns="" id="{A66DBDFD-7922-25A0-2802-9BAB5211EA81}"/>
               </a:ext>
             </a:extLst>
           </p:cNvPr>
@@ -17171,7 +17201,7 @@
           <p:cNvPr id="38" name="Conector recto 37">
             <a:extLst>
               <a:ext uri="{FF2B5EF4-FFF2-40B4-BE49-F238E27FC236}">
-                <a16:creationId xmlns:a16="http://schemas.microsoft.com/office/drawing/2014/main" id="{E7EF7746-C4A0-B3AA-DB22-665BF5B5750B}"/>
+                <a16:creationId xmlns:a16="http://schemas.microsoft.com/office/drawing/2014/main" xmlns="" id="{E7EF7746-C4A0-B3AA-DB22-665BF5B5750B}"/>
               </a:ext>
             </a:extLst>
           </p:cNvPr>
@@ -17215,7 +17245,7 @@
           <p:cNvPr id="39" name="Conector recto 38">
             <a:extLst>
               <a:ext uri="{FF2B5EF4-FFF2-40B4-BE49-F238E27FC236}">
-                <a16:creationId xmlns:a16="http://schemas.microsoft.com/office/drawing/2014/main" id="{5CEC78D8-8B50-E361-9AE7-0C36E5DB32D5}"/>
+                <a16:creationId xmlns:a16="http://schemas.microsoft.com/office/drawing/2014/main" xmlns="" id="{5CEC78D8-8B50-E361-9AE7-0C36E5DB32D5}"/>
               </a:ext>
             </a:extLst>
           </p:cNvPr>
@@ -17261,7 +17291,7 @@
               <p:cNvPr id="43" name="CuadroTexto 42">
                 <a:extLst>
                   <a:ext uri="{FF2B5EF4-FFF2-40B4-BE49-F238E27FC236}">
-                    <a16:creationId xmlns:a16="http://schemas.microsoft.com/office/drawing/2014/main" id="{F8FC5420-2043-F36A-81C7-06A76704E7F1}"/>
+                    <a16:creationId xmlns:a16="http://schemas.microsoft.com/office/drawing/2014/main" xmlns="" id="{F8FC5420-2043-F36A-81C7-06A76704E7F1}"/>
                   </a:ext>
                 </a:extLst>
               </p:cNvPr>
@@ -17388,7 +17418,7 @@
               <p:cNvPr id="44" name="CuadroTexto 43">
                 <a:extLst>
                   <a:ext uri="{FF2B5EF4-FFF2-40B4-BE49-F238E27FC236}">
-                    <a16:creationId xmlns:a16="http://schemas.microsoft.com/office/drawing/2014/main" id="{CC727B9C-2147-12F8-D394-76D6C2AD971A}"/>
+                    <a16:creationId xmlns:a16="http://schemas.microsoft.com/office/drawing/2014/main" xmlns="" id="{CC727B9C-2147-12F8-D394-76D6C2AD971A}"/>
                   </a:ext>
                 </a:extLst>
               </p:cNvPr>
@@ -17771,7 +17801,7 @@
         <p:cNvPr id="1" name="">
           <a:extLst>
             <a:ext uri="{FF2B5EF4-FFF2-40B4-BE49-F238E27FC236}">
-              <a16:creationId xmlns:a16="http://schemas.microsoft.com/office/drawing/2014/main" id="{8236AFA5-78C1-B396-92A0-1491ABD70AE0}"/>
+              <a16:creationId xmlns:a16="http://schemas.microsoft.com/office/drawing/2014/main" xmlns="" id="{8236AFA5-78C1-B396-92A0-1491ABD70AE0}"/>
             </a:ext>
           </a:extLst>
         </p:cNvPr>
@@ -17791,7 +17821,7 @@
           <p:cNvPr id="2" name="Título 1">
             <a:extLst>
               <a:ext uri="{FF2B5EF4-FFF2-40B4-BE49-F238E27FC236}">
-                <a16:creationId xmlns:a16="http://schemas.microsoft.com/office/drawing/2014/main" id="{847D2639-CA01-9D90-EAEE-6FA119CC485F}"/>
+                <a16:creationId xmlns:a16="http://schemas.microsoft.com/office/drawing/2014/main" xmlns="" id="{847D2639-CA01-9D90-EAEE-6FA119CC485F}"/>
               </a:ext>
             </a:extLst>
           </p:cNvPr>
@@ -17826,7 +17856,7 @@
               <p:cNvPr id="3" name="Marcador de contenido 2">
                 <a:extLst>
                   <a:ext uri="{FF2B5EF4-FFF2-40B4-BE49-F238E27FC236}">
-                    <a16:creationId xmlns:a16="http://schemas.microsoft.com/office/drawing/2014/main" id="{4729AEC0-EA8F-DE0E-608A-99BC36065ABE}"/>
+                    <a16:creationId xmlns:a16="http://schemas.microsoft.com/office/drawing/2014/main" xmlns="" id="{4729AEC0-EA8F-DE0E-608A-99BC36065ABE}"/>
                   </a:ext>
                 </a:extLst>
               </p:cNvPr>
@@ -18401,7 +18431,7 @@
           <p:cNvPr id="33" name="Grupo 32">
             <a:extLst>
               <a:ext uri="{FF2B5EF4-FFF2-40B4-BE49-F238E27FC236}">
-                <a16:creationId xmlns:a16="http://schemas.microsoft.com/office/drawing/2014/main" id="{48A6B34F-2C3F-D991-200D-C98CC7F65B74}"/>
+                <a16:creationId xmlns:a16="http://schemas.microsoft.com/office/drawing/2014/main" xmlns="" id="{48A6B34F-2C3F-D991-200D-C98CC7F65B74}"/>
               </a:ext>
             </a:extLst>
           </p:cNvPr>
@@ -18421,7 +18451,7 @@
             <p:cNvPr id="6" name="Grupo 5">
               <a:extLst>
                 <a:ext uri="{FF2B5EF4-FFF2-40B4-BE49-F238E27FC236}">
-                  <a16:creationId xmlns:a16="http://schemas.microsoft.com/office/drawing/2014/main" id="{CAE1C86C-0495-CDE8-6EEE-0C2450ADDD06}"/>
+                  <a16:creationId xmlns:a16="http://schemas.microsoft.com/office/drawing/2014/main" xmlns="" id="{CAE1C86C-0495-CDE8-6EEE-0C2450ADDD06}"/>
                 </a:ext>
               </a:extLst>
             </p:cNvPr>
@@ -18441,7 +18471,7 @@
               <p:cNvPr id="4" name="Elipse 3">
                 <a:extLst>
                   <a:ext uri="{FF2B5EF4-FFF2-40B4-BE49-F238E27FC236}">
-                    <a16:creationId xmlns:a16="http://schemas.microsoft.com/office/drawing/2014/main" id="{619E826A-24D4-94FE-AAEE-1A6091242565}"/>
+                    <a16:creationId xmlns:a16="http://schemas.microsoft.com/office/drawing/2014/main" xmlns="" id="{619E826A-24D4-94FE-AAEE-1A6091242565}"/>
                   </a:ext>
                 </a:extLst>
               </p:cNvPr>
@@ -18487,7 +18517,7 @@
               <p:cNvPr id="5" name="Elipse 4">
                 <a:extLst>
                   <a:ext uri="{FF2B5EF4-FFF2-40B4-BE49-F238E27FC236}">
-                    <a16:creationId xmlns:a16="http://schemas.microsoft.com/office/drawing/2014/main" id="{33088DFD-AEE8-BAD1-B753-53A9612C4BD6}"/>
+                    <a16:creationId xmlns:a16="http://schemas.microsoft.com/office/drawing/2014/main" xmlns="" id="{33088DFD-AEE8-BAD1-B753-53A9612C4BD6}"/>
                   </a:ext>
                 </a:extLst>
               </p:cNvPr>
@@ -18537,7 +18567,7 @@
             <p:cNvPr id="8" name="Conector recto 7">
               <a:extLst>
                 <a:ext uri="{FF2B5EF4-FFF2-40B4-BE49-F238E27FC236}">
-                  <a16:creationId xmlns:a16="http://schemas.microsoft.com/office/drawing/2014/main" id="{296E30CB-B5EA-E569-5C77-857F0B1E1BFF}"/>
+                  <a16:creationId xmlns:a16="http://schemas.microsoft.com/office/drawing/2014/main" xmlns="" id="{296E30CB-B5EA-E569-5C77-857F0B1E1BFF}"/>
                 </a:ext>
               </a:extLst>
             </p:cNvPr>
@@ -18582,7 +18612,7 @@
             <p:cNvPr id="9" name="Conector recto 8">
               <a:extLst>
                 <a:ext uri="{FF2B5EF4-FFF2-40B4-BE49-F238E27FC236}">
-                  <a16:creationId xmlns:a16="http://schemas.microsoft.com/office/drawing/2014/main" id="{57F25721-136D-2222-4D07-F6C3714240AD}"/>
+                  <a16:creationId xmlns:a16="http://schemas.microsoft.com/office/drawing/2014/main" xmlns="" id="{57F25721-136D-2222-4D07-F6C3714240AD}"/>
                 </a:ext>
               </a:extLst>
             </p:cNvPr>
@@ -18627,7 +18657,7 @@
             <p:cNvPr id="14" name="Conector recto 13">
               <a:extLst>
                 <a:ext uri="{FF2B5EF4-FFF2-40B4-BE49-F238E27FC236}">
-                  <a16:creationId xmlns:a16="http://schemas.microsoft.com/office/drawing/2014/main" id="{8535C2CA-14F9-A2FF-CC2B-B3C44A143273}"/>
+                  <a16:creationId xmlns:a16="http://schemas.microsoft.com/office/drawing/2014/main" xmlns="" id="{8535C2CA-14F9-A2FF-CC2B-B3C44A143273}"/>
                 </a:ext>
               </a:extLst>
             </p:cNvPr>
@@ -18672,7 +18702,7 @@
             <p:cNvPr id="17" name="Conector recto 16">
               <a:extLst>
                 <a:ext uri="{FF2B5EF4-FFF2-40B4-BE49-F238E27FC236}">
-                  <a16:creationId xmlns:a16="http://schemas.microsoft.com/office/drawing/2014/main" id="{378EA80B-D2A2-AE2B-15BD-01469C9F79FC}"/>
+                  <a16:creationId xmlns:a16="http://schemas.microsoft.com/office/drawing/2014/main" xmlns="" id="{378EA80B-D2A2-AE2B-15BD-01469C9F79FC}"/>
                 </a:ext>
               </a:extLst>
             </p:cNvPr>
@@ -18717,7 +18747,7 @@
             <p:cNvPr id="20" name="Conector recto 19">
               <a:extLst>
                 <a:ext uri="{FF2B5EF4-FFF2-40B4-BE49-F238E27FC236}">
-                  <a16:creationId xmlns:a16="http://schemas.microsoft.com/office/drawing/2014/main" id="{C4E1B510-2FF6-CBF0-CAAF-BF790468063F}"/>
+                  <a16:creationId xmlns:a16="http://schemas.microsoft.com/office/drawing/2014/main" xmlns="" id="{C4E1B510-2FF6-CBF0-CAAF-BF790468063F}"/>
                 </a:ext>
               </a:extLst>
             </p:cNvPr>
@@ -18761,7 +18791,7 @@
             <p:cNvPr id="25" name="Conector recto 24">
               <a:extLst>
                 <a:ext uri="{FF2B5EF4-FFF2-40B4-BE49-F238E27FC236}">
-                  <a16:creationId xmlns:a16="http://schemas.microsoft.com/office/drawing/2014/main" id="{78861B87-697F-57C3-F3C4-F52CD7294C41}"/>
+                  <a16:creationId xmlns:a16="http://schemas.microsoft.com/office/drawing/2014/main" xmlns="" id="{78861B87-697F-57C3-F3C4-F52CD7294C41}"/>
                 </a:ext>
               </a:extLst>
             </p:cNvPr>
@@ -18808,7 +18838,7 @@
               <p:cNvPr id="28" name="CuadroTexto 27">
                 <a:extLst>
                   <a:ext uri="{FF2B5EF4-FFF2-40B4-BE49-F238E27FC236}">
-                    <a16:creationId xmlns:a16="http://schemas.microsoft.com/office/drawing/2014/main" id="{E53635F7-A349-E5DB-1283-028431B4881A}"/>
+                    <a16:creationId xmlns:a16="http://schemas.microsoft.com/office/drawing/2014/main" xmlns="" id="{E53635F7-A349-E5DB-1283-028431B4881A}"/>
                   </a:ext>
                 </a:extLst>
               </p:cNvPr>
@@ -18935,7 +18965,7 @@
               <p:cNvPr id="29" name="CuadroTexto 28">
                 <a:extLst>
                   <a:ext uri="{FF2B5EF4-FFF2-40B4-BE49-F238E27FC236}">
-                    <a16:creationId xmlns:a16="http://schemas.microsoft.com/office/drawing/2014/main" id="{43C872DB-553E-2FBC-6987-5E915F0F5712}"/>
+                    <a16:creationId xmlns:a16="http://schemas.microsoft.com/office/drawing/2014/main" xmlns="" id="{43C872DB-553E-2FBC-6987-5E915F0F5712}"/>
                   </a:ext>
                 </a:extLst>
               </p:cNvPr>
@@ -19060,7 +19090,7 @@
           <p:cNvPr id="34" name="Rectángulo 33">
             <a:extLst>
               <a:ext uri="{FF2B5EF4-FFF2-40B4-BE49-F238E27FC236}">
-                <a16:creationId xmlns:a16="http://schemas.microsoft.com/office/drawing/2014/main" id="{BD1D1DC0-6D4E-86A2-DF3E-52D95462AA36}"/>
+                <a16:creationId xmlns:a16="http://schemas.microsoft.com/office/drawing/2014/main" xmlns="" id="{BD1D1DC0-6D4E-86A2-DF3E-52D95462AA36}"/>
               </a:ext>
             </a:extLst>
           </p:cNvPr>
@@ -19106,7 +19136,7 @@
           <p:cNvPr id="35" name="Conector recto 34">
             <a:extLst>
               <a:ext uri="{FF2B5EF4-FFF2-40B4-BE49-F238E27FC236}">
-                <a16:creationId xmlns:a16="http://schemas.microsoft.com/office/drawing/2014/main" id="{AACD2680-7136-4104-7901-70530F891E36}"/>
+                <a16:creationId xmlns:a16="http://schemas.microsoft.com/office/drawing/2014/main" xmlns="" id="{AACD2680-7136-4104-7901-70530F891E36}"/>
               </a:ext>
             </a:extLst>
           </p:cNvPr>
@@ -19150,7 +19180,7 @@
           <p:cNvPr id="38" name="Conector recto 37">
             <a:extLst>
               <a:ext uri="{FF2B5EF4-FFF2-40B4-BE49-F238E27FC236}">
-                <a16:creationId xmlns:a16="http://schemas.microsoft.com/office/drawing/2014/main" id="{F554DE12-06EF-0677-439B-C5EAB4671027}"/>
+                <a16:creationId xmlns:a16="http://schemas.microsoft.com/office/drawing/2014/main" xmlns="" id="{F554DE12-06EF-0677-439B-C5EAB4671027}"/>
               </a:ext>
             </a:extLst>
           </p:cNvPr>
@@ -19194,7 +19224,7 @@
           <p:cNvPr id="39" name="Conector recto 38">
             <a:extLst>
               <a:ext uri="{FF2B5EF4-FFF2-40B4-BE49-F238E27FC236}">
-                <a16:creationId xmlns:a16="http://schemas.microsoft.com/office/drawing/2014/main" id="{A0F5EC36-DCCD-EC90-1DF2-60930C5C61B7}"/>
+                <a16:creationId xmlns:a16="http://schemas.microsoft.com/office/drawing/2014/main" xmlns="" id="{A0F5EC36-DCCD-EC90-1DF2-60930C5C61B7}"/>
               </a:ext>
             </a:extLst>
           </p:cNvPr>
@@ -19240,7 +19270,7 @@
               <p:cNvPr id="43" name="CuadroTexto 42">
                 <a:extLst>
                   <a:ext uri="{FF2B5EF4-FFF2-40B4-BE49-F238E27FC236}">
-                    <a16:creationId xmlns:a16="http://schemas.microsoft.com/office/drawing/2014/main" id="{ACFA556C-C2BA-157B-3729-D990E2A3C95E}"/>
+                    <a16:creationId xmlns:a16="http://schemas.microsoft.com/office/drawing/2014/main" xmlns="" id="{ACFA556C-C2BA-157B-3729-D990E2A3C95E}"/>
                   </a:ext>
                 </a:extLst>
               </p:cNvPr>
@@ -19367,7 +19397,7 @@
               <p:cNvPr id="44" name="CuadroTexto 43">
                 <a:extLst>
                   <a:ext uri="{FF2B5EF4-FFF2-40B4-BE49-F238E27FC236}">
-                    <a16:creationId xmlns:a16="http://schemas.microsoft.com/office/drawing/2014/main" id="{16988A87-F30C-FF89-FFA3-416CE2094286}"/>
+                    <a16:creationId xmlns:a16="http://schemas.microsoft.com/office/drawing/2014/main" xmlns="" id="{16988A87-F30C-FF89-FFA3-416CE2094286}"/>
                   </a:ext>
                 </a:extLst>
               </p:cNvPr>
@@ -19695,7 +19725,7 @@
         <p:cNvPr id="1" name="">
           <a:extLst>
             <a:ext uri="{FF2B5EF4-FFF2-40B4-BE49-F238E27FC236}">
-              <a16:creationId xmlns:a16="http://schemas.microsoft.com/office/drawing/2014/main" id="{3EE1A028-1138-C444-7482-74B232A83DC6}"/>
+              <a16:creationId xmlns:a16="http://schemas.microsoft.com/office/drawing/2014/main" xmlns="" id="{3EE1A028-1138-C444-7482-74B232A83DC6}"/>
             </a:ext>
           </a:extLst>
         </p:cNvPr>
@@ -19715,7 +19745,7 @@
           <p:cNvPr id="2" name="Título 1">
             <a:extLst>
               <a:ext uri="{FF2B5EF4-FFF2-40B4-BE49-F238E27FC236}">
-                <a16:creationId xmlns:a16="http://schemas.microsoft.com/office/drawing/2014/main" id="{B1554601-AC38-C717-7D39-E7B3415308F2}"/>
+                <a16:creationId xmlns:a16="http://schemas.microsoft.com/office/drawing/2014/main" xmlns="" id="{B1554601-AC38-C717-7D39-E7B3415308F2}"/>
               </a:ext>
             </a:extLst>
           </p:cNvPr>
@@ -19750,7 +19780,7 @@
               <p:cNvPr id="3" name="Marcador de contenido 2">
                 <a:extLst>
                   <a:ext uri="{FF2B5EF4-FFF2-40B4-BE49-F238E27FC236}">
-                    <a16:creationId xmlns:a16="http://schemas.microsoft.com/office/drawing/2014/main" id="{32DBFBD8-0BE6-7BF5-E76B-6672EF6CD383}"/>
+                    <a16:creationId xmlns:a16="http://schemas.microsoft.com/office/drawing/2014/main" xmlns="" id="{32DBFBD8-0BE6-7BF5-E76B-6672EF6CD383}"/>
                   </a:ext>
                 </a:extLst>
               </p:cNvPr>
@@ -19976,7 +20006,7 @@
           <p:cNvPr id="48" name="Grupo 47">
             <a:extLst>
               <a:ext uri="{FF2B5EF4-FFF2-40B4-BE49-F238E27FC236}">
-                <a16:creationId xmlns:a16="http://schemas.microsoft.com/office/drawing/2014/main" id="{A6E9F6B6-0E0E-009F-1588-108C84CDB06A}"/>
+                <a16:creationId xmlns:a16="http://schemas.microsoft.com/office/drawing/2014/main" xmlns="" id="{A6E9F6B6-0E0E-009F-1588-108C84CDB06A}"/>
               </a:ext>
             </a:extLst>
           </p:cNvPr>
@@ -19996,7 +20026,7 @@
             <p:cNvPr id="11" name="Grupo 10">
               <a:extLst>
                 <a:ext uri="{FF2B5EF4-FFF2-40B4-BE49-F238E27FC236}">
-                  <a16:creationId xmlns:a16="http://schemas.microsoft.com/office/drawing/2014/main" id="{9CC24A00-877F-8DD3-84F3-31634A959DE5}"/>
+                  <a16:creationId xmlns:a16="http://schemas.microsoft.com/office/drawing/2014/main" xmlns="" id="{9CC24A00-877F-8DD3-84F3-31634A959DE5}"/>
                 </a:ext>
               </a:extLst>
             </p:cNvPr>
@@ -20016,7 +20046,7 @@
               <p:cNvPr id="7" name="Elipse 6">
                 <a:extLst>
                   <a:ext uri="{FF2B5EF4-FFF2-40B4-BE49-F238E27FC236}">
-                    <a16:creationId xmlns:a16="http://schemas.microsoft.com/office/drawing/2014/main" id="{683A4578-7D06-3414-BD0B-5C3118487E9D}"/>
+                    <a16:creationId xmlns:a16="http://schemas.microsoft.com/office/drawing/2014/main" xmlns="" id="{683A4578-7D06-3414-BD0B-5C3118487E9D}"/>
                   </a:ext>
                 </a:extLst>
               </p:cNvPr>
@@ -20068,7 +20098,7 @@
               <p:cNvPr id="10" name="Elipse 9">
                 <a:extLst>
                   <a:ext uri="{FF2B5EF4-FFF2-40B4-BE49-F238E27FC236}">
-                    <a16:creationId xmlns:a16="http://schemas.microsoft.com/office/drawing/2014/main" id="{9AC5537B-21E3-D703-8884-6D3A88A5DDD4}"/>
+                    <a16:creationId xmlns:a16="http://schemas.microsoft.com/office/drawing/2014/main" xmlns="" id="{9AC5537B-21E3-D703-8884-6D3A88A5DDD4}"/>
                   </a:ext>
                 </a:extLst>
               </p:cNvPr>
@@ -20118,7 +20148,7 @@
             <p:cNvPr id="13" name="Conector recto de flecha 12">
               <a:extLst>
                 <a:ext uri="{FF2B5EF4-FFF2-40B4-BE49-F238E27FC236}">
-                  <a16:creationId xmlns:a16="http://schemas.microsoft.com/office/drawing/2014/main" id="{C8318ADC-763C-743D-3DE6-FA95BE3096D1}"/>
+                  <a16:creationId xmlns:a16="http://schemas.microsoft.com/office/drawing/2014/main" xmlns="" id="{C8318ADC-763C-743D-3DE6-FA95BE3096D1}"/>
                 </a:ext>
               </a:extLst>
             </p:cNvPr>
@@ -20159,7 +20189,7 @@
             <p:cNvPr id="15" name="Conector recto de flecha 14">
               <a:extLst>
                 <a:ext uri="{FF2B5EF4-FFF2-40B4-BE49-F238E27FC236}">
-                  <a16:creationId xmlns:a16="http://schemas.microsoft.com/office/drawing/2014/main" id="{BDF186F1-5FA0-6A35-8735-B4DF89C27C8A}"/>
+                  <a16:creationId xmlns:a16="http://schemas.microsoft.com/office/drawing/2014/main" xmlns="" id="{BDF186F1-5FA0-6A35-8735-B4DF89C27C8A}"/>
                 </a:ext>
               </a:extLst>
             </p:cNvPr>
@@ -20200,7 +20230,7 @@
             <p:cNvPr id="19" name="Conector recto de flecha 18">
               <a:extLst>
                 <a:ext uri="{FF2B5EF4-FFF2-40B4-BE49-F238E27FC236}">
-                  <a16:creationId xmlns:a16="http://schemas.microsoft.com/office/drawing/2014/main" id="{2322A9E0-1674-6C04-0D36-385C2F322DC3}"/>
+                  <a16:creationId xmlns:a16="http://schemas.microsoft.com/office/drawing/2014/main" xmlns="" id="{2322A9E0-1674-6C04-0D36-385C2F322DC3}"/>
                 </a:ext>
               </a:extLst>
             </p:cNvPr>
@@ -20242,7 +20272,7 @@
             <p:cNvPr id="23" name="Conector recto de flecha 22">
               <a:extLst>
                 <a:ext uri="{FF2B5EF4-FFF2-40B4-BE49-F238E27FC236}">
-                  <a16:creationId xmlns:a16="http://schemas.microsoft.com/office/drawing/2014/main" id="{396F2035-2172-AF96-B6D9-053965EEB092}"/>
+                  <a16:creationId xmlns:a16="http://schemas.microsoft.com/office/drawing/2014/main" xmlns="" id="{396F2035-2172-AF96-B6D9-053965EEB092}"/>
                 </a:ext>
               </a:extLst>
             </p:cNvPr>
@@ -20284,7 +20314,7 @@
             <p:cNvPr id="27" name="Conector recto de flecha 26">
               <a:extLst>
                 <a:ext uri="{FF2B5EF4-FFF2-40B4-BE49-F238E27FC236}">
-                  <a16:creationId xmlns:a16="http://schemas.microsoft.com/office/drawing/2014/main" id="{D2FA65A6-12BF-F19B-F2D1-AC3E3044C4B5}"/>
+                  <a16:creationId xmlns:a16="http://schemas.microsoft.com/office/drawing/2014/main" xmlns="" id="{D2FA65A6-12BF-F19B-F2D1-AC3E3044C4B5}"/>
                 </a:ext>
               </a:extLst>
             </p:cNvPr>
@@ -20326,7 +20356,7 @@
             <p:cNvPr id="32" name="Conector recto de flecha 31">
               <a:extLst>
                 <a:ext uri="{FF2B5EF4-FFF2-40B4-BE49-F238E27FC236}">
-                  <a16:creationId xmlns:a16="http://schemas.microsoft.com/office/drawing/2014/main" id="{133649C1-BB8F-6B2B-D5C4-3B7D97EB40C4}"/>
+                  <a16:creationId xmlns:a16="http://schemas.microsoft.com/office/drawing/2014/main" xmlns="" id="{133649C1-BB8F-6B2B-D5C4-3B7D97EB40C4}"/>
                 </a:ext>
               </a:extLst>
             </p:cNvPr>
@@ -20368,7 +20398,7 @@
             <p:cNvPr id="40" name="Conector recto de flecha 39">
               <a:extLst>
                 <a:ext uri="{FF2B5EF4-FFF2-40B4-BE49-F238E27FC236}">
-                  <a16:creationId xmlns:a16="http://schemas.microsoft.com/office/drawing/2014/main" id="{C1E921D8-840D-B937-4486-1A0A5E56BD44}"/>
+                  <a16:creationId xmlns:a16="http://schemas.microsoft.com/office/drawing/2014/main" xmlns="" id="{C1E921D8-840D-B937-4486-1A0A5E56BD44}"/>
                 </a:ext>
               </a:extLst>
             </p:cNvPr>
@@ -20410,7 +20440,7 @@
             <p:cNvPr id="45" name="Conector recto de flecha 44">
               <a:extLst>
                 <a:ext uri="{FF2B5EF4-FFF2-40B4-BE49-F238E27FC236}">
-                  <a16:creationId xmlns:a16="http://schemas.microsoft.com/office/drawing/2014/main" id="{17C7A299-8885-D54C-0DAB-67B31ED4118F}"/>
+                  <a16:creationId xmlns:a16="http://schemas.microsoft.com/office/drawing/2014/main" xmlns="" id="{17C7A299-8885-D54C-0DAB-67B31ED4118F}"/>
                 </a:ext>
               </a:extLst>
             </p:cNvPr>
@@ -20453,7 +20483,7 @@
           <p:cNvPr id="49" name="Grupo 48">
             <a:extLst>
               <a:ext uri="{FF2B5EF4-FFF2-40B4-BE49-F238E27FC236}">
-                <a16:creationId xmlns:a16="http://schemas.microsoft.com/office/drawing/2014/main" id="{57D7CF8D-DCD2-4613-BF7C-52C07C597045}"/>
+                <a16:creationId xmlns:a16="http://schemas.microsoft.com/office/drawing/2014/main" xmlns="" id="{57D7CF8D-DCD2-4613-BF7C-52C07C597045}"/>
               </a:ext>
             </a:extLst>
           </p:cNvPr>
@@ -20473,7 +20503,7 @@
             <p:cNvPr id="50" name="Grupo 49">
               <a:extLst>
                 <a:ext uri="{FF2B5EF4-FFF2-40B4-BE49-F238E27FC236}">
-                  <a16:creationId xmlns:a16="http://schemas.microsoft.com/office/drawing/2014/main" id="{76FF5E40-DFC9-679E-2CCF-FC55CD7D751C}"/>
+                  <a16:creationId xmlns:a16="http://schemas.microsoft.com/office/drawing/2014/main" xmlns="" id="{76FF5E40-DFC9-679E-2CCF-FC55CD7D751C}"/>
                 </a:ext>
               </a:extLst>
             </p:cNvPr>
@@ -20493,7 +20523,7 @@
               <p:cNvPr id="59" name="Elipse 58">
                 <a:extLst>
                   <a:ext uri="{FF2B5EF4-FFF2-40B4-BE49-F238E27FC236}">
-                    <a16:creationId xmlns:a16="http://schemas.microsoft.com/office/drawing/2014/main" id="{03D95388-09F4-662D-9CAF-09C8CD8C5B58}"/>
+                    <a16:creationId xmlns:a16="http://schemas.microsoft.com/office/drawing/2014/main" xmlns="" id="{03D95388-09F4-662D-9CAF-09C8CD8C5B58}"/>
                   </a:ext>
                 </a:extLst>
               </p:cNvPr>
@@ -20550,7 +20580,7 @@
               <p:cNvPr id="60" name="Elipse 59">
                 <a:extLst>
                   <a:ext uri="{FF2B5EF4-FFF2-40B4-BE49-F238E27FC236}">
-                    <a16:creationId xmlns:a16="http://schemas.microsoft.com/office/drawing/2014/main" id="{DBB89719-3B13-6C15-BF86-D37DC770D5D2}"/>
+                    <a16:creationId xmlns:a16="http://schemas.microsoft.com/office/drawing/2014/main" xmlns="" id="{DBB89719-3B13-6C15-BF86-D37DC770D5D2}"/>
                   </a:ext>
                 </a:extLst>
               </p:cNvPr>
@@ -20600,7 +20630,7 @@
             <p:cNvPr id="51" name="Conector recto de flecha 50">
               <a:extLst>
                 <a:ext uri="{FF2B5EF4-FFF2-40B4-BE49-F238E27FC236}">
-                  <a16:creationId xmlns:a16="http://schemas.microsoft.com/office/drawing/2014/main" id="{C41CD6E7-1ADC-B33F-1385-631F88ADF285}"/>
+                  <a16:creationId xmlns:a16="http://schemas.microsoft.com/office/drawing/2014/main" xmlns="" id="{C41CD6E7-1ADC-B33F-1385-631F88ADF285}"/>
                 </a:ext>
               </a:extLst>
             </p:cNvPr>
@@ -20641,7 +20671,7 @@
             <p:cNvPr id="52" name="Conector recto de flecha 51">
               <a:extLst>
                 <a:ext uri="{FF2B5EF4-FFF2-40B4-BE49-F238E27FC236}">
-                  <a16:creationId xmlns:a16="http://schemas.microsoft.com/office/drawing/2014/main" id="{47254287-6AF5-2A49-27D4-BA9D4362C793}"/>
+                  <a16:creationId xmlns:a16="http://schemas.microsoft.com/office/drawing/2014/main" xmlns="" id="{47254287-6AF5-2A49-27D4-BA9D4362C793}"/>
                 </a:ext>
               </a:extLst>
             </p:cNvPr>
@@ -20682,7 +20712,7 @@
             <p:cNvPr id="53" name="Conector recto de flecha 52">
               <a:extLst>
                 <a:ext uri="{FF2B5EF4-FFF2-40B4-BE49-F238E27FC236}">
-                  <a16:creationId xmlns:a16="http://schemas.microsoft.com/office/drawing/2014/main" id="{ED52F063-804C-304E-4004-B1A35D450E98}"/>
+                  <a16:creationId xmlns:a16="http://schemas.microsoft.com/office/drawing/2014/main" xmlns="" id="{ED52F063-804C-304E-4004-B1A35D450E98}"/>
                 </a:ext>
               </a:extLst>
             </p:cNvPr>
@@ -20724,7 +20754,7 @@
             <p:cNvPr id="54" name="Conector recto de flecha 53">
               <a:extLst>
                 <a:ext uri="{FF2B5EF4-FFF2-40B4-BE49-F238E27FC236}">
-                  <a16:creationId xmlns:a16="http://schemas.microsoft.com/office/drawing/2014/main" id="{281AF653-3C47-2D75-BBA3-0DE0EEE6BFE7}"/>
+                  <a16:creationId xmlns:a16="http://schemas.microsoft.com/office/drawing/2014/main" xmlns="" id="{281AF653-3C47-2D75-BBA3-0DE0EEE6BFE7}"/>
                 </a:ext>
               </a:extLst>
             </p:cNvPr>
@@ -20766,7 +20796,7 @@
             <p:cNvPr id="55" name="Conector recto de flecha 54">
               <a:extLst>
                 <a:ext uri="{FF2B5EF4-FFF2-40B4-BE49-F238E27FC236}">
-                  <a16:creationId xmlns:a16="http://schemas.microsoft.com/office/drawing/2014/main" id="{1F7D575C-B1BC-15F6-611C-907C542D4A53}"/>
+                  <a16:creationId xmlns:a16="http://schemas.microsoft.com/office/drawing/2014/main" xmlns="" id="{1F7D575C-B1BC-15F6-611C-907C542D4A53}"/>
                 </a:ext>
               </a:extLst>
             </p:cNvPr>
@@ -20808,7 +20838,7 @@
             <p:cNvPr id="56" name="Conector recto de flecha 55">
               <a:extLst>
                 <a:ext uri="{FF2B5EF4-FFF2-40B4-BE49-F238E27FC236}">
-                  <a16:creationId xmlns:a16="http://schemas.microsoft.com/office/drawing/2014/main" id="{A5E1FB5E-4FDC-2AE0-894D-22C9E512B801}"/>
+                  <a16:creationId xmlns:a16="http://schemas.microsoft.com/office/drawing/2014/main" xmlns="" id="{A5E1FB5E-4FDC-2AE0-894D-22C9E512B801}"/>
                 </a:ext>
               </a:extLst>
             </p:cNvPr>
@@ -20850,7 +20880,7 @@
             <p:cNvPr id="57" name="Conector recto de flecha 56">
               <a:extLst>
                 <a:ext uri="{FF2B5EF4-FFF2-40B4-BE49-F238E27FC236}">
-                  <a16:creationId xmlns:a16="http://schemas.microsoft.com/office/drawing/2014/main" id="{98681D02-91E8-56AA-333C-205AEF6E173B}"/>
+                  <a16:creationId xmlns:a16="http://schemas.microsoft.com/office/drawing/2014/main" xmlns="" id="{98681D02-91E8-56AA-333C-205AEF6E173B}"/>
                 </a:ext>
               </a:extLst>
             </p:cNvPr>
@@ -20892,7 +20922,7 @@
             <p:cNvPr id="58" name="Conector recto de flecha 57">
               <a:extLst>
                 <a:ext uri="{FF2B5EF4-FFF2-40B4-BE49-F238E27FC236}">
-                  <a16:creationId xmlns:a16="http://schemas.microsoft.com/office/drawing/2014/main" id="{6698F533-9AC4-7E78-9A7E-F50427C0772E}"/>
+                  <a16:creationId xmlns:a16="http://schemas.microsoft.com/office/drawing/2014/main" xmlns="" id="{6698F533-9AC4-7E78-9A7E-F50427C0772E}"/>
                 </a:ext>
               </a:extLst>
             </p:cNvPr>
@@ -20937,7 +20967,7 @@
               <p14:cNvPr id="61" name="Entrada de lápiz 60">
                 <a:extLst>
                   <a:ext uri="{FF2B5EF4-FFF2-40B4-BE49-F238E27FC236}">
-                    <a16:creationId xmlns:a16="http://schemas.microsoft.com/office/drawing/2014/main" id="{5F606C9B-B813-AB27-A76A-B626235E29ED}"/>
+                    <a16:creationId xmlns:a16="http://schemas.microsoft.com/office/drawing/2014/main" xmlns="" id="{5F606C9B-B813-AB27-A76A-B626235E29ED}"/>
                   </a:ext>
                 </a:extLst>
               </p14:cNvPr>
@@ -20988,7 +21018,7 @@
               <p14:cNvPr id="62" name="Entrada de lápiz 61">
                 <a:extLst>
                   <a:ext uri="{FF2B5EF4-FFF2-40B4-BE49-F238E27FC236}">
-                    <a16:creationId xmlns:a16="http://schemas.microsoft.com/office/drawing/2014/main" id="{C8FBE21F-90F0-424D-96D2-4D4C55B2EFEA}"/>
+                    <a16:creationId xmlns:a16="http://schemas.microsoft.com/office/drawing/2014/main" xmlns="" id="{C8FBE21F-90F0-424D-96D2-4D4C55B2EFEA}"/>
                   </a:ext>
                 </a:extLst>
               </p14:cNvPr>
@@ -21039,7 +21069,7 @@
               <p14:cNvPr id="63" name="Entrada de lápiz 62">
                 <a:extLst>
                   <a:ext uri="{FF2B5EF4-FFF2-40B4-BE49-F238E27FC236}">
-                    <a16:creationId xmlns:a16="http://schemas.microsoft.com/office/drawing/2014/main" id="{46BE6239-16E2-2CE5-0C52-5A9D36C31885}"/>
+                    <a16:creationId xmlns:a16="http://schemas.microsoft.com/office/drawing/2014/main" xmlns="" id="{46BE6239-16E2-2CE5-0C52-5A9D36C31885}"/>
                   </a:ext>
                 </a:extLst>
               </p14:cNvPr>
@@ -21090,7 +21120,7 @@
               <p14:cNvPr id="64" name="Entrada de lápiz 63">
                 <a:extLst>
                   <a:ext uri="{FF2B5EF4-FFF2-40B4-BE49-F238E27FC236}">
-                    <a16:creationId xmlns:a16="http://schemas.microsoft.com/office/drawing/2014/main" id="{B8671239-130D-2A68-7100-ED048E868722}"/>
+                    <a16:creationId xmlns:a16="http://schemas.microsoft.com/office/drawing/2014/main" xmlns="" id="{B8671239-130D-2A68-7100-ED048E868722}"/>
                   </a:ext>
                 </a:extLst>
               </p14:cNvPr>
@@ -21141,7 +21171,7 @@
               <p14:cNvPr id="65" name="Entrada de lápiz 64">
                 <a:extLst>
                   <a:ext uri="{FF2B5EF4-FFF2-40B4-BE49-F238E27FC236}">
-                    <a16:creationId xmlns:a16="http://schemas.microsoft.com/office/drawing/2014/main" id="{EF3E710C-B0FF-769C-F352-740748E7AC2E}"/>
+                    <a16:creationId xmlns:a16="http://schemas.microsoft.com/office/drawing/2014/main" xmlns="" id="{EF3E710C-B0FF-769C-F352-740748E7AC2E}"/>
                   </a:ext>
                 </a:extLst>
               </p14:cNvPr>
@@ -21192,7 +21222,7 @@
               <p14:cNvPr id="68" name="Entrada de lápiz 67">
                 <a:extLst>
                   <a:ext uri="{FF2B5EF4-FFF2-40B4-BE49-F238E27FC236}">
-                    <a16:creationId xmlns:a16="http://schemas.microsoft.com/office/drawing/2014/main" id="{47249D8F-3481-1E1F-D6FD-EC295AF6678E}"/>
+                    <a16:creationId xmlns:a16="http://schemas.microsoft.com/office/drawing/2014/main" xmlns="" id="{47249D8F-3481-1E1F-D6FD-EC295AF6678E}"/>
                   </a:ext>
                 </a:extLst>
               </p14:cNvPr>
@@ -21243,7 +21273,7 @@
               <p14:cNvPr id="69" name="Entrada de lápiz 68">
                 <a:extLst>
                   <a:ext uri="{FF2B5EF4-FFF2-40B4-BE49-F238E27FC236}">
-                    <a16:creationId xmlns:a16="http://schemas.microsoft.com/office/drawing/2014/main" id="{EC6F2039-C493-4496-ACB0-D68C2C274874}"/>
+                    <a16:creationId xmlns:a16="http://schemas.microsoft.com/office/drawing/2014/main" xmlns="" id="{EC6F2039-C493-4496-ACB0-D68C2C274874}"/>
                   </a:ext>
                 </a:extLst>
               </p14:cNvPr>
@@ -21294,7 +21324,7 @@
               <p14:cNvPr id="70" name="Entrada de lápiz 69">
                 <a:extLst>
                   <a:ext uri="{FF2B5EF4-FFF2-40B4-BE49-F238E27FC236}">
-                    <a16:creationId xmlns:a16="http://schemas.microsoft.com/office/drawing/2014/main" id="{4D57B29B-5AEF-0C95-6B00-CB58F5AB5F02}"/>
+                    <a16:creationId xmlns:a16="http://schemas.microsoft.com/office/drawing/2014/main" xmlns="" id="{4D57B29B-5AEF-0C95-6B00-CB58F5AB5F02}"/>
                   </a:ext>
                 </a:extLst>
               </p14:cNvPr>
@@ -21343,7 +21373,7 @@
           <p:cNvPr id="74" name="Grupo 73">
             <a:extLst>
               <a:ext uri="{FF2B5EF4-FFF2-40B4-BE49-F238E27FC236}">
-                <a16:creationId xmlns:a16="http://schemas.microsoft.com/office/drawing/2014/main" id="{A78D307C-30B2-D673-F2E4-F0AFCA22E19D}"/>
+                <a16:creationId xmlns:a16="http://schemas.microsoft.com/office/drawing/2014/main" xmlns="" id="{A78D307C-30B2-D673-F2E4-F0AFCA22E19D}"/>
               </a:ext>
             </a:extLst>
           </p:cNvPr>
@@ -21365,7 +21395,7 @@
                 <p14:cNvPr id="71" name="Entrada de lápiz 70">
                   <a:extLst>
                     <a:ext uri="{FF2B5EF4-FFF2-40B4-BE49-F238E27FC236}">
-                      <a16:creationId xmlns:a16="http://schemas.microsoft.com/office/drawing/2014/main" id="{373C35D5-1983-AA44-264F-29D2A91B330E}"/>
+                      <a16:creationId xmlns:a16="http://schemas.microsoft.com/office/drawing/2014/main" xmlns="" id="{373C35D5-1983-AA44-264F-29D2A91B330E}"/>
                     </a:ext>
                   </a:extLst>
                 </p14:cNvPr>
@@ -21416,7 +21446,7 @@
                 <p14:cNvPr id="73" name="Entrada de lápiz 72">
                   <a:extLst>
                     <a:ext uri="{FF2B5EF4-FFF2-40B4-BE49-F238E27FC236}">
-                      <a16:creationId xmlns:a16="http://schemas.microsoft.com/office/drawing/2014/main" id="{30F477BA-A462-D9EE-981B-49EE431F66A0}"/>
+                      <a16:creationId xmlns:a16="http://schemas.microsoft.com/office/drawing/2014/main" xmlns="" id="{30F477BA-A462-D9EE-981B-49EE431F66A0}"/>
                     </a:ext>
                   </a:extLst>
                 </p14:cNvPr>
@@ -21468,7 +21498,7 @@
               <p14:cNvPr id="75" name="Entrada de lápiz 74">
                 <a:extLst>
                   <a:ext uri="{FF2B5EF4-FFF2-40B4-BE49-F238E27FC236}">
-                    <a16:creationId xmlns:a16="http://schemas.microsoft.com/office/drawing/2014/main" id="{A6468CA9-DFE5-6F02-6F52-950ED601FBFB}"/>
+                    <a16:creationId xmlns:a16="http://schemas.microsoft.com/office/drawing/2014/main" xmlns="" id="{A6468CA9-DFE5-6F02-6F52-950ED601FBFB}"/>
                   </a:ext>
                 </a:extLst>
               </p14:cNvPr>
@@ -21517,7 +21547,7 @@
           <p:cNvPr id="76" name="CuadroTexto 75">
             <a:extLst>
               <a:ext uri="{FF2B5EF4-FFF2-40B4-BE49-F238E27FC236}">
-                <a16:creationId xmlns:a16="http://schemas.microsoft.com/office/drawing/2014/main" id="{3001B39D-289F-3799-FE00-65CFAB18A7B8}"/>
+                <a16:creationId xmlns:a16="http://schemas.microsoft.com/office/drawing/2014/main" xmlns="" id="{3001B39D-289F-3799-FE00-65CFAB18A7B8}"/>
               </a:ext>
             </a:extLst>
           </p:cNvPr>
@@ -21552,7 +21582,7 @@
           <p:cNvPr id="77" name="CuadroTexto 76">
             <a:extLst>
               <a:ext uri="{FF2B5EF4-FFF2-40B4-BE49-F238E27FC236}">
-                <a16:creationId xmlns:a16="http://schemas.microsoft.com/office/drawing/2014/main" id="{A3949245-3422-5AAC-63E1-71FC5FE116AB}"/>
+                <a16:creationId xmlns:a16="http://schemas.microsoft.com/office/drawing/2014/main" xmlns="" id="{A3949245-3422-5AAC-63E1-71FC5FE116AB}"/>
               </a:ext>
             </a:extLst>
           </p:cNvPr>
@@ -21606,7 +21636,7 @@
         <p:cNvPr id="1" name="">
           <a:extLst>
             <a:ext uri="{FF2B5EF4-FFF2-40B4-BE49-F238E27FC236}">
-              <a16:creationId xmlns:a16="http://schemas.microsoft.com/office/drawing/2014/main" id="{8EF6E3A8-A20F-41FE-CE2F-E41CB9C719DD}"/>
+              <a16:creationId xmlns:a16="http://schemas.microsoft.com/office/drawing/2014/main" xmlns="" id="{8EF6E3A8-A20F-41FE-CE2F-E41CB9C719DD}"/>
             </a:ext>
           </a:extLst>
         </p:cNvPr>
@@ -21626,7 +21656,7 @@
           <p:cNvPr id="2" name="Título 1">
             <a:extLst>
               <a:ext uri="{FF2B5EF4-FFF2-40B4-BE49-F238E27FC236}">
-                <a16:creationId xmlns:a16="http://schemas.microsoft.com/office/drawing/2014/main" id="{C408B789-2790-FA25-6D7A-A13BCD2B733B}"/>
+                <a16:creationId xmlns:a16="http://schemas.microsoft.com/office/drawing/2014/main" xmlns="" id="{C408B789-2790-FA25-6D7A-A13BCD2B733B}"/>
               </a:ext>
             </a:extLst>
           </p:cNvPr>
@@ -21661,7 +21691,7 @@
               <p:cNvPr id="3" name="Marcador de contenido 2">
                 <a:extLst>
                   <a:ext uri="{FF2B5EF4-FFF2-40B4-BE49-F238E27FC236}">
-                    <a16:creationId xmlns:a16="http://schemas.microsoft.com/office/drawing/2014/main" id="{B77C90E1-E28C-17D2-D8CA-835C4E9D7B32}"/>
+                    <a16:creationId xmlns:a16="http://schemas.microsoft.com/office/drawing/2014/main" xmlns="" id="{B77C90E1-E28C-17D2-D8CA-835C4E9D7B32}"/>
                   </a:ext>
                 </a:extLst>
               </p:cNvPr>
@@ -21908,7 +21938,7 @@
           <p:cNvPr id="76" name="CuadroTexto 75">
             <a:extLst>
               <a:ext uri="{FF2B5EF4-FFF2-40B4-BE49-F238E27FC236}">
-                <a16:creationId xmlns:a16="http://schemas.microsoft.com/office/drawing/2014/main" id="{85341AD9-73AC-76AD-7FEF-A724F2954B92}"/>
+                <a16:creationId xmlns:a16="http://schemas.microsoft.com/office/drawing/2014/main" xmlns="" id="{85341AD9-73AC-76AD-7FEF-A724F2954B92}"/>
               </a:ext>
             </a:extLst>
           </p:cNvPr>
@@ -21943,7 +21973,7 @@
           <p:cNvPr id="5" name="Imagen 4">
             <a:extLst>
               <a:ext uri="{FF2B5EF4-FFF2-40B4-BE49-F238E27FC236}">
-                <a16:creationId xmlns:a16="http://schemas.microsoft.com/office/drawing/2014/main" id="{EC66955D-A453-81B3-6BF3-7070C457D9DE}"/>
+                <a16:creationId xmlns:a16="http://schemas.microsoft.com/office/drawing/2014/main" xmlns="" id="{EC66955D-A453-81B3-6BF3-7070C457D9DE}"/>
               </a:ext>
             </a:extLst>
           </p:cNvPr>
@@ -21972,7 +22002,7 @@
           <p:cNvPr id="8" name="Conector recto de flecha 7">
             <a:extLst>
               <a:ext uri="{FF2B5EF4-FFF2-40B4-BE49-F238E27FC236}">
-                <a16:creationId xmlns:a16="http://schemas.microsoft.com/office/drawing/2014/main" id="{FFE5B972-5CDF-8667-BE3C-0A1717D33741}"/>
+                <a16:creationId xmlns:a16="http://schemas.microsoft.com/office/drawing/2014/main" xmlns="" id="{FFE5B972-5CDF-8667-BE3C-0A1717D33741}"/>
               </a:ext>
             </a:extLst>
           </p:cNvPr>
@@ -22014,7 +22044,7 @@
           <p:cNvPr id="16" name="CuadroTexto 15">
             <a:extLst>
               <a:ext uri="{FF2B5EF4-FFF2-40B4-BE49-F238E27FC236}">
-                <a16:creationId xmlns:a16="http://schemas.microsoft.com/office/drawing/2014/main" id="{827B3C96-474D-1A78-A316-5C4556A1CFEE}"/>
+                <a16:creationId xmlns:a16="http://schemas.microsoft.com/office/drawing/2014/main" xmlns="" id="{827B3C96-474D-1A78-A316-5C4556A1CFEE}"/>
               </a:ext>
             </a:extLst>
           </p:cNvPr>
@@ -22056,7 +22086,7 @@
           <p:cNvPr id="21" name="Conector recto 20">
             <a:extLst>
               <a:ext uri="{FF2B5EF4-FFF2-40B4-BE49-F238E27FC236}">
-                <a16:creationId xmlns:a16="http://schemas.microsoft.com/office/drawing/2014/main" id="{A2A92B1B-C007-A2D7-0899-602898882524}"/>
+                <a16:creationId xmlns:a16="http://schemas.microsoft.com/office/drawing/2014/main" xmlns="" id="{A2A92B1B-C007-A2D7-0899-602898882524}"/>
               </a:ext>
             </a:extLst>
           </p:cNvPr>
@@ -22097,7 +22127,7 @@
           <p:cNvPr id="25" name="Conector recto 24">
             <a:extLst>
               <a:ext uri="{FF2B5EF4-FFF2-40B4-BE49-F238E27FC236}">
-                <a16:creationId xmlns:a16="http://schemas.microsoft.com/office/drawing/2014/main" id="{1123AA89-3ACE-A3FD-9840-7A5542544E54}"/>
+                <a16:creationId xmlns:a16="http://schemas.microsoft.com/office/drawing/2014/main" xmlns="" id="{1123AA89-3ACE-A3FD-9840-7A5542544E54}"/>
               </a:ext>
             </a:extLst>
           </p:cNvPr>
@@ -22138,7 +22168,7 @@
           <p:cNvPr id="26" name="Conector recto 25">
             <a:extLst>
               <a:ext uri="{FF2B5EF4-FFF2-40B4-BE49-F238E27FC236}">
-                <a16:creationId xmlns:a16="http://schemas.microsoft.com/office/drawing/2014/main" id="{45686287-9191-252C-4861-8E6A7EC50275}"/>
+                <a16:creationId xmlns:a16="http://schemas.microsoft.com/office/drawing/2014/main" xmlns="" id="{45686287-9191-252C-4861-8E6A7EC50275}"/>
               </a:ext>
             </a:extLst>
           </p:cNvPr>
@@ -22177,7 +22207,7 @@
           <p:cNvPr id="30" name="Conector recto 29">
             <a:extLst>
               <a:ext uri="{FF2B5EF4-FFF2-40B4-BE49-F238E27FC236}">
-                <a16:creationId xmlns:a16="http://schemas.microsoft.com/office/drawing/2014/main" id="{ED94BEE9-F032-116F-6106-0861FA8D6690}"/>
+                <a16:creationId xmlns:a16="http://schemas.microsoft.com/office/drawing/2014/main" xmlns="" id="{ED94BEE9-F032-116F-6106-0861FA8D6690}"/>
               </a:ext>
             </a:extLst>
           </p:cNvPr>
@@ -22232,7 +22262,7 @@
         <p:cNvPr id="1" name="">
           <a:extLst>
             <a:ext uri="{FF2B5EF4-FFF2-40B4-BE49-F238E27FC236}">
-              <a16:creationId xmlns:a16="http://schemas.microsoft.com/office/drawing/2014/main" id="{001FAEB8-235F-BFE3-6CF1-1EE0D5D2F79B}"/>
+              <a16:creationId xmlns:a16="http://schemas.microsoft.com/office/drawing/2014/main" xmlns="" id="{001FAEB8-235F-BFE3-6CF1-1EE0D5D2F79B}"/>
             </a:ext>
           </a:extLst>
         </p:cNvPr>
@@ -22252,7 +22282,7 @@
           <p:cNvPr id="2" name="Título 1">
             <a:extLst>
               <a:ext uri="{FF2B5EF4-FFF2-40B4-BE49-F238E27FC236}">
-                <a16:creationId xmlns:a16="http://schemas.microsoft.com/office/drawing/2014/main" id="{8BD85E92-E51D-1409-8BDE-695196A2F71A}"/>
+                <a16:creationId xmlns:a16="http://schemas.microsoft.com/office/drawing/2014/main" xmlns="" id="{8BD85E92-E51D-1409-8BDE-695196A2F71A}"/>
               </a:ext>
             </a:extLst>
           </p:cNvPr>
@@ -22285,7 +22315,7 @@
           <p:cNvPr id="3" name="Marcador de contenido 2">
             <a:extLst>
               <a:ext uri="{FF2B5EF4-FFF2-40B4-BE49-F238E27FC236}">
-                <a16:creationId xmlns:a16="http://schemas.microsoft.com/office/drawing/2014/main" id="{5DADD9D4-34ED-A09A-78DE-7B724CB5A8D8}"/>
+                <a16:creationId xmlns:a16="http://schemas.microsoft.com/office/drawing/2014/main" xmlns="" id="{5DADD9D4-34ED-A09A-78DE-7B724CB5A8D8}"/>
               </a:ext>
             </a:extLst>
           </p:cNvPr>
@@ -22328,7 +22358,7 @@
               <p:cNvPr id="10" name="CuadroTexto 9">
                 <a:extLst>
                   <a:ext uri="{FF2B5EF4-FFF2-40B4-BE49-F238E27FC236}">
-                    <a16:creationId xmlns:a16="http://schemas.microsoft.com/office/drawing/2014/main" id="{9E84CA75-77BD-A5E6-8789-CA11B68A5F3B}"/>
+                    <a16:creationId xmlns:a16="http://schemas.microsoft.com/office/drawing/2014/main" xmlns="" id="{9E84CA75-77BD-A5E6-8789-CA11B68A5F3B}"/>
                   </a:ext>
                 </a:extLst>
               </p:cNvPr>
@@ -23498,7 +23528,7 @@
           <p:cNvPr id="36" name="Grupo 35">
             <a:extLst>
               <a:ext uri="{FF2B5EF4-FFF2-40B4-BE49-F238E27FC236}">
-                <a16:creationId xmlns:a16="http://schemas.microsoft.com/office/drawing/2014/main" id="{0CB35D51-5F33-F9CC-8FA9-B719FA06D453}"/>
+                <a16:creationId xmlns:a16="http://schemas.microsoft.com/office/drawing/2014/main" xmlns="" id="{0CB35D51-5F33-F9CC-8FA9-B719FA06D453}"/>
               </a:ext>
             </a:extLst>
           </p:cNvPr>
@@ -23518,7 +23548,7 @@
             <p:cNvPr id="19" name="Grupo 18">
               <a:extLst>
                 <a:ext uri="{FF2B5EF4-FFF2-40B4-BE49-F238E27FC236}">
-                  <a16:creationId xmlns:a16="http://schemas.microsoft.com/office/drawing/2014/main" id="{50B02D32-675D-2262-13AE-6371A58BC9AA}"/>
+                  <a16:creationId xmlns:a16="http://schemas.microsoft.com/office/drawing/2014/main" xmlns="" id="{50B02D32-675D-2262-13AE-6371A58BC9AA}"/>
                 </a:ext>
               </a:extLst>
             </p:cNvPr>
@@ -23538,7 +23568,7 @@
               <p:cNvPr id="30" name="Elipse 29">
                 <a:extLst>
                   <a:ext uri="{FF2B5EF4-FFF2-40B4-BE49-F238E27FC236}">
-                    <a16:creationId xmlns:a16="http://schemas.microsoft.com/office/drawing/2014/main" id="{3D79C08D-A197-42D4-B28C-6E89E5FCEB0E}"/>
+                    <a16:creationId xmlns:a16="http://schemas.microsoft.com/office/drawing/2014/main" xmlns="" id="{3D79C08D-A197-42D4-B28C-6E89E5FCEB0E}"/>
                   </a:ext>
                 </a:extLst>
               </p:cNvPr>
@@ -23584,7 +23614,7 @@
               <p:cNvPr id="31" name="Elipse 30">
                 <a:extLst>
                   <a:ext uri="{FF2B5EF4-FFF2-40B4-BE49-F238E27FC236}">
-                    <a16:creationId xmlns:a16="http://schemas.microsoft.com/office/drawing/2014/main" id="{E9EB805D-62E6-9629-9E5D-FA936909AFF5}"/>
+                    <a16:creationId xmlns:a16="http://schemas.microsoft.com/office/drawing/2014/main" xmlns="" id="{E9EB805D-62E6-9629-9E5D-FA936909AFF5}"/>
                   </a:ext>
                 </a:extLst>
               </p:cNvPr>
@@ -23634,7 +23664,7 @@
             <p:cNvPr id="32" name="Rectángulo 31">
               <a:extLst>
                 <a:ext uri="{FF2B5EF4-FFF2-40B4-BE49-F238E27FC236}">
-                  <a16:creationId xmlns:a16="http://schemas.microsoft.com/office/drawing/2014/main" id="{4A573487-10CB-C0BE-89D2-5399693DDCBA}"/>
+                  <a16:creationId xmlns:a16="http://schemas.microsoft.com/office/drawing/2014/main" xmlns="" id="{4A573487-10CB-C0BE-89D2-5399693DDCBA}"/>
                 </a:ext>
               </a:extLst>
             </p:cNvPr>
@@ -23681,7 +23711,7 @@
           <p:cNvPr id="37" name="Grupo 36">
             <a:extLst>
               <a:ext uri="{FF2B5EF4-FFF2-40B4-BE49-F238E27FC236}">
-                <a16:creationId xmlns:a16="http://schemas.microsoft.com/office/drawing/2014/main" id="{39B1D98E-1049-2F22-16CA-7D13D1909A1C}"/>
+                <a16:creationId xmlns:a16="http://schemas.microsoft.com/office/drawing/2014/main" xmlns="" id="{39B1D98E-1049-2F22-16CA-7D13D1909A1C}"/>
               </a:ext>
             </a:extLst>
           </p:cNvPr>
@@ -23701,7 +23731,7 @@
             <p:cNvPr id="40" name="Grupo 39">
               <a:extLst>
                 <a:ext uri="{FF2B5EF4-FFF2-40B4-BE49-F238E27FC236}">
-                  <a16:creationId xmlns:a16="http://schemas.microsoft.com/office/drawing/2014/main" id="{12A34D48-24EC-0D66-0240-012CFB03DB74}"/>
+                  <a16:creationId xmlns:a16="http://schemas.microsoft.com/office/drawing/2014/main" xmlns="" id="{12A34D48-24EC-0D66-0240-012CFB03DB74}"/>
                 </a:ext>
               </a:extLst>
             </p:cNvPr>
@@ -23721,7 +23751,7 @@
               <p:cNvPr id="42" name="Elipse 41">
                 <a:extLst>
                   <a:ext uri="{FF2B5EF4-FFF2-40B4-BE49-F238E27FC236}">
-                    <a16:creationId xmlns:a16="http://schemas.microsoft.com/office/drawing/2014/main" id="{E224C2A6-F1F2-CC42-6167-D312CC4B4A5F}"/>
+                    <a16:creationId xmlns:a16="http://schemas.microsoft.com/office/drawing/2014/main" xmlns="" id="{E224C2A6-F1F2-CC42-6167-D312CC4B4A5F}"/>
                   </a:ext>
                 </a:extLst>
               </p:cNvPr>
@@ -23767,7 +23797,7 @@
               <p:cNvPr id="44" name="Elipse 43">
                 <a:extLst>
                   <a:ext uri="{FF2B5EF4-FFF2-40B4-BE49-F238E27FC236}">
-                    <a16:creationId xmlns:a16="http://schemas.microsoft.com/office/drawing/2014/main" id="{EC9E1C03-4AD3-1214-71F4-3A0462F71691}"/>
+                    <a16:creationId xmlns:a16="http://schemas.microsoft.com/office/drawing/2014/main" xmlns="" id="{EC9E1C03-4AD3-1214-71F4-3A0462F71691}"/>
                   </a:ext>
                 </a:extLst>
               </p:cNvPr>
@@ -23817,7 +23847,7 @@
             <p:cNvPr id="41" name="Rectángulo 40">
               <a:extLst>
                 <a:ext uri="{FF2B5EF4-FFF2-40B4-BE49-F238E27FC236}">
-                  <a16:creationId xmlns:a16="http://schemas.microsoft.com/office/drawing/2014/main" id="{09B92FA5-437B-93A7-7E92-94EE2A804412}"/>
+                  <a16:creationId xmlns:a16="http://schemas.microsoft.com/office/drawing/2014/main" xmlns="" id="{09B92FA5-437B-93A7-7E92-94EE2A804412}"/>
                 </a:ext>
               </a:extLst>
             </p:cNvPr>
@@ -23872,7 +23902,7 @@
           <p:cNvPr id="45" name="Grupo 44">
             <a:extLst>
               <a:ext uri="{FF2B5EF4-FFF2-40B4-BE49-F238E27FC236}">
-                <a16:creationId xmlns:a16="http://schemas.microsoft.com/office/drawing/2014/main" id="{6AB3828B-44F4-4A8C-3109-838F17D39E99}"/>
+                <a16:creationId xmlns:a16="http://schemas.microsoft.com/office/drawing/2014/main" xmlns="" id="{6AB3828B-44F4-4A8C-3109-838F17D39E99}"/>
               </a:ext>
             </a:extLst>
           </p:cNvPr>
@@ -23892,7 +23922,7 @@
             <p:cNvPr id="46" name="Grupo 45">
               <a:extLst>
                 <a:ext uri="{FF2B5EF4-FFF2-40B4-BE49-F238E27FC236}">
-                  <a16:creationId xmlns:a16="http://schemas.microsoft.com/office/drawing/2014/main" id="{D69BC071-721C-D409-2442-4A0447CB59A7}"/>
+                  <a16:creationId xmlns:a16="http://schemas.microsoft.com/office/drawing/2014/main" xmlns="" id="{D69BC071-721C-D409-2442-4A0447CB59A7}"/>
                 </a:ext>
               </a:extLst>
             </p:cNvPr>
@@ -23912,7 +23942,7 @@
               <p:cNvPr id="48" name="Elipse 47">
                 <a:extLst>
                   <a:ext uri="{FF2B5EF4-FFF2-40B4-BE49-F238E27FC236}">
-                    <a16:creationId xmlns:a16="http://schemas.microsoft.com/office/drawing/2014/main" id="{B1D7482B-3DC7-438F-184E-7B6D1F18E6FF}"/>
+                    <a16:creationId xmlns:a16="http://schemas.microsoft.com/office/drawing/2014/main" xmlns="" id="{B1D7482B-3DC7-438F-184E-7B6D1F18E6FF}"/>
                   </a:ext>
                 </a:extLst>
               </p:cNvPr>
@@ -23961,7 +23991,7 @@
               <p:cNvPr id="49" name="Elipse 48">
                 <a:extLst>
                   <a:ext uri="{FF2B5EF4-FFF2-40B4-BE49-F238E27FC236}">
-                    <a16:creationId xmlns:a16="http://schemas.microsoft.com/office/drawing/2014/main" id="{4D7D1C7A-581A-9D58-9132-F50D66C1DE3E}"/>
+                    <a16:creationId xmlns:a16="http://schemas.microsoft.com/office/drawing/2014/main" xmlns="" id="{4D7D1C7A-581A-9D58-9132-F50D66C1DE3E}"/>
                   </a:ext>
                 </a:extLst>
               </p:cNvPr>
@@ -24011,7 +24041,7 @@
             <p:cNvPr id="47" name="Rectángulo 46">
               <a:extLst>
                 <a:ext uri="{FF2B5EF4-FFF2-40B4-BE49-F238E27FC236}">
-                  <a16:creationId xmlns:a16="http://schemas.microsoft.com/office/drawing/2014/main" id="{1D3A0EF4-1FE8-E0A9-85AD-B9C5B4FDF4CF}"/>
+                  <a16:creationId xmlns:a16="http://schemas.microsoft.com/office/drawing/2014/main" xmlns="" id="{1D3A0EF4-1FE8-E0A9-85AD-B9C5B4FDF4CF}"/>
                 </a:ext>
               </a:extLst>
             </p:cNvPr>
@@ -24058,7 +24088,7 @@
           <p:cNvPr id="50" name="Elipse 49">
             <a:extLst>
               <a:ext uri="{FF2B5EF4-FFF2-40B4-BE49-F238E27FC236}">
-                <a16:creationId xmlns:a16="http://schemas.microsoft.com/office/drawing/2014/main" id="{071A2876-B523-6A0B-72FE-3AE7AB51CE42}"/>
+                <a16:creationId xmlns:a16="http://schemas.microsoft.com/office/drawing/2014/main" xmlns="" id="{071A2876-B523-6A0B-72FE-3AE7AB51CE42}"/>
               </a:ext>
             </a:extLst>
           </p:cNvPr>
@@ -24119,7 +24149,7 @@
           <p:cNvPr id="51" name="Elipse 50">
             <a:extLst>
               <a:ext uri="{FF2B5EF4-FFF2-40B4-BE49-F238E27FC236}">
-                <a16:creationId xmlns:a16="http://schemas.microsoft.com/office/drawing/2014/main" id="{3276C69E-EF12-912E-0644-AB781765031D}"/>
+                <a16:creationId xmlns:a16="http://schemas.microsoft.com/office/drawing/2014/main" xmlns="" id="{3276C69E-EF12-912E-0644-AB781765031D}"/>
               </a:ext>
             </a:extLst>
           </p:cNvPr>
@@ -24180,7 +24210,7 @@
           <p:cNvPr id="52" name="Elipse 51">
             <a:extLst>
               <a:ext uri="{FF2B5EF4-FFF2-40B4-BE49-F238E27FC236}">
-                <a16:creationId xmlns:a16="http://schemas.microsoft.com/office/drawing/2014/main" id="{25F5EAD9-0640-C865-A4BA-01B99E6E9793}"/>
+                <a16:creationId xmlns:a16="http://schemas.microsoft.com/office/drawing/2014/main" xmlns="" id="{25F5EAD9-0640-C865-A4BA-01B99E6E9793}"/>
               </a:ext>
             </a:extLst>
           </p:cNvPr>
@@ -24257,7 +24287,7 @@
         <p:cNvPr id="1" name="">
           <a:extLst>
             <a:ext uri="{FF2B5EF4-FFF2-40B4-BE49-F238E27FC236}">
-              <a16:creationId xmlns:a16="http://schemas.microsoft.com/office/drawing/2014/main" id="{373E9166-F06D-1BDA-3058-6689F24A8B2D}"/>
+              <a16:creationId xmlns:a16="http://schemas.microsoft.com/office/drawing/2014/main" xmlns="" id="{373E9166-F06D-1BDA-3058-6689F24A8B2D}"/>
             </a:ext>
           </a:extLst>
         </p:cNvPr>
@@ -24277,7 +24307,7 @@
           <p:cNvPr id="2" name="Título 1">
             <a:extLst>
               <a:ext uri="{FF2B5EF4-FFF2-40B4-BE49-F238E27FC236}">
-                <a16:creationId xmlns:a16="http://schemas.microsoft.com/office/drawing/2014/main" id="{19676135-9C73-7CEA-A849-661EB03FB5C5}"/>
+                <a16:creationId xmlns:a16="http://schemas.microsoft.com/office/drawing/2014/main" xmlns="" id="{19676135-9C73-7CEA-A849-661EB03FB5C5}"/>
               </a:ext>
             </a:extLst>
           </p:cNvPr>
@@ -24310,7 +24340,7 @@
           <p:cNvPr id="3" name="Marcador de contenido 2">
             <a:extLst>
               <a:ext uri="{FF2B5EF4-FFF2-40B4-BE49-F238E27FC236}">
-                <a16:creationId xmlns:a16="http://schemas.microsoft.com/office/drawing/2014/main" id="{BBD21FC4-3055-A691-0C29-D19DAAB4AE16}"/>
+                <a16:creationId xmlns:a16="http://schemas.microsoft.com/office/drawing/2014/main" xmlns="" id="{BBD21FC4-3055-A691-0C29-D19DAAB4AE16}"/>
               </a:ext>
             </a:extLst>
           </p:cNvPr>
@@ -24417,7 +24447,7 @@
               <p:cNvPr id="7" name="Tabla 6">
                 <a:extLst>
                   <a:ext uri="{FF2B5EF4-FFF2-40B4-BE49-F238E27FC236}">
-                    <a16:creationId xmlns:a16="http://schemas.microsoft.com/office/drawing/2014/main" id="{5FAE4B14-C983-221B-CAAC-EE8907FA23B1}"/>
+                    <a16:creationId xmlns:a16="http://schemas.microsoft.com/office/drawing/2014/main" xmlns="" id="{5FAE4B14-C983-221B-CAAC-EE8907FA23B1}"/>
                   </a:ext>
                 </a:extLst>
               </p:cNvPr>
@@ -24446,14 +24476,14 @@
                     <a:gridCol w="1159050">
                       <a:extLst>
                         <a:ext uri="{9D8B030D-6E8A-4147-A177-3AD203B41FA5}">
-                          <a16:colId xmlns:a16="http://schemas.microsoft.com/office/drawing/2014/main" val="2002694834"/>
+                          <a16:colId xmlns:a16="http://schemas.microsoft.com/office/drawing/2014/main" xmlns="" val="2002694834"/>
                         </a:ext>
                       </a:extLst>
                     </a:gridCol>
                     <a:gridCol w="2389876">
                       <a:extLst>
                         <a:ext uri="{9D8B030D-6E8A-4147-A177-3AD203B41FA5}">
-                          <a16:colId xmlns:a16="http://schemas.microsoft.com/office/drawing/2014/main" val="1831911072"/>
+                          <a16:colId xmlns:a16="http://schemas.microsoft.com/office/drawing/2014/main" xmlns="" val="1831911072"/>
                         </a:ext>
                       </a:extLst>
                     </a:gridCol>
@@ -24525,7 +24555,7 @@
                     </a:tc>
                     <a:extLst>
                       <a:ext uri="{0D108BD9-81ED-4DB2-BD59-A6C34878D82A}">
-                        <a16:rowId xmlns:a16="http://schemas.microsoft.com/office/drawing/2014/main" val="180083076"/>
+                        <a16:rowId xmlns:a16="http://schemas.microsoft.com/office/drawing/2014/main" xmlns="" val="180083076"/>
                       </a:ext>
                     </a:extLst>
                   </a:tr>
@@ -24648,7 +24678,7 @@
                     </a:tc>
                     <a:extLst>
                       <a:ext uri="{0D108BD9-81ED-4DB2-BD59-A6C34878D82A}">
-                        <a16:rowId xmlns:a16="http://schemas.microsoft.com/office/drawing/2014/main" val="3047016321"/>
+                        <a16:rowId xmlns:a16="http://schemas.microsoft.com/office/drawing/2014/main" xmlns="" val="3047016321"/>
                       </a:ext>
                     </a:extLst>
                   </a:tr>
@@ -24740,7 +24770,7 @@
                     </a:tc>
                     <a:extLst>
                       <a:ext uri="{0D108BD9-81ED-4DB2-BD59-A6C34878D82A}">
-                        <a16:rowId xmlns:a16="http://schemas.microsoft.com/office/drawing/2014/main" val="839298315"/>
+                        <a16:rowId xmlns:a16="http://schemas.microsoft.com/office/drawing/2014/main" xmlns="" val="839298315"/>
                       </a:ext>
                     </a:extLst>
                   </a:tr>
@@ -24832,7 +24862,7 @@
                     </a:tc>
                     <a:extLst>
                       <a:ext uri="{0D108BD9-81ED-4DB2-BD59-A6C34878D82A}">
-                        <a16:rowId xmlns:a16="http://schemas.microsoft.com/office/drawing/2014/main" val="2325501072"/>
+                        <a16:rowId xmlns:a16="http://schemas.microsoft.com/office/drawing/2014/main" xmlns="" val="2325501072"/>
                       </a:ext>
                     </a:extLst>
                   </a:tr>
@@ -24879,7 +24909,7 @@
                     </a:tc>
                     <a:extLst>
                       <a:ext uri="{0D108BD9-81ED-4DB2-BD59-A6C34878D82A}">
-                        <a16:rowId xmlns:a16="http://schemas.microsoft.com/office/drawing/2014/main" val="2300178154"/>
+                        <a16:rowId xmlns:a16="http://schemas.microsoft.com/office/drawing/2014/main" xmlns="" val="2300178154"/>
                       </a:ext>
                     </a:extLst>
                   </a:tr>
@@ -24951,7 +24981,7 @@
                     </a:tc>
                     <a:extLst>
                       <a:ext uri="{0D108BD9-81ED-4DB2-BD59-A6C34878D82A}">
-                        <a16:rowId xmlns:a16="http://schemas.microsoft.com/office/drawing/2014/main" val="3725229813"/>
+                        <a16:rowId xmlns:a16="http://schemas.microsoft.com/office/drawing/2014/main" xmlns="" val="3725229813"/>
                       </a:ext>
                     </a:extLst>
                   </a:tr>
@@ -25017,7 +25047,7 @@
                     </a:tc>
                     <a:extLst>
                       <a:ext uri="{0D108BD9-81ED-4DB2-BD59-A6C34878D82A}">
-                        <a16:rowId xmlns:a16="http://schemas.microsoft.com/office/drawing/2014/main" val="3644019166"/>
+                        <a16:rowId xmlns:a16="http://schemas.microsoft.com/office/drawing/2014/main" xmlns="" val="3644019166"/>
                       </a:ext>
                     </a:extLst>
                   </a:tr>
@@ -25083,7 +25113,7 @@
                     </a:tc>
                     <a:extLst>
                       <a:ext uri="{0D108BD9-81ED-4DB2-BD59-A6C34878D82A}">
-                        <a16:rowId xmlns:a16="http://schemas.microsoft.com/office/drawing/2014/main" val="693629496"/>
+                        <a16:rowId xmlns:a16="http://schemas.microsoft.com/office/drawing/2014/main" xmlns="" val="693629496"/>
                       </a:ext>
                     </a:extLst>
                   </a:tr>
@@ -25194,7 +25224,7 @@
                     </a:tc>
                     <a:extLst>
                       <a:ext uri="{0D108BD9-81ED-4DB2-BD59-A6C34878D82A}">
-                        <a16:rowId xmlns:a16="http://schemas.microsoft.com/office/drawing/2014/main" val="2630223487"/>
+                        <a16:rowId xmlns:a16="http://schemas.microsoft.com/office/drawing/2014/main" xmlns="" val="2630223487"/>
                       </a:ext>
                     </a:extLst>
                   </a:tr>
@@ -25255,7 +25285,7 @@
                     </a:tc>
                     <a:extLst>
                       <a:ext uri="{0D108BD9-81ED-4DB2-BD59-A6C34878D82A}">
-                        <a16:rowId xmlns:a16="http://schemas.microsoft.com/office/drawing/2014/main" val="704981190"/>
+                        <a16:rowId xmlns:a16="http://schemas.microsoft.com/office/drawing/2014/main" xmlns="" val="704981190"/>
                       </a:ext>
                     </a:extLst>
                   </a:tr>
@@ -25808,7 +25838,7 @@
               <p:cNvPr id="10" name="CuadroTexto 9">
                 <a:extLst>
                   <a:ext uri="{FF2B5EF4-FFF2-40B4-BE49-F238E27FC236}">
-                    <a16:creationId xmlns:a16="http://schemas.microsoft.com/office/drawing/2014/main" id="{EB8D88CF-3781-2E52-2248-F7A8D1256E11}"/>
+                    <a16:creationId xmlns:a16="http://schemas.microsoft.com/office/drawing/2014/main" xmlns="" id="{EB8D88CF-3781-2E52-2248-F7A8D1256E11}"/>
                   </a:ext>
                 </a:extLst>
               </p:cNvPr>
@@ -26410,7 +26440,7 @@
           <p:cNvPr id="11" name="Abrir llave 10">
             <a:extLst>
               <a:ext uri="{FF2B5EF4-FFF2-40B4-BE49-F238E27FC236}">
-                <a16:creationId xmlns:a16="http://schemas.microsoft.com/office/drawing/2014/main" id="{78F781D1-2D3A-739B-8B5F-E05B0625A185}"/>
+                <a16:creationId xmlns:a16="http://schemas.microsoft.com/office/drawing/2014/main" xmlns="" id="{78F781D1-2D3A-739B-8B5F-E05B0625A185}"/>
               </a:ext>
             </a:extLst>
           </p:cNvPr>
@@ -26454,7 +26484,7 @@
           <p:cNvPr id="12" name="Abrir llave 11">
             <a:extLst>
               <a:ext uri="{FF2B5EF4-FFF2-40B4-BE49-F238E27FC236}">
-                <a16:creationId xmlns:a16="http://schemas.microsoft.com/office/drawing/2014/main" id="{BA7CB6ED-A2FD-6AA9-8D97-607586E664B9}"/>
+                <a16:creationId xmlns:a16="http://schemas.microsoft.com/office/drawing/2014/main" xmlns="" id="{BA7CB6ED-A2FD-6AA9-8D97-607586E664B9}"/>
               </a:ext>
             </a:extLst>
           </p:cNvPr>
@@ -26498,7 +26528,7 @@
           <p:cNvPr id="13" name="CuadroTexto 12">
             <a:extLst>
               <a:ext uri="{FF2B5EF4-FFF2-40B4-BE49-F238E27FC236}">
-                <a16:creationId xmlns:a16="http://schemas.microsoft.com/office/drawing/2014/main" id="{D06B4813-FAC5-8AEF-6F6F-7825340048EC}"/>
+                <a16:creationId xmlns:a16="http://schemas.microsoft.com/office/drawing/2014/main" xmlns="" id="{D06B4813-FAC5-8AEF-6F6F-7825340048EC}"/>
               </a:ext>
             </a:extLst>
           </p:cNvPr>
@@ -26533,7 +26563,7 @@
           <p:cNvPr id="14" name="CuadroTexto 13">
             <a:extLst>
               <a:ext uri="{FF2B5EF4-FFF2-40B4-BE49-F238E27FC236}">
-                <a16:creationId xmlns:a16="http://schemas.microsoft.com/office/drawing/2014/main" id="{2D084D82-3BD1-347D-82D6-A0C47CC9379D}"/>
+                <a16:creationId xmlns:a16="http://schemas.microsoft.com/office/drawing/2014/main" xmlns="" id="{2D084D82-3BD1-347D-82D6-A0C47CC9379D}"/>
               </a:ext>
             </a:extLst>
           </p:cNvPr>
@@ -26584,7 +26614,7 @@
         <p:cNvPr id="1" name="">
           <a:extLst>
             <a:ext uri="{FF2B5EF4-FFF2-40B4-BE49-F238E27FC236}">
-              <a16:creationId xmlns:a16="http://schemas.microsoft.com/office/drawing/2014/main" id="{037E6E0F-E2C6-46AC-C179-61DED6A5A2E2}"/>
+              <a16:creationId xmlns:a16="http://schemas.microsoft.com/office/drawing/2014/main" xmlns="" id="{037E6E0F-E2C6-46AC-C179-61DED6A5A2E2}"/>
             </a:ext>
           </a:extLst>
         </p:cNvPr>
@@ -26604,7 +26634,7 @@
           <p:cNvPr id="2" name="Título 1">
             <a:extLst>
               <a:ext uri="{FF2B5EF4-FFF2-40B4-BE49-F238E27FC236}">
-                <a16:creationId xmlns:a16="http://schemas.microsoft.com/office/drawing/2014/main" id="{2C1F3DEF-ECB9-332B-0466-50C72B03EC10}"/>
+                <a16:creationId xmlns:a16="http://schemas.microsoft.com/office/drawing/2014/main" xmlns="" id="{2C1F3DEF-ECB9-332B-0466-50C72B03EC10}"/>
               </a:ext>
             </a:extLst>
           </p:cNvPr>
@@ -26639,7 +26669,7 @@
               <p:cNvPr id="3" name="Marcador de contenido 2">
                 <a:extLst>
                   <a:ext uri="{FF2B5EF4-FFF2-40B4-BE49-F238E27FC236}">
-                    <a16:creationId xmlns:a16="http://schemas.microsoft.com/office/drawing/2014/main" id="{E47C5000-3649-D7BB-8C9F-908F7A56CCEE}"/>
+                    <a16:creationId xmlns:a16="http://schemas.microsoft.com/office/drawing/2014/main" xmlns="" id="{E47C5000-3649-D7BB-8C9F-908F7A56CCEE}"/>
                   </a:ext>
                 </a:extLst>
               </p:cNvPr>
@@ -26855,7 +26885,7 @@
               <p:cNvPr id="10" name="CuadroTexto 9">
                 <a:extLst>
                   <a:ext uri="{FF2B5EF4-FFF2-40B4-BE49-F238E27FC236}">
-                    <a16:creationId xmlns:a16="http://schemas.microsoft.com/office/drawing/2014/main" id="{4EC9B546-838D-8A31-FE27-521AF264E985}"/>
+                    <a16:creationId xmlns:a16="http://schemas.microsoft.com/office/drawing/2014/main" xmlns="" id="{4EC9B546-838D-8A31-FE27-521AF264E985}"/>
                   </a:ext>
                 </a:extLst>
               </p:cNvPr>
@@ -27452,7 +27482,7 @@
           <p:cNvPr id="11" name="Abrir llave 10">
             <a:extLst>
               <a:ext uri="{FF2B5EF4-FFF2-40B4-BE49-F238E27FC236}">
-                <a16:creationId xmlns:a16="http://schemas.microsoft.com/office/drawing/2014/main" id="{700A52E3-D599-14DB-F372-95B30F4E1EA4}"/>
+                <a16:creationId xmlns:a16="http://schemas.microsoft.com/office/drawing/2014/main" xmlns="" id="{700A52E3-D599-14DB-F372-95B30F4E1EA4}"/>
               </a:ext>
             </a:extLst>
           </p:cNvPr>
@@ -27496,7 +27526,7 @@
           <p:cNvPr id="12" name="Abrir llave 11">
             <a:extLst>
               <a:ext uri="{FF2B5EF4-FFF2-40B4-BE49-F238E27FC236}">
-                <a16:creationId xmlns:a16="http://schemas.microsoft.com/office/drawing/2014/main" id="{8BF49794-6FE1-9A04-B38D-02E812971C9B}"/>
+                <a16:creationId xmlns:a16="http://schemas.microsoft.com/office/drawing/2014/main" xmlns="" id="{8BF49794-6FE1-9A04-B38D-02E812971C9B}"/>
               </a:ext>
             </a:extLst>
           </p:cNvPr>
@@ -27540,7 +27570,7 @@
           <p:cNvPr id="13" name="CuadroTexto 12">
             <a:extLst>
               <a:ext uri="{FF2B5EF4-FFF2-40B4-BE49-F238E27FC236}">
-                <a16:creationId xmlns:a16="http://schemas.microsoft.com/office/drawing/2014/main" id="{18496643-F82F-739D-9BAA-E5B36EC64F59}"/>
+                <a16:creationId xmlns:a16="http://schemas.microsoft.com/office/drawing/2014/main" xmlns="" id="{18496643-F82F-739D-9BAA-E5B36EC64F59}"/>
               </a:ext>
             </a:extLst>
           </p:cNvPr>
@@ -27575,7 +27605,7 @@
           <p:cNvPr id="14" name="CuadroTexto 13">
             <a:extLst>
               <a:ext uri="{FF2B5EF4-FFF2-40B4-BE49-F238E27FC236}">
-                <a16:creationId xmlns:a16="http://schemas.microsoft.com/office/drawing/2014/main" id="{1745AE60-80CC-7D9B-A46F-839547A8762A}"/>
+                <a16:creationId xmlns:a16="http://schemas.microsoft.com/office/drawing/2014/main" xmlns="" id="{1745AE60-80CC-7D9B-A46F-839547A8762A}"/>
               </a:ext>
             </a:extLst>
           </p:cNvPr>
@@ -27612,7 +27642,7 @@
               <p:cNvPr id="4" name="CuadroTexto 3">
                 <a:extLst>
                   <a:ext uri="{FF2B5EF4-FFF2-40B4-BE49-F238E27FC236}">
-                    <a16:creationId xmlns:a16="http://schemas.microsoft.com/office/drawing/2014/main" id="{9189F0BF-11D0-B233-13F8-7089C6D4AB1A}"/>
+                    <a16:creationId xmlns:a16="http://schemas.microsoft.com/office/drawing/2014/main" xmlns="" id="{9189F0BF-11D0-B233-13F8-7089C6D4AB1A}"/>
                   </a:ext>
                 </a:extLst>
               </p:cNvPr>
@@ -27732,7 +27762,7 @@
               <p:cNvPr id="5" name="CuadroTexto 4">
                 <a:extLst>
                   <a:ext uri="{FF2B5EF4-FFF2-40B4-BE49-F238E27FC236}">
-                    <a16:creationId xmlns:a16="http://schemas.microsoft.com/office/drawing/2014/main" id="{0BF7FC9D-C50F-7411-DC6E-05C87E35B77B}"/>
+                    <a16:creationId xmlns:a16="http://schemas.microsoft.com/office/drawing/2014/main" xmlns="" id="{0BF7FC9D-C50F-7411-DC6E-05C87E35B77B}"/>
                   </a:ext>
                 </a:extLst>
               </p:cNvPr>
@@ -27982,7 +28012,7 @@
           <p:cNvPr id="2" name="Título 1">
             <a:extLst>
               <a:ext uri="{FF2B5EF4-FFF2-40B4-BE49-F238E27FC236}">
-                <a16:creationId xmlns:a16="http://schemas.microsoft.com/office/drawing/2014/main" id="{7C97405F-E812-8ECA-0FBF-DE395633D086}"/>
+                <a16:creationId xmlns:a16="http://schemas.microsoft.com/office/drawing/2014/main" xmlns="" id="{7C97405F-E812-8ECA-0FBF-DE395633D086}"/>
               </a:ext>
             </a:extLst>
           </p:cNvPr>
@@ -28015,7 +28045,7 @@
           <p:cNvPr id="3" name="Marcador de contenido 2">
             <a:extLst>
               <a:ext uri="{FF2B5EF4-FFF2-40B4-BE49-F238E27FC236}">
-                <a16:creationId xmlns:a16="http://schemas.microsoft.com/office/drawing/2014/main" id="{4895F9A4-5583-A4D7-2C26-2C99E36AFD03}"/>
+                <a16:creationId xmlns:a16="http://schemas.microsoft.com/office/drawing/2014/main" xmlns="" id="{4895F9A4-5583-A4D7-2C26-2C99E36AFD03}"/>
               </a:ext>
             </a:extLst>
           </p:cNvPr>
@@ -28184,7 +28214,7 @@
           <p:cNvPr id="11" name="Imagen 10">
             <a:extLst>
               <a:ext uri="{FF2B5EF4-FFF2-40B4-BE49-F238E27FC236}">
-                <a16:creationId xmlns:a16="http://schemas.microsoft.com/office/drawing/2014/main" id="{0D66D670-FACF-9D43-855E-DD4781E3E832}"/>
+                <a16:creationId xmlns:a16="http://schemas.microsoft.com/office/drawing/2014/main" xmlns="" id="{0D66D670-FACF-9D43-855E-DD4781E3E832}"/>
               </a:ext>
             </a:extLst>
           </p:cNvPr>
@@ -28229,7 +28259,7 @@
         <p:cNvPr id="1" name="">
           <a:extLst>
             <a:ext uri="{FF2B5EF4-FFF2-40B4-BE49-F238E27FC236}">
-              <a16:creationId xmlns:a16="http://schemas.microsoft.com/office/drawing/2014/main" id="{7DE8187A-AC8C-8F50-8227-8C54EE546935}"/>
+              <a16:creationId xmlns:a16="http://schemas.microsoft.com/office/drawing/2014/main" xmlns="" id="{7DE8187A-AC8C-8F50-8227-8C54EE546935}"/>
             </a:ext>
           </a:extLst>
         </p:cNvPr>
@@ -28249,7 +28279,7 @@
           <p:cNvPr id="2" name="Título 1">
             <a:extLst>
               <a:ext uri="{FF2B5EF4-FFF2-40B4-BE49-F238E27FC236}">
-                <a16:creationId xmlns:a16="http://schemas.microsoft.com/office/drawing/2014/main" id="{98EC0236-D3A6-A3F8-3561-E49E7DD877FB}"/>
+                <a16:creationId xmlns:a16="http://schemas.microsoft.com/office/drawing/2014/main" xmlns="" id="{98EC0236-D3A6-A3F8-3561-E49E7DD877FB}"/>
               </a:ext>
             </a:extLst>
           </p:cNvPr>
@@ -28284,7 +28314,7 @@
               <p:cNvPr id="3" name="Marcador de contenido 2">
                 <a:extLst>
                   <a:ext uri="{FF2B5EF4-FFF2-40B4-BE49-F238E27FC236}">
-                    <a16:creationId xmlns:a16="http://schemas.microsoft.com/office/drawing/2014/main" id="{C70A1B2C-DFC1-80F9-36F4-F2F7301F4104}"/>
+                    <a16:creationId xmlns:a16="http://schemas.microsoft.com/office/drawing/2014/main" xmlns="" id="{C70A1B2C-DFC1-80F9-36F4-F2F7301F4104}"/>
                   </a:ext>
                 </a:extLst>
               </p:cNvPr>
@@ -28518,7 +28548,7 @@
               <p:cNvPr id="6" name="CuadroTexto 5">
                 <a:extLst>
                   <a:ext uri="{FF2B5EF4-FFF2-40B4-BE49-F238E27FC236}">
-                    <a16:creationId xmlns:a16="http://schemas.microsoft.com/office/drawing/2014/main" id="{410BBDC9-E3F1-2002-B2C7-9704710BA29F}"/>
+                    <a16:creationId xmlns:a16="http://schemas.microsoft.com/office/drawing/2014/main" xmlns="" id="{410BBDC9-E3F1-2002-B2C7-9704710BA29F}"/>
                   </a:ext>
                 </a:extLst>
               </p:cNvPr>
@@ -28748,7 +28778,7 @@
           <p:cNvPr id="9" name="CuadroTexto 8">
             <a:extLst>
               <a:ext uri="{FF2B5EF4-FFF2-40B4-BE49-F238E27FC236}">
-                <a16:creationId xmlns:a16="http://schemas.microsoft.com/office/drawing/2014/main" id="{47EF9DBC-CB34-DCDE-DD74-4991A2A483C1}"/>
+                <a16:creationId xmlns:a16="http://schemas.microsoft.com/office/drawing/2014/main" xmlns="" id="{47EF9DBC-CB34-DCDE-DD74-4991A2A483C1}"/>
               </a:ext>
             </a:extLst>
           </p:cNvPr>
@@ -28783,7 +28813,7 @@
           <p:cNvPr id="15" name="CuadroTexto 14">
             <a:extLst>
               <a:ext uri="{FF2B5EF4-FFF2-40B4-BE49-F238E27FC236}">
-                <a16:creationId xmlns:a16="http://schemas.microsoft.com/office/drawing/2014/main" id="{C6F6B4B7-46A1-3CE5-B7D4-6C313AE0EAF2}"/>
+                <a16:creationId xmlns:a16="http://schemas.microsoft.com/office/drawing/2014/main" xmlns="" id="{C6F6B4B7-46A1-3CE5-B7D4-6C313AE0EAF2}"/>
               </a:ext>
             </a:extLst>
           </p:cNvPr>
@@ -28820,7 +28850,7 @@
               <p:cNvPr id="16" name="CuadroTexto 15">
                 <a:extLst>
                   <a:ext uri="{FF2B5EF4-FFF2-40B4-BE49-F238E27FC236}">
-                    <a16:creationId xmlns:a16="http://schemas.microsoft.com/office/drawing/2014/main" id="{02D32BC2-C1F3-35ED-0933-68D1476B532A}"/>
+                    <a16:creationId xmlns:a16="http://schemas.microsoft.com/office/drawing/2014/main" xmlns="" id="{02D32BC2-C1F3-35ED-0933-68D1476B532A}"/>
                   </a:ext>
                 </a:extLst>
               </p:cNvPr>
@@ -29346,7 +29376,7 @@
           <p:cNvPr id="18" name="Conector recto de flecha 17">
             <a:extLst>
               <a:ext uri="{FF2B5EF4-FFF2-40B4-BE49-F238E27FC236}">
-                <a16:creationId xmlns:a16="http://schemas.microsoft.com/office/drawing/2014/main" id="{0E9BFD8F-6B3E-26EE-2BF1-6407B0B47A58}"/>
+                <a16:creationId xmlns:a16="http://schemas.microsoft.com/office/drawing/2014/main" xmlns="" id="{0E9BFD8F-6B3E-26EE-2BF1-6407B0B47A58}"/>
               </a:ext>
             </a:extLst>
           </p:cNvPr>
@@ -29404,7 +29434,7 @@
         <p:cNvPr id="1" name="">
           <a:extLst>
             <a:ext uri="{FF2B5EF4-FFF2-40B4-BE49-F238E27FC236}">
-              <a16:creationId xmlns:a16="http://schemas.microsoft.com/office/drawing/2014/main" id="{2E5A3AC1-9758-9150-5203-9C30480DE327}"/>
+              <a16:creationId xmlns:a16="http://schemas.microsoft.com/office/drawing/2014/main" xmlns="" id="{2E5A3AC1-9758-9150-5203-9C30480DE327}"/>
             </a:ext>
           </a:extLst>
         </p:cNvPr>
@@ -29424,7 +29454,7 @@
           <p:cNvPr id="2" name="Título 1">
             <a:extLst>
               <a:ext uri="{FF2B5EF4-FFF2-40B4-BE49-F238E27FC236}">
-                <a16:creationId xmlns:a16="http://schemas.microsoft.com/office/drawing/2014/main" id="{A2C8FEF7-3396-2018-4430-A9D0D963228B}"/>
+                <a16:creationId xmlns:a16="http://schemas.microsoft.com/office/drawing/2014/main" xmlns="" id="{A2C8FEF7-3396-2018-4430-A9D0D963228B}"/>
               </a:ext>
             </a:extLst>
           </p:cNvPr>
@@ -29457,7 +29487,7 @@
           <p:cNvPr id="3" name="Marcador de contenido 2">
             <a:extLst>
               <a:ext uri="{FF2B5EF4-FFF2-40B4-BE49-F238E27FC236}">
-                <a16:creationId xmlns:a16="http://schemas.microsoft.com/office/drawing/2014/main" id="{E075B645-FF15-BB61-FEF9-776AA72DC856}"/>
+                <a16:creationId xmlns:a16="http://schemas.microsoft.com/office/drawing/2014/main" xmlns="" id="{E075B645-FF15-BB61-FEF9-776AA72DC856}"/>
               </a:ext>
             </a:extLst>
           </p:cNvPr>
@@ -29526,7 +29556,7 @@
               <p:cNvPr id="5" name="CuadroTexto 4">
                 <a:extLst>
                   <a:ext uri="{FF2B5EF4-FFF2-40B4-BE49-F238E27FC236}">
-                    <a16:creationId xmlns:a16="http://schemas.microsoft.com/office/drawing/2014/main" id="{7AF4B05A-D5E4-26B6-D1F5-B36146BC5D32}"/>
+                    <a16:creationId xmlns:a16="http://schemas.microsoft.com/office/drawing/2014/main" xmlns="" id="{7AF4B05A-D5E4-26B6-D1F5-B36146BC5D32}"/>
                   </a:ext>
                 </a:extLst>
               </p:cNvPr>
@@ -29790,7 +29820,7 @@
               <p:cNvPr id="7" name="CuadroTexto 6">
                 <a:extLst>
                   <a:ext uri="{FF2B5EF4-FFF2-40B4-BE49-F238E27FC236}">
-                    <a16:creationId xmlns:a16="http://schemas.microsoft.com/office/drawing/2014/main" id="{78503BFD-F808-9E0C-94FE-B0A1B2AD1DC3}"/>
+                    <a16:creationId xmlns:a16="http://schemas.microsoft.com/office/drawing/2014/main" xmlns="" id="{78503BFD-F808-9E0C-94FE-B0A1B2AD1DC3}"/>
                   </a:ext>
                 </a:extLst>
               </p:cNvPr>
@@ -30209,7 +30239,7 @@
           <p:cNvPr id="8" name="CuadroTexto 7">
             <a:extLst>
               <a:ext uri="{FF2B5EF4-FFF2-40B4-BE49-F238E27FC236}">
-                <a16:creationId xmlns:a16="http://schemas.microsoft.com/office/drawing/2014/main" id="{33F1A92E-653E-8142-C3FA-B2F9E291FEAC}"/>
+                <a16:creationId xmlns:a16="http://schemas.microsoft.com/office/drawing/2014/main" xmlns="" id="{33F1A92E-653E-8142-C3FA-B2F9E291FEAC}"/>
               </a:ext>
             </a:extLst>
           </p:cNvPr>
@@ -30247,7 +30277,7 @@
               <p:cNvPr id="10" name="CuadroTexto 9">
                 <a:extLst>
                   <a:ext uri="{FF2B5EF4-FFF2-40B4-BE49-F238E27FC236}">
-                    <a16:creationId xmlns:a16="http://schemas.microsoft.com/office/drawing/2014/main" id="{5CFC48CF-4E60-C4C2-3DB1-35B37E35CE92}"/>
+                    <a16:creationId xmlns:a16="http://schemas.microsoft.com/office/drawing/2014/main" xmlns="" id="{5CFC48CF-4E60-C4C2-3DB1-35B37E35CE92}"/>
                   </a:ext>
                 </a:extLst>
               </p:cNvPr>
@@ -30385,7 +30415,7 @@
           <p:cNvPr id="12" name="CuadroTexto 11">
             <a:extLst>
               <a:ext uri="{FF2B5EF4-FFF2-40B4-BE49-F238E27FC236}">
-                <a16:creationId xmlns:a16="http://schemas.microsoft.com/office/drawing/2014/main" id="{C4452984-929E-56D5-2C55-3E251F270087}"/>
+                <a16:creationId xmlns:a16="http://schemas.microsoft.com/office/drawing/2014/main" xmlns="" id="{C4452984-929E-56D5-2C55-3E251F270087}"/>
               </a:ext>
             </a:extLst>
           </p:cNvPr>
@@ -30439,7 +30469,7 @@
         <p:cNvPr id="1" name="">
           <a:extLst>
             <a:ext uri="{FF2B5EF4-FFF2-40B4-BE49-F238E27FC236}">
-              <a16:creationId xmlns:a16="http://schemas.microsoft.com/office/drawing/2014/main" id="{8074EF4C-4739-6E9B-E888-AC6FD3A6EFC2}"/>
+              <a16:creationId xmlns:a16="http://schemas.microsoft.com/office/drawing/2014/main" xmlns="" id="{8074EF4C-4739-6E9B-E888-AC6FD3A6EFC2}"/>
             </a:ext>
           </a:extLst>
         </p:cNvPr>
@@ -30459,7 +30489,7 @@
           <p:cNvPr id="2" name="Título 1">
             <a:extLst>
               <a:ext uri="{FF2B5EF4-FFF2-40B4-BE49-F238E27FC236}">
-                <a16:creationId xmlns:a16="http://schemas.microsoft.com/office/drawing/2014/main" id="{05ED1FE7-B29A-73C2-DE91-6C986BE3BCF0}"/>
+                <a16:creationId xmlns:a16="http://schemas.microsoft.com/office/drawing/2014/main" xmlns="" id="{05ED1FE7-B29A-73C2-DE91-6C986BE3BCF0}"/>
               </a:ext>
             </a:extLst>
           </p:cNvPr>
@@ -30492,7 +30522,7 @@
           <p:cNvPr id="3" name="Marcador de contenido 2">
             <a:extLst>
               <a:ext uri="{FF2B5EF4-FFF2-40B4-BE49-F238E27FC236}">
-                <a16:creationId xmlns:a16="http://schemas.microsoft.com/office/drawing/2014/main" id="{2616CED8-7C07-0B4C-671D-1EA20A33296D}"/>
+                <a16:creationId xmlns:a16="http://schemas.microsoft.com/office/drawing/2014/main" xmlns="" id="{2616CED8-7C07-0B4C-671D-1EA20A33296D}"/>
               </a:ext>
             </a:extLst>
           </p:cNvPr>
@@ -30580,7 +30610,7 @@
           <p:cNvPr id="4" name="Imagen 3">
             <a:extLst>
               <a:ext uri="{FF2B5EF4-FFF2-40B4-BE49-F238E27FC236}">
-                <a16:creationId xmlns:a16="http://schemas.microsoft.com/office/drawing/2014/main" id="{2CB9313E-0F43-6417-BAFA-2547AFB70CD1}"/>
+                <a16:creationId xmlns:a16="http://schemas.microsoft.com/office/drawing/2014/main" xmlns="" id="{2CB9313E-0F43-6417-BAFA-2547AFB70CD1}"/>
               </a:ext>
             </a:extLst>
           </p:cNvPr>
@@ -30610,7 +30640,7 @@
           <p:cNvPr id="6" name="CuadroTexto 5">
             <a:extLst>
               <a:ext uri="{FF2B5EF4-FFF2-40B4-BE49-F238E27FC236}">
-                <a16:creationId xmlns:a16="http://schemas.microsoft.com/office/drawing/2014/main" id="{19B34EE8-2CF2-0DD9-765D-352D4FEDDD62}"/>
+                <a16:creationId xmlns:a16="http://schemas.microsoft.com/office/drawing/2014/main" xmlns="" id="{19B34EE8-2CF2-0DD9-765D-352D4FEDDD62}"/>
               </a:ext>
             </a:extLst>
           </p:cNvPr>
@@ -30669,7 +30699,7 @@
         <p:cNvPr id="1" name="">
           <a:extLst>
             <a:ext uri="{FF2B5EF4-FFF2-40B4-BE49-F238E27FC236}">
-              <a16:creationId xmlns:a16="http://schemas.microsoft.com/office/drawing/2014/main" id="{F30A0042-776C-5DE5-5335-5443911DF414}"/>
+              <a16:creationId xmlns:a16="http://schemas.microsoft.com/office/drawing/2014/main" xmlns="" id="{F30A0042-776C-5DE5-5335-5443911DF414}"/>
             </a:ext>
           </a:extLst>
         </p:cNvPr>
@@ -30689,7 +30719,7 @@
           <p:cNvPr id="7" name="Imagen 6">
             <a:extLst>
               <a:ext uri="{FF2B5EF4-FFF2-40B4-BE49-F238E27FC236}">
-                <a16:creationId xmlns:a16="http://schemas.microsoft.com/office/drawing/2014/main" id="{61C3486E-67B9-41E5-927F-A06A2A7CCCB3}"/>
+                <a16:creationId xmlns:a16="http://schemas.microsoft.com/office/drawing/2014/main" xmlns="" id="{61C3486E-67B9-41E5-927F-A06A2A7CCCB3}"/>
               </a:ext>
             </a:extLst>
           </p:cNvPr>
@@ -30719,7 +30749,7 @@
           <p:cNvPr id="2" name="Título 1">
             <a:extLst>
               <a:ext uri="{FF2B5EF4-FFF2-40B4-BE49-F238E27FC236}">
-                <a16:creationId xmlns:a16="http://schemas.microsoft.com/office/drawing/2014/main" id="{DE2ABD54-94C9-4039-8709-F7AABC5500A2}"/>
+                <a16:creationId xmlns:a16="http://schemas.microsoft.com/office/drawing/2014/main" xmlns="" id="{DE2ABD54-94C9-4039-8709-F7AABC5500A2}"/>
               </a:ext>
             </a:extLst>
           </p:cNvPr>
@@ -30752,7 +30782,7 @@
           <p:cNvPr id="3" name="Marcador de contenido 2">
             <a:extLst>
               <a:ext uri="{FF2B5EF4-FFF2-40B4-BE49-F238E27FC236}">
-                <a16:creationId xmlns:a16="http://schemas.microsoft.com/office/drawing/2014/main" id="{0DCB2DF4-D1C6-3A32-9536-B61DB744626E}"/>
+                <a16:creationId xmlns:a16="http://schemas.microsoft.com/office/drawing/2014/main" xmlns="" id="{0DCB2DF4-D1C6-3A32-9536-B61DB744626E}"/>
               </a:ext>
             </a:extLst>
           </p:cNvPr>
@@ -30852,7 +30882,7 @@
           <p:cNvPr id="6" name="CuadroTexto 5">
             <a:extLst>
               <a:ext uri="{FF2B5EF4-FFF2-40B4-BE49-F238E27FC236}">
-                <a16:creationId xmlns:a16="http://schemas.microsoft.com/office/drawing/2014/main" id="{54E234FD-24E6-29C8-EEE1-774C713E5E42}"/>
+                <a16:creationId xmlns:a16="http://schemas.microsoft.com/office/drawing/2014/main" xmlns="" id="{54E234FD-24E6-29C8-EEE1-774C713E5E42}"/>
               </a:ext>
             </a:extLst>
           </p:cNvPr>
@@ -30911,7 +30941,7 @@
         <p:cNvPr id="1" name="">
           <a:extLst>
             <a:ext uri="{FF2B5EF4-FFF2-40B4-BE49-F238E27FC236}">
-              <a16:creationId xmlns:a16="http://schemas.microsoft.com/office/drawing/2014/main" id="{B5F2B7EE-3335-92C9-0E55-22A60CC22400}"/>
+              <a16:creationId xmlns:a16="http://schemas.microsoft.com/office/drawing/2014/main" xmlns="" id="{B5F2B7EE-3335-92C9-0E55-22A60CC22400}"/>
             </a:ext>
           </a:extLst>
         </p:cNvPr>
@@ -30931,7 +30961,7 @@
           <p:cNvPr id="2" name="Título 1">
             <a:extLst>
               <a:ext uri="{FF2B5EF4-FFF2-40B4-BE49-F238E27FC236}">
-                <a16:creationId xmlns:a16="http://schemas.microsoft.com/office/drawing/2014/main" id="{554DD44F-7A5C-1A2E-3082-DE72FFBBDB7F}"/>
+                <a16:creationId xmlns:a16="http://schemas.microsoft.com/office/drawing/2014/main" xmlns="" id="{554DD44F-7A5C-1A2E-3082-DE72FFBBDB7F}"/>
               </a:ext>
             </a:extLst>
           </p:cNvPr>
@@ -30964,7 +30994,7 @@
           <p:cNvPr id="3" name="Marcador de contenido 2">
             <a:extLst>
               <a:ext uri="{FF2B5EF4-FFF2-40B4-BE49-F238E27FC236}">
-                <a16:creationId xmlns:a16="http://schemas.microsoft.com/office/drawing/2014/main" id="{07D4B520-6184-889E-5103-B1DC45632F21}"/>
+                <a16:creationId xmlns:a16="http://schemas.microsoft.com/office/drawing/2014/main" xmlns="" id="{07D4B520-6184-889E-5103-B1DC45632F21}"/>
               </a:ext>
             </a:extLst>
           </p:cNvPr>
@@ -31030,7 +31060,7 @@
         <p:cNvPr id="1" name="">
           <a:extLst>
             <a:ext uri="{FF2B5EF4-FFF2-40B4-BE49-F238E27FC236}">
-              <a16:creationId xmlns:a16="http://schemas.microsoft.com/office/drawing/2014/main" id="{7AFE3564-88D8-7E40-6ACE-149C1305325B}"/>
+              <a16:creationId xmlns:a16="http://schemas.microsoft.com/office/drawing/2014/main" xmlns="" id="{7AFE3564-88D8-7E40-6ACE-149C1305325B}"/>
             </a:ext>
           </a:extLst>
         </p:cNvPr>
@@ -31050,7 +31080,7 @@
           <p:cNvPr id="2" name="Título 1">
             <a:extLst>
               <a:ext uri="{FF2B5EF4-FFF2-40B4-BE49-F238E27FC236}">
-                <a16:creationId xmlns:a16="http://schemas.microsoft.com/office/drawing/2014/main" id="{22D84546-14C8-57FD-2016-7D653833002F}"/>
+                <a16:creationId xmlns:a16="http://schemas.microsoft.com/office/drawing/2014/main" xmlns="" id="{22D84546-14C8-57FD-2016-7D653833002F}"/>
               </a:ext>
             </a:extLst>
           </p:cNvPr>
@@ -31083,7 +31113,7 @@
           <p:cNvPr id="3" name="Marcador de contenido 2">
             <a:extLst>
               <a:ext uri="{FF2B5EF4-FFF2-40B4-BE49-F238E27FC236}">
-                <a16:creationId xmlns:a16="http://schemas.microsoft.com/office/drawing/2014/main" id="{5DD3A9A3-7310-4D8A-4B34-9552F9CB11A5}"/>
+                <a16:creationId xmlns:a16="http://schemas.microsoft.com/office/drawing/2014/main" xmlns="" id="{5DD3A9A3-7310-4D8A-4B34-9552F9CB11A5}"/>
               </a:ext>
             </a:extLst>
           </p:cNvPr>
@@ -31160,7 +31190,7 @@
           <p:cNvPr id="6" name="CuadroTexto 5">
             <a:extLst>
               <a:ext uri="{FF2B5EF4-FFF2-40B4-BE49-F238E27FC236}">
-                <a16:creationId xmlns:a16="http://schemas.microsoft.com/office/drawing/2014/main" id="{67DBC678-A344-425F-B839-565054235668}"/>
+                <a16:creationId xmlns:a16="http://schemas.microsoft.com/office/drawing/2014/main" xmlns="" id="{67DBC678-A344-425F-B839-565054235668}"/>
               </a:ext>
             </a:extLst>
           </p:cNvPr>
@@ -31203,7 +31233,7 @@
           <p:cNvPr id="5" name="Imagen 4">
             <a:extLst>
               <a:ext uri="{FF2B5EF4-FFF2-40B4-BE49-F238E27FC236}">
-                <a16:creationId xmlns:a16="http://schemas.microsoft.com/office/drawing/2014/main" id="{C654CC55-1D2E-5123-A43C-9698E330771C}"/>
+                <a16:creationId xmlns:a16="http://schemas.microsoft.com/office/drawing/2014/main" xmlns="" id="{C654CC55-1D2E-5123-A43C-9698E330771C}"/>
               </a:ext>
             </a:extLst>
           </p:cNvPr>
@@ -31249,7 +31279,7 @@
         <p:cNvPr id="1" name="">
           <a:extLst>
             <a:ext uri="{FF2B5EF4-FFF2-40B4-BE49-F238E27FC236}">
-              <a16:creationId xmlns:a16="http://schemas.microsoft.com/office/drawing/2014/main" id="{06FF8CE7-9D49-E9E5-7DB2-1F1140C296DB}"/>
+              <a16:creationId xmlns:a16="http://schemas.microsoft.com/office/drawing/2014/main" xmlns="" id="{06FF8CE7-9D49-E9E5-7DB2-1F1140C296DB}"/>
             </a:ext>
           </a:extLst>
         </p:cNvPr>
@@ -31269,7 +31299,7 @@
           <p:cNvPr id="2" name="Título 1">
             <a:extLst>
               <a:ext uri="{FF2B5EF4-FFF2-40B4-BE49-F238E27FC236}">
-                <a16:creationId xmlns:a16="http://schemas.microsoft.com/office/drawing/2014/main" id="{5C47E731-71E0-BB96-6C2F-B99B711C4C90}"/>
+                <a16:creationId xmlns:a16="http://schemas.microsoft.com/office/drawing/2014/main" xmlns="" id="{5C47E731-71E0-BB96-6C2F-B99B711C4C90}"/>
               </a:ext>
             </a:extLst>
           </p:cNvPr>
@@ -31302,7 +31332,7 @@
           <p:cNvPr id="3" name="Marcador de contenido 2">
             <a:extLst>
               <a:ext uri="{FF2B5EF4-FFF2-40B4-BE49-F238E27FC236}">
-                <a16:creationId xmlns:a16="http://schemas.microsoft.com/office/drawing/2014/main" id="{095D61F4-82C9-3AF4-140D-010A219F40CD}"/>
+                <a16:creationId xmlns:a16="http://schemas.microsoft.com/office/drawing/2014/main" xmlns="" id="{095D61F4-82C9-3AF4-140D-010A219F40CD}"/>
               </a:ext>
             </a:extLst>
           </p:cNvPr>
@@ -31368,7 +31398,7 @@
         <p:cNvPr id="1" name="">
           <a:extLst>
             <a:ext uri="{FF2B5EF4-FFF2-40B4-BE49-F238E27FC236}">
-              <a16:creationId xmlns:a16="http://schemas.microsoft.com/office/drawing/2014/main" id="{5884AAD3-992E-0AFC-2394-43B9AD463341}"/>
+              <a16:creationId xmlns:a16="http://schemas.microsoft.com/office/drawing/2014/main" xmlns="" id="{5884AAD3-992E-0AFC-2394-43B9AD463341}"/>
             </a:ext>
           </a:extLst>
         </p:cNvPr>
@@ -31388,7 +31418,7 @@
           <p:cNvPr id="2" name="Título 1">
             <a:extLst>
               <a:ext uri="{FF2B5EF4-FFF2-40B4-BE49-F238E27FC236}">
-                <a16:creationId xmlns:a16="http://schemas.microsoft.com/office/drawing/2014/main" id="{41081D6E-7CB5-4019-CB00-A117705E11B1}"/>
+                <a16:creationId xmlns:a16="http://schemas.microsoft.com/office/drawing/2014/main" xmlns="" id="{41081D6E-7CB5-4019-CB00-A117705E11B1}"/>
               </a:ext>
             </a:extLst>
           </p:cNvPr>
@@ -31421,7 +31451,7 @@
           <p:cNvPr id="3" name="Marcador de contenido 2">
             <a:extLst>
               <a:ext uri="{FF2B5EF4-FFF2-40B4-BE49-F238E27FC236}">
-                <a16:creationId xmlns:a16="http://schemas.microsoft.com/office/drawing/2014/main" id="{BC480A00-0A21-4367-700C-E009991B6D69}"/>
+                <a16:creationId xmlns:a16="http://schemas.microsoft.com/office/drawing/2014/main" xmlns="" id="{BC480A00-0A21-4367-700C-E009991B6D69}"/>
               </a:ext>
             </a:extLst>
           </p:cNvPr>
@@ -31487,7 +31517,7 @@
         <p:cNvPr id="1" name="">
           <a:extLst>
             <a:ext uri="{FF2B5EF4-FFF2-40B4-BE49-F238E27FC236}">
-              <a16:creationId xmlns:a16="http://schemas.microsoft.com/office/drawing/2014/main" id="{619A8279-F2C7-EF83-0B18-F69ED4157015}"/>
+              <a16:creationId xmlns:a16="http://schemas.microsoft.com/office/drawing/2014/main" xmlns="" id="{619A8279-F2C7-EF83-0B18-F69ED4157015}"/>
             </a:ext>
           </a:extLst>
         </p:cNvPr>
@@ -31507,7 +31537,7 @@
           <p:cNvPr id="2" name="Título 1">
             <a:extLst>
               <a:ext uri="{FF2B5EF4-FFF2-40B4-BE49-F238E27FC236}">
-                <a16:creationId xmlns:a16="http://schemas.microsoft.com/office/drawing/2014/main" id="{20D59896-C85B-852E-698C-D506FB62DF06}"/>
+                <a16:creationId xmlns:a16="http://schemas.microsoft.com/office/drawing/2014/main" xmlns="" id="{20D59896-C85B-852E-698C-D506FB62DF06}"/>
               </a:ext>
             </a:extLst>
           </p:cNvPr>
@@ -31540,7 +31570,7 @@
           <p:cNvPr id="3" name="Marcador de contenido 2">
             <a:extLst>
               <a:ext uri="{FF2B5EF4-FFF2-40B4-BE49-F238E27FC236}">
-                <a16:creationId xmlns:a16="http://schemas.microsoft.com/office/drawing/2014/main" id="{DE950F92-179A-6A18-9630-BAB1FD13673F}"/>
+                <a16:creationId xmlns:a16="http://schemas.microsoft.com/office/drawing/2014/main" xmlns="" id="{DE950F92-179A-6A18-9630-BAB1FD13673F}"/>
               </a:ext>
             </a:extLst>
           </p:cNvPr>
@@ -31554,7 +31584,7 @@
         <p:spPr/>
         <p:txBody>
           <a:bodyPr>
-            <a:normAutofit fontScale="85000" lnSpcReduction="20000"/>
+            <a:normAutofit fontScale="70000" lnSpcReduction="20000"/>
           </a:bodyPr>
           <a:lstStyle/>
           <a:p>
@@ -31614,7 +31644,7 @@
           <p:cNvPr id="4" name="Marcador de contenido 3">
             <a:extLst>
               <a:ext uri="{FF2B5EF4-FFF2-40B4-BE49-F238E27FC236}">
-                <a16:creationId xmlns:a16="http://schemas.microsoft.com/office/drawing/2014/main" id="{A5CEACF8-E932-108E-7ABE-547DAAA851ED}"/>
+                <a16:creationId xmlns:a16="http://schemas.microsoft.com/office/drawing/2014/main" xmlns="" id="{A5CEACF8-E932-108E-7ABE-547DAAA851ED}"/>
               </a:ext>
             </a:extLst>
           </p:cNvPr>
@@ -31628,7 +31658,7 @@
         <p:spPr/>
         <p:txBody>
           <a:bodyPr>
-            <a:normAutofit fontScale="85000" lnSpcReduction="20000"/>
+            <a:normAutofit fontScale="70000" lnSpcReduction="20000"/>
           </a:bodyPr>
           <a:lstStyle/>
           <a:p>
@@ -31767,7 +31797,7 @@
         <p:cNvPr id="1" name="">
           <a:extLst>
             <a:ext uri="{FF2B5EF4-FFF2-40B4-BE49-F238E27FC236}">
-              <a16:creationId xmlns:a16="http://schemas.microsoft.com/office/drawing/2014/main" id="{BE571F52-05EF-1021-3347-CDB2E8EB7C99}"/>
+              <a16:creationId xmlns:a16="http://schemas.microsoft.com/office/drawing/2014/main" xmlns="" id="{BE571F52-05EF-1021-3347-CDB2E8EB7C99}"/>
             </a:ext>
           </a:extLst>
         </p:cNvPr>
@@ -31787,7 +31817,7 @@
           <p:cNvPr id="2" name="Título 1">
             <a:extLst>
               <a:ext uri="{FF2B5EF4-FFF2-40B4-BE49-F238E27FC236}">
-                <a16:creationId xmlns:a16="http://schemas.microsoft.com/office/drawing/2014/main" id="{5DF2C60B-4C6E-7437-4245-1CC0A26AA7B3}"/>
+                <a16:creationId xmlns:a16="http://schemas.microsoft.com/office/drawing/2014/main" xmlns="" id="{5DF2C60B-4C6E-7437-4245-1CC0A26AA7B3}"/>
               </a:ext>
             </a:extLst>
           </p:cNvPr>
@@ -31817,7 +31847,7 @@
           <p:cNvPr id="6" name="Marcador de contenido 3">
             <a:extLst>
               <a:ext uri="{FF2B5EF4-FFF2-40B4-BE49-F238E27FC236}">
-                <a16:creationId xmlns:a16="http://schemas.microsoft.com/office/drawing/2014/main" id="{A5CEACF8-E932-108E-7ABE-547DAAA851ED}"/>
+                <a16:creationId xmlns:a16="http://schemas.microsoft.com/office/drawing/2014/main" xmlns="" id="{A5CEACF8-E932-108E-7ABE-547DAAA851ED}"/>
               </a:ext>
             </a:extLst>
           </p:cNvPr>
@@ -31836,7 +31866,7 @@
         </p:spPr>
         <p:txBody>
           <a:bodyPr>
-            <a:normAutofit fontScale="85000" lnSpcReduction="20000"/>
+            <a:normAutofit fontScale="70000" lnSpcReduction="20000"/>
           </a:bodyPr>
           <a:lstStyle/>
           <a:p>
@@ -31989,7 +32019,7 @@
           <p:cNvPr id="2" name="Título 1">
             <a:extLst>
               <a:ext uri="{FF2B5EF4-FFF2-40B4-BE49-F238E27FC236}">
-                <a16:creationId xmlns:a16="http://schemas.microsoft.com/office/drawing/2014/main" id="{670F0C23-FE50-8839-B107-C21CD5459C01}"/>
+                <a16:creationId xmlns:a16="http://schemas.microsoft.com/office/drawing/2014/main" xmlns="" id="{670F0C23-FE50-8839-B107-C21CD5459C01}"/>
               </a:ext>
             </a:extLst>
           </p:cNvPr>
@@ -32027,7 +32057,7 @@
           <p:cNvPr id="3" name="Marcador de contenido 2">
             <a:extLst>
               <a:ext uri="{FF2B5EF4-FFF2-40B4-BE49-F238E27FC236}">
-                <a16:creationId xmlns:a16="http://schemas.microsoft.com/office/drawing/2014/main" id="{3D773A57-4E75-6D1E-BD6A-ACA49DF5A864}"/>
+                <a16:creationId xmlns:a16="http://schemas.microsoft.com/office/drawing/2014/main" xmlns="" id="{3D773A57-4E75-6D1E-BD6A-ACA49DF5A864}"/>
               </a:ext>
             </a:extLst>
           </p:cNvPr>
@@ -32117,7 +32147,7 @@
           <p:cNvPr id="4" name="Marcador de contenido 3">
             <a:extLst>
               <a:ext uri="{FF2B5EF4-FFF2-40B4-BE49-F238E27FC236}">
-                <a16:creationId xmlns:a16="http://schemas.microsoft.com/office/drawing/2014/main" id="{3AE55076-95D7-6938-72E0-C14CE7451679}"/>
+                <a16:creationId xmlns:a16="http://schemas.microsoft.com/office/drawing/2014/main" xmlns="" id="{3AE55076-95D7-6938-72E0-C14CE7451679}"/>
               </a:ext>
             </a:extLst>
           </p:cNvPr>
@@ -32241,7 +32271,7 @@
         <p:cNvPr id="1" name="">
           <a:extLst>
             <a:ext uri="{FF2B5EF4-FFF2-40B4-BE49-F238E27FC236}">
-              <a16:creationId xmlns:a16="http://schemas.microsoft.com/office/drawing/2014/main" id="{BAA8E253-6747-9B1F-FBE9-E6CD87C5A445}"/>
+              <a16:creationId xmlns:a16="http://schemas.microsoft.com/office/drawing/2014/main" xmlns="" id="{BAA8E253-6747-9B1F-FBE9-E6CD87C5A445}"/>
             </a:ext>
           </a:extLst>
         </p:cNvPr>
@@ -32261,7 +32291,7 @@
           <p:cNvPr id="2" name="Título 1">
             <a:extLst>
               <a:ext uri="{FF2B5EF4-FFF2-40B4-BE49-F238E27FC236}">
-                <a16:creationId xmlns:a16="http://schemas.microsoft.com/office/drawing/2014/main" id="{6396FCE1-269E-47E7-6B0B-83CB1C803157}"/>
+                <a16:creationId xmlns:a16="http://schemas.microsoft.com/office/drawing/2014/main" xmlns="" id="{6396FCE1-269E-47E7-6B0B-83CB1C803157}"/>
               </a:ext>
             </a:extLst>
           </p:cNvPr>
@@ -32291,7 +32321,7 @@
           <p:cNvPr id="3" name="Marcador de contenido 2">
             <a:extLst>
               <a:ext uri="{FF2B5EF4-FFF2-40B4-BE49-F238E27FC236}">
-                <a16:creationId xmlns:a16="http://schemas.microsoft.com/office/drawing/2014/main" id="{65EDB4A7-80AE-EB79-5B23-32C347FD2312}"/>
+                <a16:creationId xmlns:a16="http://schemas.microsoft.com/office/drawing/2014/main" xmlns="" id="{65EDB4A7-80AE-EB79-5B23-32C347FD2312}"/>
               </a:ext>
             </a:extLst>
           </p:cNvPr>
@@ -32319,7 +32349,7 @@
           <p:cNvPr id="4" name="Marcador de contenido 3">
             <a:extLst>
               <a:ext uri="{FF2B5EF4-FFF2-40B4-BE49-F238E27FC236}">
-                <a16:creationId xmlns:a16="http://schemas.microsoft.com/office/drawing/2014/main" id="{1D6431B4-69A1-CB17-CB70-D9632CC15269}"/>
+                <a16:creationId xmlns:a16="http://schemas.microsoft.com/office/drawing/2014/main" xmlns="" id="{1D6431B4-69A1-CB17-CB70-D9632CC15269}"/>
               </a:ext>
             </a:extLst>
           </p:cNvPr>
@@ -32379,7 +32409,7 @@
         <p:cNvPr id="1" name="">
           <a:extLst>
             <a:ext uri="{FF2B5EF4-FFF2-40B4-BE49-F238E27FC236}">
-              <a16:creationId xmlns:a16="http://schemas.microsoft.com/office/drawing/2014/main" id="{1B05AE3F-3E46-25CF-7795-E72C123AB1CA}"/>
+              <a16:creationId xmlns:a16="http://schemas.microsoft.com/office/drawing/2014/main" xmlns="" id="{1B05AE3F-3E46-25CF-7795-E72C123AB1CA}"/>
             </a:ext>
           </a:extLst>
         </p:cNvPr>
@@ -32399,7 +32429,7 @@
           <p:cNvPr id="2" name="Título 1">
             <a:extLst>
               <a:ext uri="{FF2B5EF4-FFF2-40B4-BE49-F238E27FC236}">
-                <a16:creationId xmlns:a16="http://schemas.microsoft.com/office/drawing/2014/main" id="{D86BF721-CFA0-0B79-12AE-967BA8A80533}"/>
+                <a16:creationId xmlns:a16="http://schemas.microsoft.com/office/drawing/2014/main" xmlns="" id="{D86BF721-CFA0-0B79-12AE-967BA8A80533}"/>
               </a:ext>
             </a:extLst>
           </p:cNvPr>
@@ -32429,7 +32459,7 @@
           <p:cNvPr id="3" name="Marcador de contenido 2">
             <a:extLst>
               <a:ext uri="{FF2B5EF4-FFF2-40B4-BE49-F238E27FC236}">
-                <a16:creationId xmlns:a16="http://schemas.microsoft.com/office/drawing/2014/main" id="{1A4A8CD1-135B-E096-AE71-BC1C655CF49F}"/>
+                <a16:creationId xmlns:a16="http://schemas.microsoft.com/office/drawing/2014/main" xmlns="" id="{1A4A8CD1-135B-E096-AE71-BC1C655CF49F}"/>
               </a:ext>
             </a:extLst>
           </p:cNvPr>
@@ -32457,7 +32487,7 @@
           <p:cNvPr id="4" name="Marcador de contenido 3">
             <a:extLst>
               <a:ext uri="{FF2B5EF4-FFF2-40B4-BE49-F238E27FC236}">
-                <a16:creationId xmlns:a16="http://schemas.microsoft.com/office/drawing/2014/main" id="{8A49EB46-BCFB-0531-809D-2CF4707CCB6C}"/>
+                <a16:creationId xmlns:a16="http://schemas.microsoft.com/office/drawing/2014/main" xmlns="" id="{8A49EB46-BCFB-0531-809D-2CF4707CCB6C}"/>
               </a:ext>
             </a:extLst>
           </p:cNvPr>
@@ -32507,7 +32537,7 @@
         <p:cNvPr id="1" name="">
           <a:extLst>
             <a:ext uri="{FF2B5EF4-FFF2-40B4-BE49-F238E27FC236}">
-              <a16:creationId xmlns:a16="http://schemas.microsoft.com/office/drawing/2014/main" id="{3F99DBFF-3CCC-FB73-1D73-C13DE4E739D6}"/>
+              <a16:creationId xmlns:a16="http://schemas.microsoft.com/office/drawing/2014/main" xmlns="" id="{3F99DBFF-3CCC-FB73-1D73-C13DE4E739D6}"/>
             </a:ext>
           </a:extLst>
         </p:cNvPr>
@@ -32527,7 +32557,7 @@
           <p:cNvPr id="2" name="Título 1">
             <a:extLst>
               <a:ext uri="{FF2B5EF4-FFF2-40B4-BE49-F238E27FC236}">
-                <a16:creationId xmlns:a16="http://schemas.microsoft.com/office/drawing/2014/main" id="{AFC0F982-AE5F-0EEC-B904-65B61080AE39}"/>
+                <a16:creationId xmlns:a16="http://schemas.microsoft.com/office/drawing/2014/main" xmlns="" id="{AFC0F982-AE5F-0EEC-B904-65B61080AE39}"/>
               </a:ext>
             </a:extLst>
           </p:cNvPr>
@@ -32557,7 +32587,7 @@
           <p:cNvPr id="3" name="Marcador de contenido 2">
             <a:extLst>
               <a:ext uri="{FF2B5EF4-FFF2-40B4-BE49-F238E27FC236}">
-                <a16:creationId xmlns:a16="http://schemas.microsoft.com/office/drawing/2014/main" id="{DF291CFD-A504-813F-7B16-EFDAA7340469}"/>
+                <a16:creationId xmlns:a16="http://schemas.microsoft.com/office/drawing/2014/main" xmlns="" id="{DF291CFD-A504-813F-7B16-EFDAA7340469}"/>
               </a:ext>
             </a:extLst>
           </p:cNvPr>
@@ -32585,7 +32615,7 @@
           <p:cNvPr id="4" name="Marcador de contenido 3">
             <a:extLst>
               <a:ext uri="{FF2B5EF4-FFF2-40B4-BE49-F238E27FC236}">
-                <a16:creationId xmlns:a16="http://schemas.microsoft.com/office/drawing/2014/main" id="{EB51802A-7BF4-F0A5-635F-154D94CAF798}"/>
+                <a16:creationId xmlns:a16="http://schemas.microsoft.com/office/drawing/2014/main" xmlns="" id="{EB51802A-7BF4-F0A5-635F-154D94CAF798}"/>
               </a:ext>
             </a:extLst>
           </p:cNvPr>
@@ -32619,7 +32649,7 @@
           <p:cNvPr id="6" name="Picture 5" descr="A metal pipe on a machine&#10;&#10;AI-generated content may be incorrect.">
             <a:extLst>
               <a:ext uri="{FF2B5EF4-FFF2-40B4-BE49-F238E27FC236}">
-                <a16:creationId xmlns:a16="http://schemas.microsoft.com/office/drawing/2014/main" id="{CFF35E7E-8475-93E6-540B-6FCD13109CD0}"/>
+                <a16:creationId xmlns:a16="http://schemas.microsoft.com/office/drawing/2014/main" xmlns="" id="{CFF35E7E-8475-93E6-540B-6FCD13109CD0}"/>
               </a:ext>
             </a:extLst>
           </p:cNvPr>
@@ -32685,7 +32715,7 @@
           <p:cNvPr id="2" name="Título 1">
             <a:extLst>
               <a:ext uri="{FF2B5EF4-FFF2-40B4-BE49-F238E27FC236}">
-                <a16:creationId xmlns:a16="http://schemas.microsoft.com/office/drawing/2014/main" id="{BAB3C702-D01F-22C8-A53B-ED6B01BB12EA}"/>
+                <a16:creationId xmlns:a16="http://schemas.microsoft.com/office/drawing/2014/main" xmlns="" id="{BAB3C702-D01F-22C8-A53B-ED6B01BB12EA}"/>
               </a:ext>
             </a:extLst>
           </p:cNvPr>
@@ -32718,7 +32748,7 @@
           <p:cNvPr id="3" name="Marcador de contenido 2">
             <a:extLst>
               <a:ext uri="{FF2B5EF4-FFF2-40B4-BE49-F238E27FC236}">
-                <a16:creationId xmlns:a16="http://schemas.microsoft.com/office/drawing/2014/main" id="{2D8CD9DD-E26B-97A0-50D8-9A66444B9BE2}"/>
+                <a16:creationId xmlns:a16="http://schemas.microsoft.com/office/drawing/2014/main" xmlns="" id="{2D8CD9DD-E26B-97A0-50D8-9A66444B9BE2}"/>
               </a:ext>
             </a:extLst>
           </p:cNvPr>
@@ -33210,7 +33240,7 @@
         <p:cNvPr id="1" name="">
           <a:extLst>
             <a:ext uri="{FF2B5EF4-FFF2-40B4-BE49-F238E27FC236}">
-              <a16:creationId xmlns:a16="http://schemas.microsoft.com/office/drawing/2014/main" id="{31C6875D-C95D-1D74-F9EE-216415E755A6}"/>
+              <a16:creationId xmlns:a16="http://schemas.microsoft.com/office/drawing/2014/main" xmlns="" id="{31C6875D-C95D-1D74-F9EE-216415E755A6}"/>
             </a:ext>
           </a:extLst>
         </p:cNvPr>
@@ -33230,7 +33260,7 @@
           <p:cNvPr id="10" name="Imagen 9">
             <a:extLst>
               <a:ext uri="{FF2B5EF4-FFF2-40B4-BE49-F238E27FC236}">
-                <a16:creationId xmlns:a16="http://schemas.microsoft.com/office/drawing/2014/main" id="{8AD9506E-FD56-EBC8-13F7-CB8F7C5F557C}"/>
+                <a16:creationId xmlns:a16="http://schemas.microsoft.com/office/drawing/2014/main" xmlns="" id="{8AD9506E-FD56-EBC8-13F7-CB8F7C5F557C}"/>
               </a:ext>
             </a:extLst>
           </p:cNvPr>
@@ -33259,7 +33289,7 @@
           <p:cNvPr id="2" name="Título 1">
             <a:extLst>
               <a:ext uri="{FF2B5EF4-FFF2-40B4-BE49-F238E27FC236}">
-                <a16:creationId xmlns:a16="http://schemas.microsoft.com/office/drawing/2014/main" id="{AC643883-C073-62C1-5633-BFD9AB76F757}"/>
+                <a16:creationId xmlns:a16="http://schemas.microsoft.com/office/drawing/2014/main" xmlns="" id="{AC643883-C073-62C1-5633-BFD9AB76F757}"/>
               </a:ext>
             </a:extLst>
           </p:cNvPr>
@@ -33292,7 +33322,7 @@
           <p:cNvPr id="3" name="Marcador de contenido 2">
             <a:extLst>
               <a:ext uri="{FF2B5EF4-FFF2-40B4-BE49-F238E27FC236}">
-                <a16:creationId xmlns:a16="http://schemas.microsoft.com/office/drawing/2014/main" id="{2685F9AA-AC6D-61A2-78E4-7AC46AF7ACB5}"/>
+                <a16:creationId xmlns:a16="http://schemas.microsoft.com/office/drawing/2014/main" xmlns="" id="{2685F9AA-AC6D-61A2-78E4-7AC46AF7ACB5}"/>
               </a:ext>
             </a:extLst>
           </p:cNvPr>
@@ -33371,7 +33401,7 @@
           <p:cNvPr id="4" name="Marcador de contenido 3">
             <a:extLst>
               <a:ext uri="{FF2B5EF4-FFF2-40B4-BE49-F238E27FC236}">
-                <a16:creationId xmlns:a16="http://schemas.microsoft.com/office/drawing/2014/main" id="{2CC351AA-7BF7-138C-B3C7-5032644CF2DE}"/>
+                <a16:creationId xmlns:a16="http://schemas.microsoft.com/office/drawing/2014/main" xmlns="" id="{2CC351AA-7BF7-138C-B3C7-5032644CF2DE}"/>
               </a:ext>
             </a:extLst>
           </p:cNvPr>
@@ -33433,7 +33463,7 @@
           <p:cNvPr id="5" name="Chart 2">
             <a:extLst>
               <a:ext uri="{FF2B5EF4-FFF2-40B4-BE49-F238E27FC236}">
-                <a16:creationId xmlns:a16="http://schemas.microsoft.com/office/drawing/2014/main" id="{5E28E901-0E6D-7A41-49E7-C7B810DB2845}"/>
+                <a16:creationId xmlns:a16="http://schemas.microsoft.com/office/drawing/2014/main" xmlns="" id="{5E28E901-0E6D-7A41-49E7-C7B810DB2845}"/>
               </a:ext>
             </a:extLst>
           </p:cNvPr>
@@ -33465,7 +33495,7 @@
               <p:cNvPr id="6" name="CuadroTexto 5">
                 <a:extLst>
                   <a:ext uri="{FF2B5EF4-FFF2-40B4-BE49-F238E27FC236}">
-                    <a16:creationId xmlns:a16="http://schemas.microsoft.com/office/drawing/2014/main" id="{61FA3746-FE94-2D6A-C0C9-5B8C833E10A9}"/>
+                    <a16:creationId xmlns:a16="http://schemas.microsoft.com/office/drawing/2014/main" xmlns="" id="{61FA3746-FE94-2D6A-C0C9-5B8C833E10A9}"/>
                   </a:ext>
                 </a:extLst>
               </p:cNvPr>
@@ -33655,7 +33685,7 @@
               <p:cNvPr id="7" name="CuadroTexto 6">
                 <a:extLst>
                   <a:ext uri="{FF2B5EF4-FFF2-40B4-BE49-F238E27FC236}">
-                    <a16:creationId xmlns:a16="http://schemas.microsoft.com/office/drawing/2014/main" id="{C7CD6F09-E80E-CC70-CFFD-ECC62F245C4A}"/>
+                    <a16:creationId xmlns:a16="http://schemas.microsoft.com/office/drawing/2014/main" xmlns="" id="{C7CD6F09-E80E-CC70-CFFD-ECC62F245C4A}"/>
                   </a:ext>
                 </a:extLst>
               </p:cNvPr>
@@ -33918,7 +33948,7 @@
               <p:cNvPr id="8" name="CuadroTexto 7">
                 <a:extLst>
                   <a:ext uri="{FF2B5EF4-FFF2-40B4-BE49-F238E27FC236}">
-                    <a16:creationId xmlns:a16="http://schemas.microsoft.com/office/drawing/2014/main" id="{0E12C880-5F16-BC4D-02C5-BBB868263AAD}"/>
+                    <a16:creationId xmlns:a16="http://schemas.microsoft.com/office/drawing/2014/main" xmlns="" id="{0E12C880-5F16-BC4D-02C5-BBB868263AAD}"/>
                   </a:ext>
                 </a:extLst>
               </p:cNvPr>
@@ -34278,7 +34308,7 @@
           <p:cNvPr id="13" name="CuadroTexto 12">
             <a:extLst>
               <a:ext uri="{FF2B5EF4-FFF2-40B4-BE49-F238E27FC236}">
-                <a16:creationId xmlns:a16="http://schemas.microsoft.com/office/drawing/2014/main" id="{0C21B8DD-7ABD-2A11-C645-94BBE1F7B2CE}"/>
+                <a16:creationId xmlns:a16="http://schemas.microsoft.com/office/drawing/2014/main" xmlns="" id="{0C21B8DD-7ABD-2A11-C645-94BBE1F7B2CE}"/>
               </a:ext>
             </a:extLst>
           </p:cNvPr>
@@ -34313,7 +34343,7 @@
           <p:cNvPr id="14" name="CuadroTexto 13">
             <a:extLst>
               <a:ext uri="{FF2B5EF4-FFF2-40B4-BE49-F238E27FC236}">
-                <a16:creationId xmlns:a16="http://schemas.microsoft.com/office/drawing/2014/main" id="{7B174281-B4B3-1CB6-86AE-440AD45CFA13}"/>
+                <a16:creationId xmlns:a16="http://schemas.microsoft.com/office/drawing/2014/main" xmlns="" id="{7B174281-B4B3-1CB6-86AE-440AD45CFA13}"/>
               </a:ext>
             </a:extLst>
           </p:cNvPr>
@@ -34372,7 +34402,7 @@
         <p:cNvPr id="1" name="">
           <a:extLst>
             <a:ext uri="{FF2B5EF4-FFF2-40B4-BE49-F238E27FC236}">
-              <a16:creationId xmlns:a16="http://schemas.microsoft.com/office/drawing/2014/main" id="{D819ECBA-0FE3-A262-6DF8-976C93CBBDA3}"/>
+              <a16:creationId xmlns:a16="http://schemas.microsoft.com/office/drawing/2014/main" xmlns="" id="{D819ECBA-0FE3-A262-6DF8-976C93CBBDA3}"/>
             </a:ext>
           </a:extLst>
         </p:cNvPr>
@@ -34392,7 +34422,7 @@
           <p:cNvPr id="2" name="Título 1">
             <a:extLst>
               <a:ext uri="{FF2B5EF4-FFF2-40B4-BE49-F238E27FC236}">
-                <a16:creationId xmlns:a16="http://schemas.microsoft.com/office/drawing/2014/main" id="{8B3DFA6D-9F9C-65BA-1D43-48404335AA47}"/>
+                <a16:creationId xmlns:a16="http://schemas.microsoft.com/office/drawing/2014/main" xmlns="" id="{8B3DFA6D-9F9C-65BA-1D43-48404335AA47}"/>
               </a:ext>
             </a:extLst>
           </p:cNvPr>
@@ -34427,7 +34457,7 @@
               <p:cNvPr id="3" name="Marcador de contenido 2">
                 <a:extLst>
                   <a:ext uri="{FF2B5EF4-FFF2-40B4-BE49-F238E27FC236}">
-                    <a16:creationId xmlns:a16="http://schemas.microsoft.com/office/drawing/2014/main" id="{9D212CE2-B569-5765-664D-52BD84671B53}"/>
+                    <a16:creationId xmlns:a16="http://schemas.microsoft.com/office/drawing/2014/main" xmlns="" id="{9D212CE2-B569-5765-664D-52BD84671B53}"/>
                   </a:ext>
                 </a:extLst>
               </p:cNvPr>
@@ -35267,7 +35297,7 @@
           <p:cNvPr id="11" name="Imagen 10">
             <a:extLst>
               <a:ext uri="{FF2B5EF4-FFF2-40B4-BE49-F238E27FC236}">
-                <a16:creationId xmlns:a16="http://schemas.microsoft.com/office/drawing/2014/main" id="{4171342F-33BD-9E54-AFF9-8592B2450642}"/>
+                <a16:creationId xmlns:a16="http://schemas.microsoft.com/office/drawing/2014/main" xmlns="" id="{4171342F-33BD-9E54-AFF9-8592B2450642}"/>
               </a:ext>
             </a:extLst>
           </p:cNvPr>
@@ -35297,7 +35327,7 @@
           <p:cNvPr id="13" name="Abrir llave 12">
             <a:extLst>
               <a:ext uri="{FF2B5EF4-FFF2-40B4-BE49-F238E27FC236}">
-                <a16:creationId xmlns:a16="http://schemas.microsoft.com/office/drawing/2014/main" id="{E0BBBB8D-80D2-0277-2D83-5839EDB6890E}"/>
+                <a16:creationId xmlns:a16="http://schemas.microsoft.com/office/drawing/2014/main" xmlns="" id="{E0BBBB8D-80D2-0277-2D83-5839EDB6890E}"/>
               </a:ext>
             </a:extLst>
           </p:cNvPr>
@@ -35341,7 +35371,7 @@
           <p:cNvPr id="14" name="Abrir llave 13">
             <a:extLst>
               <a:ext uri="{FF2B5EF4-FFF2-40B4-BE49-F238E27FC236}">
-                <a16:creationId xmlns:a16="http://schemas.microsoft.com/office/drawing/2014/main" id="{B01E28D3-F041-7B60-80A1-C1D466F0E5E1}"/>
+                <a16:creationId xmlns:a16="http://schemas.microsoft.com/office/drawing/2014/main" xmlns="" id="{B01E28D3-F041-7B60-80A1-C1D466F0E5E1}"/>
               </a:ext>
             </a:extLst>
           </p:cNvPr>
@@ -35385,7 +35415,7 @@
           <p:cNvPr id="15" name="CuadroTexto 14">
             <a:extLst>
               <a:ext uri="{FF2B5EF4-FFF2-40B4-BE49-F238E27FC236}">
-                <a16:creationId xmlns:a16="http://schemas.microsoft.com/office/drawing/2014/main" id="{71392D05-5CB3-995F-825F-28AD09643899}"/>
+                <a16:creationId xmlns:a16="http://schemas.microsoft.com/office/drawing/2014/main" xmlns="" id="{71392D05-5CB3-995F-825F-28AD09643899}"/>
               </a:ext>
             </a:extLst>
           </p:cNvPr>
@@ -35421,7 +35451,7 @@
           <p:cNvPr id="16" name="CuadroTexto 15">
             <a:extLst>
               <a:ext uri="{FF2B5EF4-FFF2-40B4-BE49-F238E27FC236}">
-                <a16:creationId xmlns:a16="http://schemas.microsoft.com/office/drawing/2014/main" id="{071E4AFD-07EF-C366-4ACD-3295252BC030}"/>
+                <a16:creationId xmlns:a16="http://schemas.microsoft.com/office/drawing/2014/main" xmlns="" id="{071E4AFD-07EF-C366-4ACD-3295252BC030}"/>
               </a:ext>
             </a:extLst>
           </p:cNvPr>
@@ -35457,7 +35487,7 @@
           <p:cNvPr id="19" name="CuadroTexto 18">
             <a:extLst>
               <a:ext uri="{FF2B5EF4-FFF2-40B4-BE49-F238E27FC236}">
-                <a16:creationId xmlns:a16="http://schemas.microsoft.com/office/drawing/2014/main" id="{6E4EF6AD-030C-D1D9-14FB-843EC4460BEB}"/>
+                <a16:creationId xmlns:a16="http://schemas.microsoft.com/office/drawing/2014/main" xmlns="" id="{6E4EF6AD-030C-D1D9-14FB-843EC4460BEB}"/>
               </a:ext>
             </a:extLst>
           </p:cNvPr>
@@ -35516,7 +35546,7 @@
         <p:cNvPr id="1" name="">
           <a:extLst>
             <a:ext uri="{FF2B5EF4-FFF2-40B4-BE49-F238E27FC236}">
-              <a16:creationId xmlns:a16="http://schemas.microsoft.com/office/drawing/2014/main" id="{6BFCBCE7-4227-3A4F-7553-65FB8C0E2E15}"/>
+              <a16:creationId xmlns:a16="http://schemas.microsoft.com/office/drawing/2014/main" xmlns="" id="{6BFCBCE7-4227-3A4F-7553-65FB8C0E2E15}"/>
             </a:ext>
           </a:extLst>
         </p:cNvPr>
@@ -35536,7 +35566,7 @@
           <p:cNvPr id="2" name="Título 1">
             <a:extLst>
               <a:ext uri="{FF2B5EF4-FFF2-40B4-BE49-F238E27FC236}">
-                <a16:creationId xmlns:a16="http://schemas.microsoft.com/office/drawing/2014/main" id="{2845A44F-A3CC-A535-578F-D1159003EE11}"/>
+                <a16:creationId xmlns:a16="http://schemas.microsoft.com/office/drawing/2014/main" xmlns="" id="{2845A44F-A3CC-A535-578F-D1159003EE11}"/>
               </a:ext>
             </a:extLst>
           </p:cNvPr>
@@ -35571,7 +35601,7 @@
               <p:cNvPr id="3" name="Marcador de contenido 2">
                 <a:extLst>
                   <a:ext uri="{FF2B5EF4-FFF2-40B4-BE49-F238E27FC236}">
-                    <a16:creationId xmlns:a16="http://schemas.microsoft.com/office/drawing/2014/main" id="{9B47C1CA-1FBE-412A-E933-F868B5095F17}"/>
+                    <a16:creationId xmlns:a16="http://schemas.microsoft.com/office/drawing/2014/main" xmlns="" id="{9B47C1CA-1FBE-412A-E933-F868B5095F17}"/>
                   </a:ext>
                 </a:extLst>
               </p:cNvPr>
@@ -35928,7 +35958,7 @@
               <p:cNvPr id="4" name="Marcador de contenido 3">
                 <a:extLst>
                   <a:ext uri="{FF2B5EF4-FFF2-40B4-BE49-F238E27FC236}">
-                    <a16:creationId xmlns:a16="http://schemas.microsoft.com/office/drawing/2014/main" id="{33376411-7794-DBE3-8CFD-7FD77FD9B7E1}"/>
+                    <a16:creationId xmlns:a16="http://schemas.microsoft.com/office/drawing/2014/main" xmlns="" id="{33376411-7794-DBE3-8CFD-7FD77FD9B7E1}"/>
                   </a:ext>
                 </a:extLst>
               </p:cNvPr>
@@ -36062,7 +36092,7 @@
               <p:cNvPr id="9" name="Tabla 8">
                 <a:extLst>
                   <a:ext uri="{FF2B5EF4-FFF2-40B4-BE49-F238E27FC236}">
-                    <a16:creationId xmlns:a16="http://schemas.microsoft.com/office/drawing/2014/main" id="{98CA1BFB-021D-ADE1-A02E-3506BDC1A908}"/>
+                    <a16:creationId xmlns:a16="http://schemas.microsoft.com/office/drawing/2014/main" xmlns="" id="{98CA1BFB-021D-ADE1-A02E-3506BDC1A908}"/>
                   </a:ext>
                 </a:extLst>
               </p:cNvPr>
@@ -36079,7 +36109,7 @@
             </p:nvGraphicFramePr>
             <p:xfrm>
               <a:off x="838200" y="3811133"/>
-              <a:ext cx="6261821" cy="1847606"/>
+              <a:ext cx="6261821" cy="2660406"/>
             </p:xfrm>
             <a:graphic>
               <a:graphicData uri="http://schemas.openxmlformats.org/drawingml/2006/table">
@@ -36091,28 +36121,28 @@
                     <a:gridCol w="1207135">
                       <a:extLst>
                         <a:ext uri="{9D8B030D-6E8A-4147-A177-3AD203B41FA5}">
-                          <a16:colId xmlns:a16="http://schemas.microsoft.com/office/drawing/2014/main" val="4231280534"/>
+                          <a16:colId xmlns:a16="http://schemas.microsoft.com/office/drawing/2014/main" xmlns="" val="4231280534"/>
                         </a:ext>
                       </a:extLst>
                     </a:gridCol>
                     <a:gridCol w="1170305">
                       <a:extLst>
                         <a:ext uri="{9D8B030D-6E8A-4147-A177-3AD203B41FA5}">
-                          <a16:colId xmlns:a16="http://schemas.microsoft.com/office/drawing/2014/main" val="1923169229"/>
+                          <a16:colId xmlns:a16="http://schemas.microsoft.com/office/drawing/2014/main" xmlns="" val="1923169229"/>
                         </a:ext>
                       </a:extLst>
                     </a:gridCol>
                     <a:gridCol w="2041144">
                       <a:extLst>
                         <a:ext uri="{9D8B030D-6E8A-4147-A177-3AD203B41FA5}">
-                          <a16:colId xmlns:a16="http://schemas.microsoft.com/office/drawing/2014/main" val="3299784387"/>
+                          <a16:colId xmlns:a16="http://schemas.microsoft.com/office/drawing/2014/main" xmlns="" val="3299784387"/>
                         </a:ext>
                       </a:extLst>
                     </a:gridCol>
                     <a:gridCol w="1843237">
                       <a:extLst>
                         <a:ext uri="{9D8B030D-6E8A-4147-A177-3AD203B41FA5}">
-                          <a16:colId xmlns:a16="http://schemas.microsoft.com/office/drawing/2014/main" val="2309885579"/>
+                          <a16:colId xmlns:a16="http://schemas.microsoft.com/office/drawing/2014/main" xmlns="" val="2309885579"/>
                         </a:ext>
                       </a:extLst>
                     </a:gridCol>
@@ -36292,7 +36322,7 @@
                     </a:tc>
                     <a:extLst>
                       <a:ext uri="{0D108BD9-81ED-4DB2-BD59-A6C34878D82A}">
-                        <a16:rowId xmlns:a16="http://schemas.microsoft.com/office/drawing/2014/main" val="1334428884"/>
+                        <a16:rowId xmlns:a16="http://schemas.microsoft.com/office/drawing/2014/main" xmlns="" val="1334428884"/>
                       </a:ext>
                     </a:extLst>
                   </a:tr>
@@ -36428,7 +36458,7 @@
                     </a:tc>
                     <a:extLst>
                       <a:ext uri="{0D108BD9-81ED-4DB2-BD59-A6C34878D82A}">
-                        <a16:rowId xmlns:a16="http://schemas.microsoft.com/office/drawing/2014/main" val="3115401656"/>
+                        <a16:rowId xmlns:a16="http://schemas.microsoft.com/office/drawing/2014/main" xmlns="" val="3115401656"/>
                       </a:ext>
                     </a:extLst>
                   </a:tr>
@@ -36563,7 +36593,7 @@
                     </a:tc>
                     <a:extLst>
                       <a:ext uri="{0D108BD9-81ED-4DB2-BD59-A6C34878D82A}">
-                        <a16:rowId xmlns:a16="http://schemas.microsoft.com/office/drawing/2014/main" val="1033675829"/>
+                        <a16:rowId xmlns:a16="http://schemas.microsoft.com/office/drawing/2014/main" xmlns="" val="1033675829"/>
                       </a:ext>
                     </a:extLst>
                   </a:tr>
@@ -36699,7 +36729,7 @@
                     </a:tc>
                     <a:extLst>
                       <a:ext uri="{0D108BD9-81ED-4DB2-BD59-A6C34878D82A}">
-                        <a16:rowId xmlns:a16="http://schemas.microsoft.com/office/drawing/2014/main" val="2867198737"/>
+                        <a16:rowId xmlns:a16="http://schemas.microsoft.com/office/drawing/2014/main" xmlns="" val="2867198737"/>
                       </a:ext>
                     </a:extLst>
                   </a:tr>
@@ -36834,7 +36864,7 @@
                     </a:tc>
                     <a:extLst>
                       <a:ext uri="{0D108BD9-81ED-4DB2-BD59-A6C34878D82A}">
-                        <a16:rowId xmlns:a16="http://schemas.microsoft.com/office/drawing/2014/main" val="2125488404"/>
+                        <a16:rowId xmlns:a16="http://schemas.microsoft.com/office/drawing/2014/main" xmlns="" val="2125488404"/>
                       </a:ext>
                     </a:extLst>
                   </a:tr>
@@ -37602,7 +37632,7 @@
           <p:cNvPr id="11" name="Rectángulo 10">
             <a:extLst>
               <a:ext uri="{FF2B5EF4-FFF2-40B4-BE49-F238E27FC236}">
-                <a16:creationId xmlns:a16="http://schemas.microsoft.com/office/drawing/2014/main" id="{5095EFC9-E205-7BDE-EED9-84ACF52F2416}"/>
+                <a16:creationId xmlns:a16="http://schemas.microsoft.com/office/drawing/2014/main" xmlns="" id="{5095EFC9-E205-7BDE-EED9-84ACF52F2416}"/>
               </a:ext>
             </a:extLst>
           </p:cNvPr>
@@ -37651,7 +37681,7 @@
           <p:cNvPr id="12" name="Rectángulo 11">
             <a:extLst>
               <a:ext uri="{FF2B5EF4-FFF2-40B4-BE49-F238E27FC236}">
-                <a16:creationId xmlns:a16="http://schemas.microsoft.com/office/drawing/2014/main" id="{F1920D2E-75E3-40C4-47B1-53C315C071B7}"/>
+                <a16:creationId xmlns:a16="http://schemas.microsoft.com/office/drawing/2014/main" xmlns="" id="{F1920D2E-75E3-40C4-47B1-53C315C071B7}"/>
               </a:ext>
             </a:extLst>
           </p:cNvPr>
@@ -37701,7 +37731,7 @@
           <p:cNvPr id="14" name="Conector recto 13">
             <a:extLst>
               <a:ext uri="{FF2B5EF4-FFF2-40B4-BE49-F238E27FC236}">
-                <a16:creationId xmlns:a16="http://schemas.microsoft.com/office/drawing/2014/main" id="{1EE5BF10-512B-83CF-68A9-867146FAA8B4}"/>
+                <a16:creationId xmlns:a16="http://schemas.microsoft.com/office/drawing/2014/main" xmlns="" id="{1EE5BF10-512B-83CF-68A9-867146FAA8B4}"/>
               </a:ext>
             </a:extLst>
           </p:cNvPr>
@@ -37740,7 +37770,7 @@
           <p:cNvPr id="17" name="Conector recto 16">
             <a:extLst>
               <a:ext uri="{FF2B5EF4-FFF2-40B4-BE49-F238E27FC236}">
-                <a16:creationId xmlns:a16="http://schemas.microsoft.com/office/drawing/2014/main" id="{F8835413-E296-86F1-2413-0044EA33819B}"/>
+                <a16:creationId xmlns:a16="http://schemas.microsoft.com/office/drawing/2014/main" xmlns="" id="{F8835413-E296-86F1-2413-0044EA33819B}"/>
               </a:ext>
             </a:extLst>
           </p:cNvPr>
@@ -37779,7 +37809,7 @@
           <p:cNvPr id="19" name="Conector recto 18">
             <a:extLst>
               <a:ext uri="{FF2B5EF4-FFF2-40B4-BE49-F238E27FC236}">
-                <a16:creationId xmlns:a16="http://schemas.microsoft.com/office/drawing/2014/main" id="{1B2D845B-7087-3602-3CA9-E2B8E95AB6E8}"/>
+                <a16:creationId xmlns:a16="http://schemas.microsoft.com/office/drawing/2014/main" xmlns="" id="{1B2D845B-7087-3602-3CA9-E2B8E95AB6E8}"/>
               </a:ext>
             </a:extLst>
           </p:cNvPr>
@@ -37818,7 +37848,7 @@
           <p:cNvPr id="22" name="Conector recto 21">
             <a:extLst>
               <a:ext uri="{FF2B5EF4-FFF2-40B4-BE49-F238E27FC236}">
-                <a16:creationId xmlns:a16="http://schemas.microsoft.com/office/drawing/2014/main" id="{11AB5E83-A8AA-0B74-F944-196109C24502}"/>
+                <a16:creationId xmlns:a16="http://schemas.microsoft.com/office/drawing/2014/main" xmlns="" id="{11AB5E83-A8AA-0B74-F944-196109C24502}"/>
               </a:ext>
             </a:extLst>
           </p:cNvPr>
@@ -37857,7 +37887,7 @@
           <p:cNvPr id="25" name="Conector recto 24">
             <a:extLst>
               <a:ext uri="{FF2B5EF4-FFF2-40B4-BE49-F238E27FC236}">
-                <a16:creationId xmlns:a16="http://schemas.microsoft.com/office/drawing/2014/main" id="{4F5F5433-B5F6-7D1B-3AB2-64E901A5EDD7}"/>
+                <a16:creationId xmlns:a16="http://schemas.microsoft.com/office/drawing/2014/main" xmlns="" id="{4F5F5433-B5F6-7D1B-3AB2-64E901A5EDD7}"/>
               </a:ext>
             </a:extLst>
           </p:cNvPr>
@@ -37896,7 +37926,7 @@
           <p:cNvPr id="28" name="Conector recto 27">
             <a:extLst>
               <a:ext uri="{FF2B5EF4-FFF2-40B4-BE49-F238E27FC236}">
-                <a16:creationId xmlns:a16="http://schemas.microsoft.com/office/drawing/2014/main" id="{E5664ADB-503E-0D4D-FC40-F342CB76DE76}"/>
+                <a16:creationId xmlns:a16="http://schemas.microsoft.com/office/drawing/2014/main" xmlns="" id="{E5664ADB-503E-0D4D-FC40-F342CB76DE76}"/>
               </a:ext>
             </a:extLst>
           </p:cNvPr>
@@ -37935,7 +37965,7 @@
           <p:cNvPr id="32" name="Conector recto 31">
             <a:extLst>
               <a:ext uri="{FF2B5EF4-FFF2-40B4-BE49-F238E27FC236}">
-                <a16:creationId xmlns:a16="http://schemas.microsoft.com/office/drawing/2014/main" id="{41689905-FEF3-814B-2CEF-8D2C69CF4D71}"/>
+                <a16:creationId xmlns:a16="http://schemas.microsoft.com/office/drawing/2014/main" xmlns="" id="{41689905-FEF3-814B-2CEF-8D2C69CF4D71}"/>
               </a:ext>
             </a:extLst>
           </p:cNvPr>
@@ -37974,7 +38004,7 @@
           <p:cNvPr id="35" name="Conector recto 34">
             <a:extLst>
               <a:ext uri="{FF2B5EF4-FFF2-40B4-BE49-F238E27FC236}">
-                <a16:creationId xmlns:a16="http://schemas.microsoft.com/office/drawing/2014/main" id="{2A1609FC-EA89-E8CE-5936-3D54BD98D145}"/>
+                <a16:creationId xmlns:a16="http://schemas.microsoft.com/office/drawing/2014/main" xmlns="" id="{2A1609FC-EA89-E8CE-5936-3D54BD98D145}"/>
               </a:ext>
             </a:extLst>
           </p:cNvPr>
@@ -38013,7 +38043,7 @@
           <p:cNvPr id="38" name="CuadroTexto 37">
             <a:extLst>
               <a:ext uri="{FF2B5EF4-FFF2-40B4-BE49-F238E27FC236}">
-                <a16:creationId xmlns:a16="http://schemas.microsoft.com/office/drawing/2014/main" id="{5FCB0778-1654-B6B4-8BA1-3D5727A1CC3D}"/>
+                <a16:creationId xmlns:a16="http://schemas.microsoft.com/office/drawing/2014/main" xmlns="" id="{5FCB0778-1654-B6B4-8BA1-3D5727A1CC3D}"/>
               </a:ext>
             </a:extLst>
           </p:cNvPr>
@@ -38048,7 +38078,7 @@
           <p:cNvPr id="39" name="CuadroTexto 38">
             <a:extLst>
               <a:ext uri="{FF2B5EF4-FFF2-40B4-BE49-F238E27FC236}">
-                <a16:creationId xmlns:a16="http://schemas.microsoft.com/office/drawing/2014/main" id="{17CEBE75-1994-6BCE-472F-8E7809BDADF8}"/>
+                <a16:creationId xmlns:a16="http://schemas.microsoft.com/office/drawing/2014/main" xmlns="" id="{17CEBE75-1994-6BCE-472F-8E7809BDADF8}"/>
               </a:ext>
             </a:extLst>
           </p:cNvPr>
@@ -38083,7 +38113,7 @@
           <p:cNvPr id="40" name="CuadroTexto 39">
             <a:extLst>
               <a:ext uri="{FF2B5EF4-FFF2-40B4-BE49-F238E27FC236}">
-                <a16:creationId xmlns:a16="http://schemas.microsoft.com/office/drawing/2014/main" id="{5D1A0A17-21C4-C698-DA37-49B7314640A8}"/>
+                <a16:creationId xmlns:a16="http://schemas.microsoft.com/office/drawing/2014/main" xmlns="" id="{5D1A0A17-21C4-C698-DA37-49B7314640A8}"/>
               </a:ext>
             </a:extLst>
           </p:cNvPr>
@@ -38118,7 +38148,7 @@
           <p:cNvPr id="41" name="CuadroTexto 40">
             <a:extLst>
               <a:ext uri="{FF2B5EF4-FFF2-40B4-BE49-F238E27FC236}">
-                <a16:creationId xmlns:a16="http://schemas.microsoft.com/office/drawing/2014/main" id="{1EB65284-6CAB-4A7D-CEC5-E9DB0295E301}"/>
+                <a16:creationId xmlns:a16="http://schemas.microsoft.com/office/drawing/2014/main" xmlns="" id="{1EB65284-6CAB-4A7D-CEC5-E9DB0295E301}"/>
               </a:ext>
             </a:extLst>
           </p:cNvPr>
@@ -38177,7 +38207,7 @@
         <p:cNvPr id="1" name="">
           <a:extLst>
             <a:ext uri="{FF2B5EF4-FFF2-40B4-BE49-F238E27FC236}">
-              <a16:creationId xmlns:a16="http://schemas.microsoft.com/office/drawing/2014/main" id="{872BFE6A-2DB1-E0D0-9400-F02E1069CC92}"/>
+              <a16:creationId xmlns:a16="http://schemas.microsoft.com/office/drawing/2014/main" xmlns="" id="{872BFE6A-2DB1-E0D0-9400-F02E1069CC92}"/>
             </a:ext>
           </a:extLst>
         </p:cNvPr>
@@ -38197,7 +38227,7 @@
           <p:cNvPr id="2" name="Título 1">
             <a:extLst>
               <a:ext uri="{FF2B5EF4-FFF2-40B4-BE49-F238E27FC236}">
-                <a16:creationId xmlns:a16="http://schemas.microsoft.com/office/drawing/2014/main" id="{734A44EE-5DC6-76A6-8360-7880E3E694E1}"/>
+                <a16:creationId xmlns:a16="http://schemas.microsoft.com/office/drawing/2014/main" xmlns="" id="{734A44EE-5DC6-76A6-8360-7880E3E694E1}"/>
               </a:ext>
             </a:extLst>
           </p:cNvPr>
@@ -38232,7 +38262,7 @@
               <p:cNvPr id="3" name="Marcador de contenido 2">
                 <a:extLst>
                   <a:ext uri="{FF2B5EF4-FFF2-40B4-BE49-F238E27FC236}">
-                    <a16:creationId xmlns:a16="http://schemas.microsoft.com/office/drawing/2014/main" id="{33643874-1905-7EFB-B2A0-9A8BC1D7A8BD}"/>
+                    <a16:creationId xmlns:a16="http://schemas.microsoft.com/office/drawing/2014/main" xmlns="" id="{33643874-1905-7EFB-B2A0-9A8BC1D7A8BD}"/>
                   </a:ext>
                 </a:extLst>
               </p:cNvPr>
@@ -39095,7 +39125,7 @@
               <p:cNvPr id="4" name="Marcador de contenido 3">
                 <a:extLst>
                   <a:ext uri="{FF2B5EF4-FFF2-40B4-BE49-F238E27FC236}">
-                    <a16:creationId xmlns:a16="http://schemas.microsoft.com/office/drawing/2014/main" id="{317D7AD1-7B06-B41D-A2C7-6563599477F1}"/>
+                    <a16:creationId xmlns:a16="http://schemas.microsoft.com/office/drawing/2014/main" xmlns="" id="{317D7AD1-7B06-B41D-A2C7-6563599477F1}"/>
                   </a:ext>
                 </a:extLst>
               </p:cNvPr>
@@ -39449,7 +39479,7 @@
           <p:cNvPr id="9" name="Abrir llave 8">
             <a:extLst>
               <a:ext uri="{FF2B5EF4-FFF2-40B4-BE49-F238E27FC236}">
-                <a16:creationId xmlns:a16="http://schemas.microsoft.com/office/drawing/2014/main" id="{6D1EF346-10A7-B9BA-E281-E0BE0F7E0702}"/>
+                <a16:creationId xmlns:a16="http://schemas.microsoft.com/office/drawing/2014/main" xmlns="" id="{6D1EF346-10A7-B9BA-E281-E0BE0F7E0702}"/>
               </a:ext>
             </a:extLst>
           </p:cNvPr>
@@ -39493,7 +39523,7 @@
           <p:cNvPr id="11" name="CuadroTexto 10">
             <a:extLst>
               <a:ext uri="{FF2B5EF4-FFF2-40B4-BE49-F238E27FC236}">
-                <a16:creationId xmlns:a16="http://schemas.microsoft.com/office/drawing/2014/main" id="{300D47FF-0E73-F6FD-1E6D-F93C30936340}"/>
+                <a16:creationId xmlns:a16="http://schemas.microsoft.com/office/drawing/2014/main" xmlns="" id="{300D47FF-0E73-F6FD-1E6D-F93C30936340}"/>
               </a:ext>
             </a:extLst>
           </p:cNvPr>
@@ -39528,7 +39558,7 @@
           <p:cNvPr id="14" name="CuadroTexto 13">
             <a:extLst>
               <a:ext uri="{FF2B5EF4-FFF2-40B4-BE49-F238E27FC236}">
-                <a16:creationId xmlns:a16="http://schemas.microsoft.com/office/drawing/2014/main" id="{383A969F-4553-4EEA-7F8A-103791D6F8D7}"/>
+                <a16:creationId xmlns:a16="http://schemas.microsoft.com/office/drawing/2014/main" xmlns="" id="{383A969F-4553-4EEA-7F8A-103791D6F8D7}"/>
               </a:ext>
             </a:extLst>
           </p:cNvPr>
@@ -39563,7 +39593,7 @@
           <p:cNvPr id="16" name="Imagen 15">
             <a:extLst>
               <a:ext uri="{FF2B5EF4-FFF2-40B4-BE49-F238E27FC236}">
-                <a16:creationId xmlns:a16="http://schemas.microsoft.com/office/drawing/2014/main" id="{944F5E01-6509-6391-1291-62C2B4838CCD}"/>
+                <a16:creationId xmlns:a16="http://schemas.microsoft.com/office/drawing/2014/main" xmlns="" id="{944F5E01-6509-6391-1291-62C2B4838CCD}"/>
               </a:ext>
             </a:extLst>
           </p:cNvPr>
@@ -39609,7 +39639,7 @@
         <p:cNvPr id="1" name="">
           <a:extLst>
             <a:ext uri="{FF2B5EF4-FFF2-40B4-BE49-F238E27FC236}">
-              <a16:creationId xmlns:a16="http://schemas.microsoft.com/office/drawing/2014/main" id="{D8811552-CF54-B7B0-228A-FCC1759885BF}"/>
+              <a16:creationId xmlns:a16="http://schemas.microsoft.com/office/drawing/2014/main" xmlns="" id="{D8811552-CF54-B7B0-228A-FCC1759885BF}"/>
             </a:ext>
           </a:extLst>
         </p:cNvPr>
@@ -39629,7 +39659,7 @@
           <p:cNvPr id="2" name="Título 1">
             <a:extLst>
               <a:ext uri="{FF2B5EF4-FFF2-40B4-BE49-F238E27FC236}">
-                <a16:creationId xmlns:a16="http://schemas.microsoft.com/office/drawing/2014/main" id="{C6DE340F-FCED-4F7D-FE84-7B279ABAD467}"/>
+                <a16:creationId xmlns:a16="http://schemas.microsoft.com/office/drawing/2014/main" xmlns="" id="{C6DE340F-FCED-4F7D-FE84-7B279ABAD467}"/>
               </a:ext>
             </a:extLst>
           </p:cNvPr>
@@ -39662,7 +39692,7 @@
           <p:cNvPr id="16" name="Imagen 15">
             <a:extLst>
               <a:ext uri="{FF2B5EF4-FFF2-40B4-BE49-F238E27FC236}">
-                <a16:creationId xmlns:a16="http://schemas.microsoft.com/office/drawing/2014/main" id="{D673634D-3F76-0399-4602-730EAA99ABBB}"/>
+                <a16:creationId xmlns:a16="http://schemas.microsoft.com/office/drawing/2014/main" xmlns="" id="{D673634D-3F76-0399-4602-730EAA99ABBB}"/>
               </a:ext>
             </a:extLst>
           </p:cNvPr>

</xml_diff>